<commit_message>
Replace EPQ report with full dissertation
</commit_message>
<xml_diff>
--- a/assets/documents/a-level-epq-presentation.pptx
+++ b/assets/documents/a-level-epq-presentation.pptx
@@ -2,26 +2,26 @@
 <file path=ppt/presentation.xml><?xml version="1.0" encoding="utf-8"?>
 <p:presentation xmlns:p="http://schemas.openxmlformats.org/presentationml/2006/main">
   <p:sldMasterIdLst>
-    <p:sldMasterId xmlns:r="http://schemas.openxmlformats.org/officeDocument/2006/relationships" id="2147483648" r:id="R62ef28e8def543e7"/>
+    <p:sldMasterId xmlns:r="http://schemas.openxmlformats.org/officeDocument/2006/relationships" id="2147483648" r:id="R9c5a7f6f7c024af0"/>
   </p:sldMasterIdLst>
   <p:notesMasterIdLst>
-    <p:notesMasterId xmlns:r="http://schemas.openxmlformats.org/officeDocument/2006/relationships" r:id="Rf4c201e9c81143fe"/>
+    <p:notesMasterId xmlns:r="http://schemas.openxmlformats.org/officeDocument/2006/relationships" r:id="R24b0ecdaa4804433"/>
   </p:notesMasterIdLst>
   <p:sldIdLst>
-    <p:sldId xmlns:r="http://schemas.openxmlformats.org/officeDocument/2006/relationships" id="256" r:id="Ra3db71a27a6d434d"/>
-    <p:sldId xmlns:r="http://schemas.openxmlformats.org/officeDocument/2006/relationships" id="257" r:id="Reccd75ece4724540"/>
-    <p:sldId xmlns:r="http://schemas.openxmlformats.org/officeDocument/2006/relationships" id="258" r:id="R98c8d073038b4733"/>
-    <p:sldId xmlns:r="http://schemas.openxmlformats.org/officeDocument/2006/relationships" id="259" r:id="R063dbe4f57ff45df"/>
-    <p:sldId xmlns:r="http://schemas.openxmlformats.org/officeDocument/2006/relationships" id="260" r:id="Rf6aa79b14a4e4d35"/>
-    <p:sldId xmlns:r="http://schemas.openxmlformats.org/officeDocument/2006/relationships" id="261" r:id="R1d510561d9524264"/>
-    <p:sldId xmlns:r="http://schemas.openxmlformats.org/officeDocument/2006/relationships" id="262" r:id="R058a1fa0ab664e95"/>
-    <p:sldId xmlns:r="http://schemas.openxmlformats.org/officeDocument/2006/relationships" id="263" r:id="Rbef37c032a35491f"/>
-    <p:sldId xmlns:r="http://schemas.openxmlformats.org/officeDocument/2006/relationships" id="264" r:id="R2c1f9df41a1a4038"/>
-    <p:sldId xmlns:r="http://schemas.openxmlformats.org/officeDocument/2006/relationships" id="265" r:id="Re53eebe4c80e48f6"/>
-    <p:sldId xmlns:r="http://schemas.openxmlformats.org/officeDocument/2006/relationships" id="266" r:id="R49664143a59345c6"/>
-    <p:sldId xmlns:r="http://schemas.openxmlformats.org/officeDocument/2006/relationships" id="267" r:id="R0455b9ecfb6e487b"/>
-    <p:sldId xmlns:r="http://schemas.openxmlformats.org/officeDocument/2006/relationships" id="268" r:id="Rf591b2c810cb47ed"/>
-    <p:sldId xmlns:r="http://schemas.openxmlformats.org/officeDocument/2006/relationships" id="269" r:id="R35b781733b834bdd"/>
+    <p:sldId xmlns:r="http://schemas.openxmlformats.org/officeDocument/2006/relationships" id="256" r:id="R4b4144aef8c34cdc"/>
+    <p:sldId xmlns:r="http://schemas.openxmlformats.org/officeDocument/2006/relationships" id="257" r:id="R05bb4e1fc9584c26"/>
+    <p:sldId xmlns:r="http://schemas.openxmlformats.org/officeDocument/2006/relationships" id="258" r:id="R1ad5893b2d9c4504"/>
+    <p:sldId xmlns:r="http://schemas.openxmlformats.org/officeDocument/2006/relationships" id="259" r:id="R8b9ec66d58324a65"/>
+    <p:sldId xmlns:r="http://schemas.openxmlformats.org/officeDocument/2006/relationships" id="260" r:id="R3427cc298c3342c3"/>
+    <p:sldId xmlns:r="http://schemas.openxmlformats.org/officeDocument/2006/relationships" id="261" r:id="R3794e988d7cf4704"/>
+    <p:sldId xmlns:r="http://schemas.openxmlformats.org/officeDocument/2006/relationships" id="262" r:id="Redb94554c6db4bdf"/>
+    <p:sldId xmlns:r="http://schemas.openxmlformats.org/officeDocument/2006/relationships" id="263" r:id="Rada69711e6c34993"/>
+    <p:sldId xmlns:r="http://schemas.openxmlformats.org/officeDocument/2006/relationships" id="264" r:id="Rf0d11ad996d14c7d"/>
+    <p:sldId xmlns:r="http://schemas.openxmlformats.org/officeDocument/2006/relationships" id="265" r:id="Rbacc522ba1f8498f"/>
+    <p:sldId xmlns:r="http://schemas.openxmlformats.org/officeDocument/2006/relationships" id="266" r:id="R4b18b27999d84c16"/>
+    <p:sldId xmlns:r="http://schemas.openxmlformats.org/officeDocument/2006/relationships" id="267" r:id="R7694c7a966294f60"/>
+    <p:sldId xmlns:r="http://schemas.openxmlformats.org/officeDocument/2006/relationships" id="268" r:id="Rcddb617d05a3421c"/>
+    <p:sldId xmlns:r="http://schemas.openxmlformats.org/officeDocument/2006/relationships" id="269" r:id="Re35e7f997ccc48f8"/>
   </p:sldIdLst>
   <p:sldSz cx="12192000" cy="6858000"/>
   <p:notesSz cx="6858000" cy="9144000"/>
@@ -550,7 +550,7 @@
           <a:lstStyle xmlns:a="http://schemas.openxmlformats.org/drawingml/2006/main"/>
           <a:p xmlns:a="http://schemas.openxmlformats.org/drawingml/2006/main">
             <a:r>
-              <a:t>Open with the original question and explain that this is a critical revision, not a replacement of the assessed submission.</a:t>
+              <a:t>Open with the original question and explain that this is a new standalone investigation; the assessed 2020 submission remains preserved as the historical record.</a:t>
             </a:r>
           </a:p>
           <a:p xmlns:a="http://schemas.openxmlformats.org/drawingml/2006/main">
@@ -1533,7 +1533,7 @@
   </p:cSld>
   <p:clrMap bg1="lt1" tx1="dk1" bg2="lt2" tx2="dk2" accent1="accent1" accent2="accent2" accent3="accent3" accent4="accent4" accent5="accent5" accent6="accent6" hlink="hlink" folHlink="folHlink"/>
   <p:sldLayoutIdLst>
-    <p:sldLayoutId xmlns:r="http://schemas.openxmlformats.org/officeDocument/2006/relationships" id="2147483649" r:id="R5fba90d948194632"/>
+    <p:sldLayoutId xmlns:r="http://schemas.openxmlformats.org/officeDocument/2006/relationships" id="2147483649" r:id="R6edecc5707b2481f"/>
   </p:sldLayoutIdLst>
   <p:txStyles>
     <p:titleStyle>
@@ -2264,7 +2264,7 @@
           <p:cNvPr id="9" name="">
             <a:extLst xmlns:a="http://schemas.openxmlformats.org/drawingml/2006/main">
               <a:ext uri="{FF2B5EF4-FFF2-40B4-BE49-F238E27FC236}">
-                <a16:creationId xmlns:a16="http://schemas.microsoft.com/office/drawing/2014/main" id="{48164E69-074D-4B51-9138-5EE4C2E01D9A}"/>
+                <a16:creationId xmlns:a16="http://schemas.microsoft.com/office/drawing/2014/main" id="{4FA0792A-D0E8-4A08-B36A-FE932695298C}"/>
               </a:ext>
             </a:extLst>
           </p:cNvPr>
@@ -2309,7 +2309,7 @@
           <p:cNvPr id="2" name="">
             <a:extLst xmlns:a="http://schemas.openxmlformats.org/drawingml/2006/main">
               <a:ext uri="{FF2B5EF4-FFF2-40B4-BE49-F238E27FC236}">
-                <a16:creationId xmlns:a16="http://schemas.microsoft.com/office/drawing/2014/main" id="{4F7F58D4-C334-4279-9BAF-408261899C22}"/>
+                <a16:creationId xmlns:a16="http://schemas.microsoft.com/office/drawing/2014/main" id="{872E7A39-AEB3-44C2-BD96-32E014B6B53F}"/>
               </a:ext>
             </a:extLst>
           </p:cNvPr>
@@ -2354,7 +2354,7 @@
           <p:cNvPr id="3" name="">
             <a:extLst xmlns:a="http://schemas.openxmlformats.org/drawingml/2006/main">
               <a:ext uri="{FF2B5EF4-FFF2-40B4-BE49-F238E27FC236}">
-                <a16:creationId xmlns:a16="http://schemas.microsoft.com/office/drawing/2014/main" id="{E9D80C2E-9B4A-4B8B-A80F-4891922990F3}"/>
+                <a16:creationId xmlns:a16="http://schemas.microsoft.com/office/drawing/2014/main" id="{7973FDDB-9666-4C39-8580-2BA6A1F17BD2}"/>
               </a:ext>
             </a:extLst>
           </p:cNvPr>
@@ -2389,7 +2389,7 @@
               </a:defRPr>
             </a:pPr>
             <a:r>
-              <a:t>A 2026 reappraisal of my first A-level dissertation—and the question that led towards safer product decisions.</a:t>
+              <a:t>A new 2026 investigation built from my first A-level dissertation—and the question that led towards safer product decisions.</a:t>
             </a:r>
           </a:p>
         </p:txBody>
@@ -2399,7 +2399,7 @@
           <p:cNvPr id="4" name="">
             <a:extLst xmlns:a="http://schemas.openxmlformats.org/drawingml/2006/main">
               <a:ext uri="{FF2B5EF4-FFF2-40B4-BE49-F238E27FC236}">
-                <a16:creationId xmlns:a16="http://schemas.microsoft.com/office/drawing/2014/main" id="{83FCBAEB-1CF5-45C4-A8C2-25B85CDEAB39}"/>
+                <a16:creationId xmlns:a16="http://schemas.microsoft.com/office/drawing/2014/main" id="{B64B39FC-9D71-4630-A247-A794FC605B0E}"/>
               </a:ext>
             </a:extLst>
           </p:cNvPr>
@@ -2444,7 +2444,7 @@
           <p:cNvPr id="5" name="cover-image-backing">
             <a:extLst xmlns:a="http://schemas.openxmlformats.org/drawingml/2006/main">
               <a:ext uri="{FF2B5EF4-FFF2-40B4-BE49-F238E27FC236}">
-                <a16:creationId xmlns:a16="http://schemas.microsoft.com/office/drawing/2014/main" id="{9E54BAD5-3EFE-45C8-B59F-58E663A859BF}"/>
+                <a16:creationId xmlns:a16="http://schemas.microsoft.com/office/drawing/2014/main" id="{80E1563D-19A2-4066-BB4D-B6017E7408FF}"/>
               </a:ext>
             </a:extLst>
           </p:cNvPr>
@@ -2479,7 +2479,7 @@
           <p:cNvPr id="6" name="source-1">
             <a:extLst xmlns:a="http://schemas.openxmlformats.org/drawingml/2006/main">
               <a:ext uri="{FF2B5EF4-FFF2-40B4-BE49-F238E27FC236}">
-                <a16:creationId xmlns:a16="http://schemas.microsoft.com/office/drawing/2014/main" id="{183EB84A-3571-42FB-BC22-19F1E6E4CC04}"/>
+                <a16:creationId xmlns:a16="http://schemas.microsoft.com/office/drawing/2014/main" id="{3E478A0F-76A9-476F-8164-167C6259CE04}"/>
               </a:ext>
             </a:extLst>
           </p:cNvPr>
@@ -2524,7 +2524,7 @@
           <p:cNvPr id="7" name="page-1">
             <a:extLst xmlns:a="http://schemas.openxmlformats.org/drawingml/2006/main">
               <a:ext uri="{FF2B5EF4-FFF2-40B4-BE49-F238E27FC236}">
-                <a16:creationId xmlns:a16="http://schemas.microsoft.com/office/drawing/2014/main" id="{BB454D1B-966A-4191-AB1B-7A955E9005BA}"/>
+                <a16:creationId xmlns:a16="http://schemas.microsoft.com/office/drawing/2014/main" id="{0EF814F0-C2E1-40AF-BE79-B62A3E68A080}"/>
               </a:ext>
             </a:extLst>
           </p:cNvPr>
@@ -2573,7 +2573,7 @@
           <p:nvPr/>
         </p:nvPicPr>
         <p:blipFill>
-          <a:blip xmlns:r="http://schemas.openxmlformats.org/officeDocument/2006/relationships" xmlns:a="http://schemas.openxmlformats.org/drawingml/2006/main" r:embed="Rbaa0f97faffc4468"/>
+          <a:blip xmlns:r="http://schemas.openxmlformats.org/officeDocument/2006/relationships" xmlns:a="http://schemas.openxmlformats.org/drawingml/2006/main" r:embed="R2ad579f3837c407e"/>
           <a:stretch xmlns:a="http://schemas.openxmlformats.org/drawingml/2006/main"/>
         </p:blipFill>
         <p:spPr>
@@ -2589,7 +2589,7 @@
     </p:spTree>
     <p:extLst>
       <p:ext uri="{BB962C8B-B14F-4D97-AF65-F5344CB8AC3E}">
-        <p14:creationId xmlns:p14="http://schemas.microsoft.com/office/powerpoint/2010/main" val="1011605470"/>
+        <p14:creationId xmlns:p14="http://schemas.microsoft.com/office/powerpoint/2010/main" val="1744085433"/>
       </p:ext>
     </p:extLst>
   </p:cSld>
@@ -2620,7 +2620,7 @@
           <p:cNvPr id="15" name="title-10">
             <a:extLst xmlns:a="http://schemas.openxmlformats.org/drawingml/2006/main">
               <a:ext uri="{FF2B5EF4-FFF2-40B4-BE49-F238E27FC236}">
-                <a16:creationId xmlns:a16="http://schemas.microsoft.com/office/drawing/2014/main" id="{01470746-AEC4-48DB-8E45-892EBD4F46FE}"/>
+                <a16:creationId xmlns:a16="http://schemas.microsoft.com/office/drawing/2014/main" id="{8351C8BC-E894-46D9-89F4-0BE6191835C1}"/>
               </a:ext>
             </a:extLst>
           </p:cNvPr>
@@ -2665,7 +2665,7 @@
           <p:cNvPr id="2" name="source-10">
             <a:extLst xmlns:a="http://schemas.openxmlformats.org/drawingml/2006/main">
               <a:ext uri="{FF2B5EF4-FFF2-40B4-BE49-F238E27FC236}">
-                <a16:creationId xmlns:a16="http://schemas.microsoft.com/office/drawing/2014/main" id="{C9DFA85F-DF98-4E5A-9E9B-74E00EA0444F}"/>
+                <a16:creationId xmlns:a16="http://schemas.microsoft.com/office/drawing/2014/main" id="{0645BF36-9457-4EF0-B8D4-42F8ED247281}"/>
               </a:ext>
             </a:extLst>
           </p:cNvPr>
@@ -2710,7 +2710,7 @@
           <p:cNvPr id="3" name="page-10">
             <a:extLst xmlns:a="http://schemas.openxmlformats.org/drawingml/2006/main">
               <a:ext uri="{FF2B5EF4-FFF2-40B4-BE49-F238E27FC236}">
-                <a16:creationId xmlns:a16="http://schemas.microsoft.com/office/drawing/2014/main" id="{C502CFD6-BC47-46A2-8AA2-C1082FF52B96}"/>
+                <a16:creationId xmlns:a16="http://schemas.microsoft.com/office/drawing/2014/main" id="{D94F9F58-8E24-45AA-9577-5FAC3390F5D4}"/>
               </a:ext>
             </a:extLst>
           </p:cNvPr>
@@ -2755,7 +2755,7 @@
           <p:cNvPr id="4" name="">
             <a:extLst xmlns:a="http://schemas.openxmlformats.org/drawingml/2006/main">
               <a:ext uri="{FF2B5EF4-FFF2-40B4-BE49-F238E27FC236}">
-                <a16:creationId xmlns:a16="http://schemas.microsoft.com/office/drawing/2014/main" id="{E5E994BE-AECF-4351-ACDC-019629090C85}"/>
+                <a16:creationId xmlns:a16="http://schemas.microsoft.com/office/drawing/2014/main" id="{8F0ABFB8-D7AB-4E7A-8CF9-847DE312EF51}"/>
               </a:ext>
             </a:extLst>
           </p:cNvPr>
@@ -2800,7 +2800,7 @@
           <p:cNvPr id="5" name="">
             <a:extLst xmlns:a="http://schemas.openxmlformats.org/drawingml/2006/main">
               <a:ext uri="{FF2B5EF4-FFF2-40B4-BE49-F238E27FC236}">
-                <a16:creationId xmlns:a16="http://schemas.microsoft.com/office/drawing/2014/main" id="{9ED2102A-D5BF-47F5-930E-D9677CD872FE}"/>
+                <a16:creationId xmlns:a16="http://schemas.microsoft.com/office/drawing/2014/main" id="{A6694FC0-B073-4A2B-9825-D3B82D005C25}"/>
               </a:ext>
             </a:extLst>
           </p:cNvPr>
@@ -2833,7 +2833,7 @@
           <p:cNvPr id="6" name="">
             <a:extLst xmlns:a="http://schemas.openxmlformats.org/drawingml/2006/main">
               <a:ext uri="{FF2B5EF4-FFF2-40B4-BE49-F238E27FC236}">
-                <a16:creationId xmlns:a16="http://schemas.microsoft.com/office/drawing/2014/main" id="{AED008D5-C217-4E6C-96AE-1484D3982433}"/>
+                <a16:creationId xmlns:a16="http://schemas.microsoft.com/office/drawing/2014/main" id="{6BB90A3E-C54C-492E-9FA1-234DB9B2C23D}"/>
               </a:ext>
             </a:extLst>
           </p:cNvPr>
@@ -2878,7 +2878,7 @@
           <p:cNvPr id="7" name="">
             <a:extLst xmlns:a="http://schemas.openxmlformats.org/drawingml/2006/main">
               <a:ext uri="{FF2B5EF4-FFF2-40B4-BE49-F238E27FC236}">
-                <a16:creationId xmlns:a16="http://schemas.microsoft.com/office/drawing/2014/main" id="{A11F851B-6C30-46BD-9EF7-948CB6CC0BFA}"/>
+                <a16:creationId xmlns:a16="http://schemas.microsoft.com/office/drawing/2014/main" id="{0B61A283-2316-4BFB-A0E0-EA288585CC8B}"/>
               </a:ext>
             </a:extLst>
           </p:cNvPr>
@@ -2923,7 +2923,7 @@
           <p:cNvPr id="8" name="">
             <a:extLst xmlns:a="http://schemas.openxmlformats.org/drawingml/2006/main">
               <a:ext uri="{FF2B5EF4-FFF2-40B4-BE49-F238E27FC236}">
-                <a16:creationId xmlns:a16="http://schemas.microsoft.com/office/drawing/2014/main" id="{992ACD24-856A-46EB-AAAD-6089CE588E2B}"/>
+                <a16:creationId xmlns:a16="http://schemas.microsoft.com/office/drawing/2014/main" id="{B02F5E5C-CF69-48C1-B394-AA557FCF1B27}"/>
               </a:ext>
             </a:extLst>
           </p:cNvPr>
@@ -2968,7 +2968,7 @@
           <p:cNvPr id="9" name="">
             <a:extLst xmlns:a="http://schemas.openxmlformats.org/drawingml/2006/main">
               <a:ext uri="{FF2B5EF4-FFF2-40B4-BE49-F238E27FC236}">
-                <a16:creationId xmlns:a16="http://schemas.microsoft.com/office/drawing/2014/main" id="{206939B3-B5D2-46F2-98C0-05122B48D8FA}"/>
+                <a16:creationId xmlns:a16="http://schemas.microsoft.com/office/drawing/2014/main" id="{7C8C6AB8-2CA3-4F04-90FF-DF524BBB3EFB}"/>
               </a:ext>
             </a:extLst>
           </p:cNvPr>
@@ -3013,7 +3013,7 @@
           <p:cNvPr id="10" name="">
             <a:extLst xmlns:a="http://schemas.openxmlformats.org/drawingml/2006/main">
               <a:ext uri="{FF2B5EF4-FFF2-40B4-BE49-F238E27FC236}">
-                <a16:creationId xmlns:a16="http://schemas.microsoft.com/office/drawing/2014/main" id="{028BE292-12B9-4644-A9B1-329CE75492FC}"/>
+                <a16:creationId xmlns:a16="http://schemas.microsoft.com/office/drawing/2014/main" id="{097500F5-DE44-47F1-9018-7F3ACA0A932F}"/>
               </a:ext>
             </a:extLst>
           </p:cNvPr>
@@ -3058,7 +3058,7 @@
           <p:cNvPr id="11" name="">
             <a:extLst xmlns:a="http://schemas.openxmlformats.org/drawingml/2006/main">
               <a:ext uri="{FF2B5EF4-FFF2-40B4-BE49-F238E27FC236}">
-                <a16:creationId xmlns:a16="http://schemas.microsoft.com/office/drawing/2014/main" id="{5B128D3E-9F91-43C6-8CD2-FD47C96F7553}"/>
+                <a16:creationId xmlns:a16="http://schemas.microsoft.com/office/drawing/2014/main" id="{394646BC-38C3-4EF8-83E4-02CA43AD2937}"/>
               </a:ext>
             </a:extLst>
           </p:cNvPr>
@@ -3103,7 +3103,7 @@
           <p:cNvPr id="12" name="">
             <a:extLst xmlns:a="http://schemas.openxmlformats.org/drawingml/2006/main">
               <a:ext uri="{FF2B5EF4-FFF2-40B4-BE49-F238E27FC236}">
-                <a16:creationId xmlns:a16="http://schemas.microsoft.com/office/drawing/2014/main" id="{8F75DD3F-BA7E-4F15-B46E-866CECDB6133}"/>
+                <a16:creationId xmlns:a16="http://schemas.microsoft.com/office/drawing/2014/main" id="{732C9175-1DC7-452C-9A53-CFB98158449E}"/>
               </a:ext>
             </a:extLst>
           </p:cNvPr>
@@ -3148,7 +3148,7 @@
           <p:cNvPr id="13" name="">
             <a:extLst xmlns:a="http://schemas.openxmlformats.org/drawingml/2006/main">
               <a:ext uri="{FF2B5EF4-FFF2-40B4-BE49-F238E27FC236}">
-                <a16:creationId xmlns:a16="http://schemas.microsoft.com/office/drawing/2014/main" id="{945A3012-CC92-4852-ACA8-4EFB6E5BA4AB}"/>
+                <a16:creationId xmlns:a16="http://schemas.microsoft.com/office/drawing/2014/main" id="{1F714200-1F49-4C4E-9F31-50A4F7BEDAE8}"/>
               </a:ext>
             </a:extLst>
           </p:cNvPr>
@@ -3193,7 +3193,7 @@
           <p:cNvPr id="14" name="">
             <a:extLst xmlns:a="http://schemas.openxmlformats.org/drawingml/2006/main">
               <a:ext uri="{FF2B5EF4-FFF2-40B4-BE49-F238E27FC236}">
-                <a16:creationId xmlns:a16="http://schemas.microsoft.com/office/drawing/2014/main" id="{CBD3BB86-5ABE-4C90-B8B0-CA413A7FD357}"/>
+                <a16:creationId xmlns:a16="http://schemas.microsoft.com/office/drawing/2014/main" id="{457AEED5-9CFC-4FE6-8588-A6B3922AF9C1}"/>
               </a:ext>
             </a:extLst>
           </p:cNvPr>
@@ -3236,7 +3236,7 @@
     </p:spTree>
     <p:extLst>
       <p:ext uri="{BB962C8B-B14F-4D97-AF65-F5344CB8AC3E}">
-        <p14:creationId xmlns:p14="http://schemas.microsoft.com/office/powerpoint/2010/main" val="297287567"/>
+        <p14:creationId xmlns:p14="http://schemas.microsoft.com/office/powerpoint/2010/main" val="1602927068"/>
       </p:ext>
     </p:extLst>
   </p:cSld>
@@ -3267,7 +3267,7 @@
           <p:cNvPr id="12" name="title-11">
             <a:extLst xmlns:a="http://schemas.openxmlformats.org/drawingml/2006/main">
               <a:ext uri="{FF2B5EF4-FFF2-40B4-BE49-F238E27FC236}">
-                <a16:creationId xmlns:a16="http://schemas.microsoft.com/office/drawing/2014/main" id="{8694E8F4-2453-4041-A069-A8F3BB3EAF33}"/>
+                <a16:creationId xmlns:a16="http://schemas.microsoft.com/office/drawing/2014/main" id="{4585CFD0-C98F-4129-B209-ECBC19871DCD}"/>
               </a:ext>
             </a:extLst>
           </p:cNvPr>
@@ -3312,7 +3312,7 @@
           <p:cNvPr id="2" name="source-11">
             <a:extLst xmlns:a="http://schemas.openxmlformats.org/drawingml/2006/main">
               <a:ext uri="{FF2B5EF4-FFF2-40B4-BE49-F238E27FC236}">
-                <a16:creationId xmlns:a16="http://schemas.microsoft.com/office/drawing/2014/main" id="{AB15A32C-5D93-42FC-9EF9-C79F79229F8F}"/>
+                <a16:creationId xmlns:a16="http://schemas.microsoft.com/office/drawing/2014/main" id="{EA1C27EA-9FAF-4D9B-A958-45D76143ACD0}"/>
               </a:ext>
             </a:extLst>
           </p:cNvPr>
@@ -3357,7 +3357,7 @@
           <p:cNvPr id="3" name="page-11">
             <a:extLst xmlns:a="http://schemas.openxmlformats.org/drawingml/2006/main">
               <a:ext uri="{FF2B5EF4-FFF2-40B4-BE49-F238E27FC236}">
-                <a16:creationId xmlns:a16="http://schemas.microsoft.com/office/drawing/2014/main" id="{93A68C67-F084-47F5-B69D-D0B86F6B3C7C}"/>
+                <a16:creationId xmlns:a16="http://schemas.microsoft.com/office/drawing/2014/main" id="{EF4D0D10-1F06-4A04-9FF7-10B209999F97}"/>
               </a:ext>
             </a:extLst>
           </p:cNvPr>
@@ -3402,7 +3402,7 @@
           <p:cNvPr id="4" name="">
             <a:extLst xmlns:a="http://schemas.openxmlformats.org/drawingml/2006/main">
               <a:ext uri="{FF2B5EF4-FFF2-40B4-BE49-F238E27FC236}">
-                <a16:creationId xmlns:a16="http://schemas.microsoft.com/office/drawing/2014/main" id="{D6D6E8A3-D552-4D96-AAF0-D3DA02D0E672}"/>
+                <a16:creationId xmlns:a16="http://schemas.microsoft.com/office/drawing/2014/main" id="{E5D5E9E1-7860-429D-8CA3-187A162C5C3A}"/>
               </a:ext>
             </a:extLst>
           </p:cNvPr>
@@ -3447,7 +3447,7 @@
           <p:cNvPr id="5" name="">
             <a:extLst xmlns:a="http://schemas.openxmlformats.org/drawingml/2006/main">
               <a:ext uri="{FF2B5EF4-FFF2-40B4-BE49-F238E27FC236}">
-                <a16:creationId xmlns:a16="http://schemas.microsoft.com/office/drawing/2014/main" id="{6E51C316-CF8E-478A-BD23-83A2FFEA0DC2}"/>
+                <a16:creationId xmlns:a16="http://schemas.microsoft.com/office/drawing/2014/main" id="{AB216255-FBA2-4A8C-BE20-6345FA5D35D0}"/>
               </a:ext>
             </a:extLst>
           </p:cNvPr>
@@ -3495,7 +3495,7 @@
           <p:cNvPr id="6" name="">
             <a:extLst xmlns:a="http://schemas.openxmlformats.org/drawingml/2006/main">
               <a:ext uri="{FF2B5EF4-FFF2-40B4-BE49-F238E27FC236}">
-                <a16:creationId xmlns:a16="http://schemas.microsoft.com/office/drawing/2014/main" id="{99EDA548-AF25-4EB3-871A-B27AA37E3C5C}"/>
+                <a16:creationId xmlns:a16="http://schemas.microsoft.com/office/drawing/2014/main" id="{4887EB6C-5527-4921-8266-E131B563D6A8}"/>
               </a:ext>
             </a:extLst>
           </p:cNvPr>
@@ -3540,7 +3540,7 @@
           <p:cNvPr id="7" name="">
             <a:extLst xmlns:a="http://schemas.openxmlformats.org/drawingml/2006/main">
               <a:ext uri="{FF2B5EF4-FFF2-40B4-BE49-F238E27FC236}">
-                <a16:creationId xmlns:a16="http://schemas.microsoft.com/office/drawing/2014/main" id="{2F033278-39D5-47CA-A128-EC6C2BB56F94}"/>
+                <a16:creationId xmlns:a16="http://schemas.microsoft.com/office/drawing/2014/main" id="{F5DFC85B-483B-4E66-9721-731D0FCA5097}"/>
               </a:ext>
             </a:extLst>
           </p:cNvPr>
@@ -3588,7 +3588,7 @@
           <p:cNvPr id="8" name="">
             <a:extLst xmlns:a="http://schemas.openxmlformats.org/drawingml/2006/main">
               <a:ext uri="{FF2B5EF4-FFF2-40B4-BE49-F238E27FC236}">
-                <a16:creationId xmlns:a16="http://schemas.microsoft.com/office/drawing/2014/main" id="{18522B44-9F58-4B44-9595-116AA9E93C36}"/>
+                <a16:creationId xmlns:a16="http://schemas.microsoft.com/office/drawing/2014/main" id="{A7D2FB54-993F-4F01-AA53-902239004EFE}"/>
               </a:ext>
             </a:extLst>
           </p:cNvPr>
@@ -3633,7 +3633,7 @@
           <p:cNvPr id="9" name="">
             <a:extLst xmlns:a="http://schemas.openxmlformats.org/drawingml/2006/main">
               <a:ext uri="{FF2B5EF4-FFF2-40B4-BE49-F238E27FC236}">
-                <a16:creationId xmlns:a16="http://schemas.microsoft.com/office/drawing/2014/main" id="{FD92074C-12FD-4063-9690-36D69212D1E1}"/>
+                <a16:creationId xmlns:a16="http://schemas.microsoft.com/office/drawing/2014/main" id="{768DDED6-B078-4BFC-ABBD-1D76F993CBA8}"/>
               </a:ext>
             </a:extLst>
           </p:cNvPr>
@@ -3681,7 +3681,7 @@
           <p:cNvPr id="10" name="">
             <a:extLst xmlns:a="http://schemas.openxmlformats.org/drawingml/2006/main">
               <a:ext uri="{FF2B5EF4-FFF2-40B4-BE49-F238E27FC236}">
-                <a16:creationId xmlns:a16="http://schemas.microsoft.com/office/drawing/2014/main" id="{F0F955CE-EBB2-42CA-A71A-677E26112555}"/>
+                <a16:creationId xmlns:a16="http://schemas.microsoft.com/office/drawing/2014/main" id="{E9E27F6D-F8B0-4281-A4FB-6A964027A73C}"/>
               </a:ext>
             </a:extLst>
           </p:cNvPr>
@@ -3714,7 +3714,7 @@
           <p:cNvPr id="11" name="">
             <a:extLst xmlns:a="http://schemas.openxmlformats.org/drawingml/2006/main">
               <a:ext uri="{FF2B5EF4-FFF2-40B4-BE49-F238E27FC236}">
-                <a16:creationId xmlns:a16="http://schemas.microsoft.com/office/drawing/2014/main" id="{187BED0A-5400-40B0-8E0D-C7158FDD89B9}"/>
+                <a16:creationId xmlns:a16="http://schemas.microsoft.com/office/drawing/2014/main" id="{41CC4F9F-1919-429E-B1FD-CE8EBEC143D3}"/>
               </a:ext>
             </a:extLst>
           </p:cNvPr>
@@ -3757,7 +3757,7 @@
     </p:spTree>
     <p:extLst>
       <p:ext uri="{BB962C8B-B14F-4D97-AF65-F5344CB8AC3E}">
-        <p14:creationId xmlns:p14="http://schemas.microsoft.com/office/powerpoint/2010/main" val="2013672487"/>
+        <p14:creationId xmlns:p14="http://schemas.microsoft.com/office/powerpoint/2010/main" val="775397249"/>
       </p:ext>
     </p:extLst>
   </p:cSld>
@@ -3788,7 +3788,7 @@
           <p:cNvPr id="23" name="title-12">
             <a:extLst xmlns:a="http://schemas.openxmlformats.org/drawingml/2006/main">
               <a:ext uri="{FF2B5EF4-FFF2-40B4-BE49-F238E27FC236}">
-                <a16:creationId xmlns:a16="http://schemas.microsoft.com/office/drawing/2014/main" id="{77126688-9CFE-44C5-85AA-E62009B46A73}"/>
+                <a16:creationId xmlns:a16="http://schemas.microsoft.com/office/drawing/2014/main" id="{F621531A-F453-4C07-830B-F7104709D2E2}"/>
               </a:ext>
             </a:extLst>
           </p:cNvPr>
@@ -3833,7 +3833,7 @@
           <p:cNvPr id="2" name="source-12">
             <a:extLst xmlns:a="http://schemas.openxmlformats.org/drawingml/2006/main">
               <a:ext uri="{FF2B5EF4-FFF2-40B4-BE49-F238E27FC236}">
-                <a16:creationId xmlns:a16="http://schemas.microsoft.com/office/drawing/2014/main" id="{A21D3007-C16A-4963-B1D0-271CA44C7606}"/>
+                <a16:creationId xmlns:a16="http://schemas.microsoft.com/office/drawing/2014/main" id="{461C76EA-FA42-49EB-84AE-E138A8F7C2CD}"/>
               </a:ext>
             </a:extLst>
           </p:cNvPr>
@@ -3878,7 +3878,7 @@
           <p:cNvPr id="3" name="page-12">
             <a:extLst xmlns:a="http://schemas.openxmlformats.org/drawingml/2006/main">
               <a:ext uri="{FF2B5EF4-FFF2-40B4-BE49-F238E27FC236}">
-                <a16:creationId xmlns:a16="http://schemas.microsoft.com/office/drawing/2014/main" id="{DB9C0B82-E5B2-412D-B29B-5706F66D939A}"/>
+                <a16:creationId xmlns:a16="http://schemas.microsoft.com/office/drawing/2014/main" id="{80E9F1FD-8F6D-439B-8182-B496E6DC937F}"/>
               </a:ext>
             </a:extLst>
           </p:cNvPr>
@@ -3923,7 +3923,7 @@
           <p:cNvPr id="4" name="">
             <a:extLst xmlns:a="http://schemas.openxmlformats.org/drawingml/2006/main">
               <a:ext uri="{FF2B5EF4-FFF2-40B4-BE49-F238E27FC236}">
-                <a16:creationId xmlns:a16="http://schemas.microsoft.com/office/drawing/2014/main" id="{C8E7012D-217F-4454-BC48-090F9B183ABA}"/>
+                <a16:creationId xmlns:a16="http://schemas.microsoft.com/office/drawing/2014/main" id="{52726B63-6246-41D6-82AC-FA0356160D22}"/>
               </a:ext>
             </a:extLst>
           </p:cNvPr>
@@ -3956,7 +3956,7 @@
           <p:cNvPr id="5" name="function-label-0">
             <a:extLst xmlns:a="http://schemas.openxmlformats.org/drawingml/2006/main">
               <a:ext uri="{FF2B5EF4-FFF2-40B4-BE49-F238E27FC236}">
-                <a16:creationId xmlns:a16="http://schemas.microsoft.com/office/drawing/2014/main" id="{EEC23E61-CD5C-4BA6-BCAD-2815CA5A8A79}"/>
+                <a16:creationId xmlns:a16="http://schemas.microsoft.com/office/drawing/2014/main" id="{1A46DE28-F096-467B-9D0C-7E616C5BBDCF}"/>
               </a:ext>
             </a:extLst>
           </p:cNvPr>
@@ -4001,7 +4001,7 @@
           <p:cNvPr id="6" name="function-body-0">
             <a:extLst xmlns:a="http://schemas.openxmlformats.org/drawingml/2006/main">
               <a:ext uri="{FF2B5EF4-FFF2-40B4-BE49-F238E27FC236}">
-                <a16:creationId xmlns:a16="http://schemas.microsoft.com/office/drawing/2014/main" id="{00436939-4959-4F0B-A10B-17403965D8E0}"/>
+                <a16:creationId xmlns:a16="http://schemas.microsoft.com/office/drawing/2014/main" id="{4446A1EE-0FD0-433A-A80B-3B159050E503}"/>
               </a:ext>
             </a:extLst>
           </p:cNvPr>
@@ -4046,7 +4046,7 @@
           <p:cNvPr id="7" name="">
             <a:extLst xmlns:a="http://schemas.openxmlformats.org/drawingml/2006/main">
               <a:ext uri="{FF2B5EF4-FFF2-40B4-BE49-F238E27FC236}">
-                <a16:creationId xmlns:a16="http://schemas.microsoft.com/office/drawing/2014/main" id="{641DDBFB-AFA8-42B4-8397-315136FF490A}"/>
+                <a16:creationId xmlns:a16="http://schemas.microsoft.com/office/drawing/2014/main" id="{ACF058D2-EEBF-40D6-BE54-DBF5B675BCF9}"/>
               </a:ext>
             </a:extLst>
           </p:cNvPr>
@@ -4079,7 +4079,7 @@
           <p:cNvPr id="8" name="function-label-1">
             <a:extLst xmlns:a="http://schemas.openxmlformats.org/drawingml/2006/main">
               <a:ext uri="{FF2B5EF4-FFF2-40B4-BE49-F238E27FC236}">
-                <a16:creationId xmlns:a16="http://schemas.microsoft.com/office/drawing/2014/main" id="{6BC20FAD-8DF2-4C9F-8DFA-3A62FB3C5D4F}"/>
+                <a16:creationId xmlns:a16="http://schemas.microsoft.com/office/drawing/2014/main" id="{2561D8DE-B7D9-4D36-81F3-A60578AC3A04}"/>
               </a:ext>
             </a:extLst>
           </p:cNvPr>
@@ -4124,7 +4124,7 @@
           <p:cNvPr id="9" name="function-body-1">
             <a:extLst xmlns:a="http://schemas.openxmlformats.org/drawingml/2006/main">
               <a:ext uri="{FF2B5EF4-FFF2-40B4-BE49-F238E27FC236}">
-                <a16:creationId xmlns:a16="http://schemas.microsoft.com/office/drawing/2014/main" id="{E185801B-2C48-4363-BDFD-3EB15D27472C}"/>
+                <a16:creationId xmlns:a16="http://schemas.microsoft.com/office/drawing/2014/main" id="{10EE3215-98E3-4894-B9A3-4870E6A2290A}"/>
               </a:ext>
             </a:extLst>
           </p:cNvPr>
@@ -4169,7 +4169,7 @@
           <p:cNvPr id="10" name="">
             <a:extLst xmlns:a="http://schemas.openxmlformats.org/drawingml/2006/main">
               <a:ext uri="{FF2B5EF4-FFF2-40B4-BE49-F238E27FC236}">
-                <a16:creationId xmlns:a16="http://schemas.microsoft.com/office/drawing/2014/main" id="{D9A50EFA-E3DE-41DB-8204-024E2FD760FC}"/>
+                <a16:creationId xmlns:a16="http://schemas.microsoft.com/office/drawing/2014/main" id="{2C936E1C-E94A-41E3-A454-0666B5372315}"/>
               </a:ext>
             </a:extLst>
           </p:cNvPr>
@@ -4202,7 +4202,7 @@
           <p:cNvPr id="11" name="function-label-2">
             <a:extLst xmlns:a="http://schemas.openxmlformats.org/drawingml/2006/main">
               <a:ext uri="{FF2B5EF4-FFF2-40B4-BE49-F238E27FC236}">
-                <a16:creationId xmlns:a16="http://schemas.microsoft.com/office/drawing/2014/main" id="{D046C0DB-C76B-42F2-BDC8-6F1DCB7346EA}"/>
+                <a16:creationId xmlns:a16="http://schemas.microsoft.com/office/drawing/2014/main" id="{EB5D3A86-B7F9-4DD5-A6E1-FAB2DEF3D1A2}"/>
               </a:ext>
             </a:extLst>
           </p:cNvPr>
@@ -4247,7 +4247,7 @@
           <p:cNvPr id="12" name="function-body-2">
             <a:extLst xmlns:a="http://schemas.openxmlformats.org/drawingml/2006/main">
               <a:ext uri="{FF2B5EF4-FFF2-40B4-BE49-F238E27FC236}">
-                <a16:creationId xmlns:a16="http://schemas.microsoft.com/office/drawing/2014/main" id="{86F7EF1D-1B91-41CC-BC68-83CA0A0756EB}"/>
+                <a16:creationId xmlns:a16="http://schemas.microsoft.com/office/drawing/2014/main" id="{B967194C-2A00-4823-B82B-50DF15A3DE60}"/>
               </a:ext>
             </a:extLst>
           </p:cNvPr>
@@ -4292,7 +4292,7 @@
           <p:cNvPr id="13" name="">
             <a:extLst xmlns:a="http://schemas.openxmlformats.org/drawingml/2006/main">
               <a:ext uri="{FF2B5EF4-FFF2-40B4-BE49-F238E27FC236}">
-                <a16:creationId xmlns:a16="http://schemas.microsoft.com/office/drawing/2014/main" id="{0C9DE110-44AC-4593-9009-1E04E541E16B}"/>
+                <a16:creationId xmlns:a16="http://schemas.microsoft.com/office/drawing/2014/main" id="{5703534B-A2DF-413E-A8C1-5B6D70677E34}"/>
               </a:ext>
             </a:extLst>
           </p:cNvPr>
@@ -4325,7 +4325,7 @@
           <p:cNvPr id="14" name="function-label-3">
             <a:extLst xmlns:a="http://schemas.openxmlformats.org/drawingml/2006/main">
               <a:ext uri="{FF2B5EF4-FFF2-40B4-BE49-F238E27FC236}">
-                <a16:creationId xmlns:a16="http://schemas.microsoft.com/office/drawing/2014/main" id="{E94211C0-852E-49F0-BFC3-1D8AF5AB08E6}"/>
+                <a16:creationId xmlns:a16="http://schemas.microsoft.com/office/drawing/2014/main" id="{F1BED849-D36E-4592-A190-FA1B3DC02FFB}"/>
               </a:ext>
             </a:extLst>
           </p:cNvPr>
@@ -4370,7 +4370,7 @@
           <p:cNvPr id="15" name="function-body-3">
             <a:extLst xmlns:a="http://schemas.openxmlformats.org/drawingml/2006/main">
               <a:ext uri="{FF2B5EF4-FFF2-40B4-BE49-F238E27FC236}">
-                <a16:creationId xmlns:a16="http://schemas.microsoft.com/office/drawing/2014/main" id="{F3BA82E6-DD98-43C2-8160-70D8CEA5D856}"/>
+                <a16:creationId xmlns:a16="http://schemas.microsoft.com/office/drawing/2014/main" id="{1417146D-3D7F-48E3-905B-A2D2297BC463}"/>
               </a:ext>
             </a:extLst>
           </p:cNvPr>
@@ -4415,7 +4415,7 @@
           <p:cNvPr id="16" name="">
             <a:extLst xmlns:a="http://schemas.openxmlformats.org/drawingml/2006/main">
               <a:ext uri="{FF2B5EF4-FFF2-40B4-BE49-F238E27FC236}">
-                <a16:creationId xmlns:a16="http://schemas.microsoft.com/office/drawing/2014/main" id="{34FBFDEF-99AE-430E-A921-42253D451734}"/>
+                <a16:creationId xmlns:a16="http://schemas.microsoft.com/office/drawing/2014/main" id="{83A015CE-D5FD-497B-97AD-DAEC114556E4}"/>
               </a:ext>
             </a:extLst>
           </p:cNvPr>
@@ -4448,7 +4448,7 @@
           <p:cNvPr id="17" name="function-label-4">
             <a:extLst xmlns:a="http://schemas.openxmlformats.org/drawingml/2006/main">
               <a:ext uri="{FF2B5EF4-FFF2-40B4-BE49-F238E27FC236}">
-                <a16:creationId xmlns:a16="http://schemas.microsoft.com/office/drawing/2014/main" id="{F6E23BD3-B2F0-4D13-97FE-7F15F863B828}"/>
+                <a16:creationId xmlns:a16="http://schemas.microsoft.com/office/drawing/2014/main" id="{8CD12405-0B55-43C8-80C7-0B3191D3D21F}"/>
               </a:ext>
             </a:extLst>
           </p:cNvPr>
@@ -4493,7 +4493,7 @@
           <p:cNvPr id="18" name="function-body-4">
             <a:extLst xmlns:a="http://schemas.openxmlformats.org/drawingml/2006/main">
               <a:ext uri="{FF2B5EF4-FFF2-40B4-BE49-F238E27FC236}">
-                <a16:creationId xmlns:a16="http://schemas.microsoft.com/office/drawing/2014/main" id="{BFD1B2D9-59DF-4F3F-8669-DAFEDAEBD108}"/>
+                <a16:creationId xmlns:a16="http://schemas.microsoft.com/office/drawing/2014/main" id="{F6F5D998-D0C1-4D45-9355-334C16008F52}"/>
               </a:ext>
             </a:extLst>
           </p:cNvPr>
@@ -4538,7 +4538,7 @@
           <p:cNvPr id="19" name="">
             <a:extLst xmlns:a="http://schemas.openxmlformats.org/drawingml/2006/main">
               <a:ext uri="{FF2B5EF4-FFF2-40B4-BE49-F238E27FC236}">
-                <a16:creationId xmlns:a16="http://schemas.microsoft.com/office/drawing/2014/main" id="{EA789C24-21F6-4064-ACE9-FCADA6E88AB4}"/>
+                <a16:creationId xmlns:a16="http://schemas.microsoft.com/office/drawing/2014/main" id="{B7EA09E9-3F1A-4912-9150-567BA65EC7FD}"/>
               </a:ext>
             </a:extLst>
           </p:cNvPr>
@@ -4571,7 +4571,7 @@
           <p:cNvPr id="20" name="function-label-5">
             <a:extLst xmlns:a="http://schemas.openxmlformats.org/drawingml/2006/main">
               <a:ext uri="{FF2B5EF4-FFF2-40B4-BE49-F238E27FC236}">
-                <a16:creationId xmlns:a16="http://schemas.microsoft.com/office/drawing/2014/main" id="{5A535438-371C-41A6-94AB-82B78F7EE1F9}"/>
+                <a16:creationId xmlns:a16="http://schemas.microsoft.com/office/drawing/2014/main" id="{BDA719F4-5EF9-4E2A-84A4-D28584F84AFA}"/>
               </a:ext>
             </a:extLst>
           </p:cNvPr>
@@ -4616,7 +4616,7 @@
           <p:cNvPr id="21" name="function-body-5">
             <a:extLst xmlns:a="http://schemas.openxmlformats.org/drawingml/2006/main">
               <a:ext uri="{FF2B5EF4-FFF2-40B4-BE49-F238E27FC236}">
-                <a16:creationId xmlns:a16="http://schemas.microsoft.com/office/drawing/2014/main" id="{64AF12DC-E5F5-4990-8F2F-EC66F0A2D2A8}"/>
+                <a16:creationId xmlns:a16="http://schemas.microsoft.com/office/drawing/2014/main" id="{62577BA8-EEB0-43B8-B3B6-9C9F8375F3F4}"/>
               </a:ext>
             </a:extLst>
           </p:cNvPr>
@@ -4661,7 +4661,7 @@
           <p:cNvPr id="22" name="">
             <a:extLst xmlns:a="http://schemas.openxmlformats.org/drawingml/2006/main">
               <a:ext uri="{FF2B5EF4-FFF2-40B4-BE49-F238E27FC236}">
-                <a16:creationId xmlns:a16="http://schemas.microsoft.com/office/drawing/2014/main" id="{C8A6849D-35F6-4234-935E-B6B0014B34CE}"/>
+                <a16:creationId xmlns:a16="http://schemas.microsoft.com/office/drawing/2014/main" id="{ABB6D065-87B1-41E7-BA49-F5B32960A247}"/>
               </a:ext>
             </a:extLst>
           </p:cNvPr>
@@ -4704,7 +4704,7 @@
     </p:spTree>
     <p:extLst>
       <p:ext uri="{BB962C8B-B14F-4D97-AF65-F5344CB8AC3E}">
-        <p14:creationId xmlns:p14="http://schemas.microsoft.com/office/powerpoint/2010/main" val="1864908812"/>
+        <p14:creationId xmlns:p14="http://schemas.microsoft.com/office/powerpoint/2010/main" val="1461290828"/>
       </p:ext>
     </p:extLst>
   </p:cSld>
@@ -4735,7 +4735,7 @@
           <p:cNvPr id="16" name="title-13">
             <a:extLst xmlns:a="http://schemas.openxmlformats.org/drawingml/2006/main">
               <a:ext uri="{FF2B5EF4-FFF2-40B4-BE49-F238E27FC236}">
-                <a16:creationId xmlns:a16="http://schemas.microsoft.com/office/drawing/2014/main" id="{3387035D-70AA-45B5-A0D8-BECA728B4554}"/>
+                <a16:creationId xmlns:a16="http://schemas.microsoft.com/office/drawing/2014/main" id="{3E14B6BC-3DB5-4A68-8367-E8CBC31F5094}"/>
               </a:ext>
             </a:extLst>
           </p:cNvPr>
@@ -4780,7 +4780,7 @@
           <p:cNvPr id="2" name="source-13">
             <a:extLst xmlns:a="http://schemas.openxmlformats.org/drawingml/2006/main">
               <a:ext uri="{FF2B5EF4-FFF2-40B4-BE49-F238E27FC236}">
-                <a16:creationId xmlns:a16="http://schemas.microsoft.com/office/drawing/2014/main" id="{EC0F0D2A-968B-4F0C-9AD7-F085BBE9F12D}"/>
+                <a16:creationId xmlns:a16="http://schemas.microsoft.com/office/drawing/2014/main" id="{7DBE529B-A12B-49DC-969C-CA138C84D71F}"/>
               </a:ext>
             </a:extLst>
           </p:cNvPr>
@@ -4825,7 +4825,7 @@
           <p:cNvPr id="3" name="page-13">
             <a:extLst xmlns:a="http://schemas.openxmlformats.org/drawingml/2006/main">
               <a:ext uri="{FF2B5EF4-FFF2-40B4-BE49-F238E27FC236}">
-                <a16:creationId xmlns:a16="http://schemas.microsoft.com/office/drawing/2014/main" id="{525F2788-39C5-44F6-8587-C6CD5D3FD8E2}"/>
+                <a16:creationId xmlns:a16="http://schemas.microsoft.com/office/drawing/2014/main" id="{77CCB5AF-F523-44C6-8F82-3DC3A6CD2FF6}"/>
               </a:ext>
             </a:extLst>
           </p:cNvPr>
@@ -4870,7 +4870,7 @@
           <p:cNvPr id="4" name="">
             <a:extLst xmlns:a="http://schemas.openxmlformats.org/drawingml/2006/main">
               <a:ext uri="{FF2B5EF4-FFF2-40B4-BE49-F238E27FC236}">
-                <a16:creationId xmlns:a16="http://schemas.microsoft.com/office/drawing/2014/main" id="{1FB0C7B7-CD9A-4A6D-B920-A31A24626B6D}"/>
+                <a16:creationId xmlns:a16="http://schemas.microsoft.com/office/drawing/2014/main" id="{7B5AF9D7-771F-4F6C-B00F-CB5A9FAA7C81}"/>
               </a:ext>
             </a:extLst>
           </p:cNvPr>
@@ -4915,7 +4915,7 @@
           <p:cNvPr id="5" name="">
             <a:extLst xmlns:a="http://schemas.openxmlformats.org/drawingml/2006/main">
               <a:ext uri="{FF2B5EF4-FFF2-40B4-BE49-F238E27FC236}">
-                <a16:creationId xmlns:a16="http://schemas.microsoft.com/office/drawing/2014/main" id="{2ED65FCA-CC5D-4DB6-9F96-ED2DABA1C991}"/>
+                <a16:creationId xmlns:a16="http://schemas.microsoft.com/office/drawing/2014/main" id="{31E37D24-E1BE-4592-9519-667ACED335BE}"/>
               </a:ext>
             </a:extLst>
           </p:cNvPr>
@@ -4960,7 +4960,7 @@
           <p:cNvPr id="6" name="">
             <a:extLst xmlns:a="http://schemas.openxmlformats.org/drawingml/2006/main">
               <a:ext uri="{FF2B5EF4-FFF2-40B4-BE49-F238E27FC236}">
-                <a16:creationId xmlns:a16="http://schemas.microsoft.com/office/drawing/2014/main" id="{946D7523-A4CF-48AA-8BF8-E8169F9D4C9C}"/>
+                <a16:creationId xmlns:a16="http://schemas.microsoft.com/office/drawing/2014/main" id="{B6CBC751-3E78-4353-A6C2-A083709D8154}"/>
               </a:ext>
             </a:extLst>
           </p:cNvPr>
@@ -5005,7 +5005,7 @@
           <p:cNvPr id="7" name="">
             <a:extLst xmlns:a="http://schemas.openxmlformats.org/drawingml/2006/main">
               <a:ext uri="{FF2B5EF4-FFF2-40B4-BE49-F238E27FC236}">
-                <a16:creationId xmlns:a16="http://schemas.microsoft.com/office/drawing/2014/main" id="{FCAE4964-32F7-4554-9E83-7F0D0FD41588}"/>
+                <a16:creationId xmlns:a16="http://schemas.microsoft.com/office/drawing/2014/main" id="{0E66B2AF-2F90-4BC9-A336-9E5461F03576}"/>
               </a:ext>
             </a:extLst>
           </p:cNvPr>
@@ -5050,7 +5050,7 @@
           <p:cNvPr id="8" name="">
             <a:extLst xmlns:a="http://schemas.openxmlformats.org/drawingml/2006/main">
               <a:ext uri="{FF2B5EF4-FFF2-40B4-BE49-F238E27FC236}">
-                <a16:creationId xmlns:a16="http://schemas.microsoft.com/office/drawing/2014/main" id="{87D6A976-CAD8-4B64-BD00-D4FCE79E6471}"/>
+                <a16:creationId xmlns:a16="http://schemas.microsoft.com/office/drawing/2014/main" id="{42DF3EA9-9119-4E13-B462-10124E33B06B}"/>
               </a:ext>
             </a:extLst>
           </p:cNvPr>
@@ -5095,7 +5095,7 @@
           <p:cNvPr id="9" name="">
             <a:extLst xmlns:a="http://schemas.openxmlformats.org/drawingml/2006/main">
               <a:ext uri="{FF2B5EF4-FFF2-40B4-BE49-F238E27FC236}">
-                <a16:creationId xmlns:a16="http://schemas.microsoft.com/office/drawing/2014/main" id="{C22A2AF7-EDCD-4C3E-97AC-673A0368BE5B}"/>
+                <a16:creationId xmlns:a16="http://schemas.microsoft.com/office/drawing/2014/main" id="{057DF786-3134-4B3A-83AD-A61B08C9F962}"/>
               </a:ext>
             </a:extLst>
           </p:cNvPr>
@@ -5140,7 +5140,7 @@
           <p:cNvPr id="10" name="">
             <a:extLst xmlns:a="http://schemas.openxmlformats.org/drawingml/2006/main">
               <a:ext uri="{FF2B5EF4-FFF2-40B4-BE49-F238E27FC236}">
-                <a16:creationId xmlns:a16="http://schemas.microsoft.com/office/drawing/2014/main" id="{EE78BC0C-11C9-4655-ADB9-D34647B51F39}"/>
+                <a16:creationId xmlns:a16="http://schemas.microsoft.com/office/drawing/2014/main" id="{4ED4D68D-2B9C-483A-B05E-CB29CF17DA6F}"/>
               </a:ext>
             </a:extLst>
           </p:cNvPr>
@@ -5185,7 +5185,7 @@
           <p:cNvPr id="11" name="">
             <a:extLst xmlns:a="http://schemas.openxmlformats.org/drawingml/2006/main">
               <a:ext uri="{FF2B5EF4-FFF2-40B4-BE49-F238E27FC236}">
-                <a16:creationId xmlns:a16="http://schemas.microsoft.com/office/drawing/2014/main" id="{2F9B78E7-99E8-43D9-9602-BE2790ED35CF}"/>
+                <a16:creationId xmlns:a16="http://schemas.microsoft.com/office/drawing/2014/main" id="{0DF75CFF-6E9A-4B99-B124-20622CF50BDF}"/>
               </a:ext>
             </a:extLst>
           </p:cNvPr>
@@ -5230,7 +5230,7 @@
           <p:cNvPr id="12" name="home-frame">
             <a:extLst xmlns:a="http://schemas.openxmlformats.org/drawingml/2006/main">
               <a:ext uri="{FF2B5EF4-FFF2-40B4-BE49-F238E27FC236}">
-                <a16:creationId xmlns:a16="http://schemas.microsoft.com/office/drawing/2014/main" id="{18708451-8005-4616-A950-7F86074C9B2D}"/>
+                <a16:creationId xmlns:a16="http://schemas.microsoft.com/office/drawing/2014/main" id="{21349B99-397A-4E84-ACC9-02F45A5A7B7B}"/>
               </a:ext>
             </a:extLst>
           </p:cNvPr>
@@ -5265,7 +5265,7 @@
           <p:cNvPr id="13" name="guide-frame">
             <a:extLst xmlns:a="http://schemas.openxmlformats.org/drawingml/2006/main">
               <a:ext uri="{FF2B5EF4-FFF2-40B4-BE49-F238E27FC236}">
-                <a16:creationId xmlns:a16="http://schemas.microsoft.com/office/drawing/2014/main" id="{3C29F344-12A9-4C6F-9043-7D932C6CA1BF}"/>
+                <a16:creationId xmlns:a16="http://schemas.microsoft.com/office/drawing/2014/main" id="{38195234-97A2-499E-B978-CE4A8AE9787B}"/>
               </a:ext>
             </a:extLst>
           </p:cNvPr>
@@ -5304,7 +5304,7 @@
           <p:nvPr/>
         </p:nvPicPr>
         <p:blipFill>
-          <a:blip xmlns:r="http://schemas.openxmlformats.org/officeDocument/2006/relationships" xmlns:a="http://schemas.openxmlformats.org/drawingml/2006/main" r:embed="R6d1a85fd84c04427"/>
+          <a:blip xmlns:r="http://schemas.openxmlformats.org/officeDocument/2006/relationships" xmlns:a="http://schemas.openxmlformats.org/drawingml/2006/main" r:embed="Rceceecb365d7449a"/>
           <a:stretch xmlns:a="http://schemas.openxmlformats.org/drawingml/2006/main"/>
         </p:blipFill>
         <p:spPr>
@@ -5326,7 +5326,7 @@
           <p:nvPr/>
         </p:nvPicPr>
         <p:blipFill>
-          <a:blip xmlns:r="http://schemas.openxmlformats.org/officeDocument/2006/relationships" xmlns:a="http://schemas.openxmlformats.org/drawingml/2006/main" r:embed="Rdb61bae263814d83"/>
+          <a:blip xmlns:r="http://schemas.openxmlformats.org/officeDocument/2006/relationships" xmlns:a="http://schemas.openxmlformats.org/drawingml/2006/main" r:embed="R15429af2adbf4142"/>
           <a:stretch xmlns:a="http://schemas.openxmlformats.org/drawingml/2006/main"/>
         </p:blipFill>
         <p:spPr>
@@ -5342,7 +5342,7 @@
     </p:spTree>
     <p:extLst>
       <p:ext uri="{BB962C8B-B14F-4D97-AF65-F5344CB8AC3E}">
-        <p14:creationId xmlns:p14="http://schemas.microsoft.com/office/powerpoint/2010/main" val="227750709"/>
+        <p14:creationId xmlns:p14="http://schemas.microsoft.com/office/powerpoint/2010/main" val="1932892947"/>
       </p:ext>
     </p:extLst>
   </p:cSld>
@@ -5373,7 +5373,7 @@
           <p:cNvPr id="6" name="">
             <a:extLst xmlns:a="http://schemas.openxmlformats.org/drawingml/2006/main">
               <a:ext uri="{FF2B5EF4-FFF2-40B4-BE49-F238E27FC236}">
-                <a16:creationId xmlns:a16="http://schemas.microsoft.com/office/drawing/2014/main" id="{EE33B384-37A3-4973-B09C-FA75EB8EE9F8}"/>
+                <a16:creationId xmlns:a16="http://schemas.microsoft.com/office/drawing/2014/main" id="{D032F7FC-E59F-427D-B89E-3B2E53F712DF}"/>
               </a:ext>
             </a:extLst>
           </p:cNvPr>
@@ -5418,7 +5418,7 @@
           <p:cNvPr id="2" name="">
             <a:extLst xmlns:a="http://schemas.openxmlformats.org/drawingml/2006/main">
               <a:ext uri="{FF2B5EF4-FFF2-40B4-BE49-F238E27FC236}">
-                <a16:creationId xmlns:a16="http://schemas.microsoft.com/office/drawing/2014/main" id="{21626EAC-18EA-49A5-AB8F-FF75636EF032}"/>
+                <a16:creationId xmlns:a16="http://schemas.microsoft.com/office/drawing/2014/main" id="{03F0CF33-6AA8-41BF-852E-91DD7D5655B0}"/>
               </a:ext>
             </a:extLst>
           </p:cNvPr>
@@ -5463,7 +5463,7 @@
           <p:cNvPr id="3" name="">
             <a:extLst xmlns:a="http://schemas.openxmlformats.org/drawingml/2006/main">
               <a:ext uri="{FF2B5EF4-FFF2-40B4-BE49-F238E27FC236}">
-                <a16:creationId xmlns:a16="http://schemas.microsoft.com/office/drawing/2014/main" id="{074A716A-02DE-458A-A390-B35DFA92AF97}"/>
+                <a16:creationId xmlns:a16="http://schemas.microsoft.com/office/drawing/2014/main" id="{87DD923A-7461-4CC3-8AC4-1A367A920036}"/>
               </a:ext>
             </a:extLst>
           </p:cNvPr>
@@ -5508,7 +5508,7 @@
           <p:cNvPr id="4" name="source-14">
             <a:extLst xmlns:a="http://schemas.openxmlformats.org/drawingml/2006/main">
               <a:ext uri="{FF2B5EF4-FFF2-40B4-BE49-F238E27FC236}">
-                <a16:creationId xmlns:a16="http://schemas.microsoft.com/office/drawing/2014/main" id="{8A0CAB2C-FFEA-48EA-837C-53582FDB79F6}"/>
+                <a16:creationId xmlns:a16="http://schemas.microsoft.com/office/drawing/2014/main" id="{72BC433F-3AFA-4A37-8C00-44802AA2A677}"/>
               </a:ext>
             </a:extLst>
           </p:cNvPr>
@@ -5553,7 +5553,7 @@
           <p:cNvPr id="5" name="page-14">
             <a:extLst xmlns:a="http://schemas.openxmlformats.org/drawingml/2006/main">
               <a:ext uri="{FF2B5EF4-FFF2-40B4-BE49-F238E27FC236}">
-                <a16:creationId xmlns:a16="http://schemas.microsoft.com/office/drawing/2014/main" id="{71731B7E-4DBD-401D-BB45-5A572FC6A6B8}"/>
+                <a16:creationId xmlns:a16="http://schemas.microsoft.com/office/drawing/2014/main" id="{730DCAEE-E2BD-421B-9711-2ECCB2ED2684}"/>
               </a:ext>
             </a:extLst>
           </p:cNvPr>
@@ -5596,7 +5596,7 @@
     </p:spTree>
     <p:extLst>
       <p:ext uri="{BB962C8B-B14F-4D97-AF65-F5344CB8AC3E}">
-        <p14:creationId xmlns:p14="http://schemas.microsoft.com/office/powerpoint/2010/main" val="1263398483"/>
+        <p14:creationId xmlns:p14="http://schemas.microsoft.com/office/powerpoint/2010/main" val="91205442"/>
       </p:ext>
     </p:extLst>
   </p:cSld>
@@ -5627,7 +5627,7 @@
           <p:cNvPr id="17" name="title-2">
             <a:extLst xmlns:a="http://schemas.openxmlformats.org/drawingml/2006/main">
               <a:ext uri="{FF2B5EF4-FFF2-40B4-BE49-F238E27FC236}">
-                <a16:creationId xmlns:a16="http://schemas.microsoft.com/office/drawing/2014/main" id="{20900B2A-450F-44AA-9639-B156506578DE}"/>
+                <a16:creationId xmlns:a16="http://schemas.microsoft.com/office/drawing/2014/main" id="{762223F7-DA32-4620-AF64-61EC7E509767}"/>
               </a:ext>
             </a:extLst>
           </p:cNvPr>
@@ -5672,7 +5672,7 @@
           <p:cNvPr id="2" name="source-2">
             <a:extLst xmlns:a="http://schemas.openxmlformats.org/drawingml/2006/main">
               <a:ext uri="{FF2B5EF4-FFF2-40B4-BE49-F238E27FC236}">
-                <a16:creationId xmlns:a16="http://schemas.microsoft.com/office/drawing/2014/main" id="{D9D89DD3-2E6C-428E-8AF8-A0065B7CF1CA}"/>
+                <a16:creationId xmlns:a16="http://schemas.microsoft.com/office/drawing/2014/main" id="{1937A38A-FC70-4C0C-A49F-43283FAE41B3}"/>
               </a:ext>
             </a:extLst>
           </p:cNvPr>
@@ -5717,7 +5717,7 @@
           <p:cNvPr id="3" name="page-2">
             <a:extLst xmlns:a="http://schemas.openxmlformats.org/drawingml/2006/main">
               <a:ext uri="{FF2B5EF4-FFF2-40B4-BE49-F238E27FC236}">
-                <a16:creationId xmlns:a16="http://schemas.microsoft.com/office/drawing/2014/main" id="{8F6AF70E-1258-4AF6-B60B-52111639B520}"/>
+                <a16:creationId xmlns:a16="http://schemas.microsoft.com/office/drawing/2014/main" id="{D456BB4B-2F24-4537-A14B-3EB3EF38417E}"/>
               </a:ext>
             </a:extLst>
           </p:cNvPr>
@@ -5762,7 +5762,7 @@
           <p:cNvPr id="4" name="">
             <a:extLst xmlns:a="http://schemas.openxmlformats.org/drawingml/2006/main">
               <a:ext uri="{FF2B5EF4-FFF2-40B4-BE49-F238E27FC236}">
-                <a16:creationId xmlns:a16="http://schemas.microsoft.com/office/drawing/2014/main" id="{13E9E9A1-261C-4AFD-A3A2-297AEB28259E}"/>
+                <a16:creationId xmlns:a16="http://schemas.microsoft.com/office/drawing/2014/main" id="{56B7CDCA-5A1B-491D-B578-BF7A58F4B813}"/>
               </a:ext>
             </a:extLst>
           </p:cNvPr>
@@ -5795,7 +5795,7 @@
           <p:cNvPr id="5" name="">
             <a:extLst xmlns:a="http://schemas.openxmlformats.org/drawingml/2006/main">
               <a:ext uri="{FF2B5EF4-FFF2-40B4-BE49-F238E27FC236}">
-                <a16:creationId xmlns:a16="http://schemas.microsoft.com/office/drawing/2014/main" id="{761C6F94-B073-41A2-A3CE-E42A6B310C44}"/>
+                <a16:creationId xmlns:a16="http://schemas.microsoft.com/office/drawing/2014/main" id="{CD46263F-F963-4842-8A49-0DB251BB3DED}"/>
               </a:ext>
             </a:extLst>
           </p:cNvPr>
@@ -5828,7 +5828,7 @@
           <p:cNvPr id="6" name="">
             <a:extLst xmlns:a="http://schemas.openxmlformats.org/drawingml/2006/main">
               <a:ext uri="{FF2B5EF4-FFF2-40B4-BE49-F238E27FC236}">
-                <a16:creationId xmlns:a16="http://schemas.microsoft.com/office/drawing/2014/main" id="{62E09E8F-F2B0-4559-8420-BFA5B849B43E}"/>
+                <a16:creationId xmlns:a16="http://schemas.microsoft.com/office/drawing/2014/main" id="{521A5829-C4E0-453F-9336-E54FF0E1833D}"/>
               </a:ext>
             </a:extLst>
           </p:cNvPr>
@@ -5861,7 +5861,7 @@
           <p:cNvPr id="7" name="">
             <a:extLst xmlns:a="http://schemas.openxmlformats.org/drawingml/2006/main">
               <a:ext uri="{FF2B5EF4-FFF2-40B4-BE49-F238E27FC236}">
-                <a16:creationId xmlns:a16="http://schemas.microsoft.com/office/drawing/2014/main" id="{4924F56B-4E85-4673-8851-587981616359}"/>
+                <a16:creationId xmlns:a16="http://schemas.microsoft.com/office/drawing/2014/main" id="{B46BD8B7-1CEE-47DF-81C7-0485351424D3}"/>
               </a:ext>
             </a:extLst>
           </p:cNvPr>
@@ -5894,7 +5894,7 @@
           <p:cNvPr id="8" name="">
             <a:extLst xmlns:a="http://schemas.openxmlformats.org/drawingml/2006/main">
               <a:ext uri="{FF2B5EF4-FFF2-40B4-BE49-F238E27FC236}">
-                <a16:creationId xmlns:a16="http://schemas.microsoft.com/office/drawing/2014/main" id="{DA87B25F-DE19-4037-8130-4203799AE603}"/>
+                <a16:creationId xmlns:a16="http://schemas.microsoft.com/office/drawing/2014/main" id="{8EB1B047-2997-42A0-9992-46F948CE193F}"/>
               </a:ext>
             </a:extLst>
           </p:cNvPr>
@@ -5939,7 +5939,7 @@
           <p:cNvPr id="9" name="">
             <a:extLst xmlns:a="http://schemas.openxmlformats.org/drawingml/2006/main">
               <a:ext uri="{FF2B5EF4-FFF2-40B4-BE49-F238E27FC236}">
-                <a16:creationId xmlns:a16="http://schemas.microsoft.com/office/drawing/2014/main" id="{EA1F5E49-BD61-47E4-A4AD-48424516CB3B}"/>
+                <a16:creationId xmlns:a16="http://schemas.microsoft.com/office/drawing/2014/main" id="{D51FD599-34AF-4769-B5A1-01301949ACAB}"/>
               </a:ext>
             </a:extLst>
           </p:cNvPr>
@@ -5984,7 +5984,7 @@
           <p:cNvPr id="10" name="">
             <a:extLst xmlns:a="http://schemas.openxmlformats.org/drawingml/2006/main">
               <a:ext uri="{FF2B5EF4-FFF2-40B4-BE49-F238E27FC236}">
-                <a16:creationId xmlns:a16="http://schemas.microsoft.com/office/drawing/2014/main" id="{E20B8B6F-B3F7-4751-9F75-4F4BB503D9A3}"/>
+                <a16:creationId xmlns:a16="http://schemas.microsoft.com/office/drawing/2014/main" id="{184A3C3E-9897-48C0-B0AA-9F12BC46002D}"/>
               </a:ext>
             </a:extLst>
           </p:cNvPr>
@@ -6029,7 +6029,7 @@
           <p:cNvPr id="11" name="">
             <a:extLst xmlns:a="http://schemas.openxmlformats.org/drawingml/2006/main">
               <a:ext uri="{FF2B5EF4-FFF2-40B4-BE49-F238E27FC236}">
-                <a16:creationId xmlns:a16="http://schemas.microsoft.com/office/drawing/2014/main" id="{86074D4D-12B7-4944-86AC-FF72BA9A390A}"/>
+                <a16:creationId xmlns:a16="http://schemas.microsoft.com/office/drawing/2014/main" id="{73D3177A-3FBE-4FCC-9077-E4B787576514}"/>
               </a:ext>
             </a:extLst>
           </p:cNvPr>
@@ -6074,7 +6074,7 @@
           <p:cNvPr id="12" name="">
             <a:extLst xmlns:a="http://schemas.openxmlformats.org/drawingml/2006/main">
               <a:ext uri="{FF2B5EF4-FFF2-40B4-BE49-F238E27FC236}">
-                <a16:creationId xmlns:a16="http://schemas.microsoft.com/office/drawing/2014/main" id="{43BAB6DD-A096-428D-8D09-F037C562D938}"/>
+                <a16:creationId xmlns:a16="http://schemas.microsoft.com/office/drawing/2014/main" id="{4F93A615-18E0-4A13-B29A-23C273640852}"/>
               </a:ext>
             </a:extLst>
           </p:cNvPr>
@@ -6119,7 +6119,7 @@
           <p:cNvPr id="13" name="">
             <a:extLst xmlns:a="http://schemas.openxmlformats.org/drawingml/2006/main">
               <a:ext uri="{FF2B5EF4-FFF2-40B4-BE49-F238E27FC236}">
-                <a16:creationId xmlns:a16="http://schemas.microsoft.com/office/drawing/2014/main" id="{A6C7B0BD-ED03-486D-AAB7-FBB56846255A}"/>
+                <a16:creationId xmlns:a16="http://schemas.microsoft.com/office/drawing/2014/main" id="{47354D36-FB9B-41EB-BF80-4670F8E932B6}"/>
               </a:ext>
             </a:extLst>
           </p:cNvPr>
@@ -6164,7 +6164,7 @@
           <p:cNvPr id="14" name="">
             <a:extLst xmlns:a="http://schemas.openxmlformats.org/drawingml/2006/main">
               <a:ext uri="{FF2B5EF4-FFF2-40B4-BE49-F238E27FC236}">
-                <a16:creationId xmlns:a16="http://schemas.microsoft.com/office/drawing/2014/main" id="{4A0BD92D-F1A7-4601-9264-0CD82BA68AB5}"/>
+                <a16:creationId xmlns:a16="http://schemas.microsoft.com/office/drawing/2014/main" id="{4B030E63-B90D-4FF7-9386-19EFC911E7AC}"/>
               </a:ext>
             </a:extLst>
           </p:cNvPr>
@@ -6209,7 +6209,7 @@
           <p:cNvPr id="15" name="">
             <a:extLst xmlns:a="http://schemas.openxmlformats.org/drawingml/2006/main">
               <a:ext uri="{FF2B5EF4-FFF2-40B4-BE49-F238E27FC236}">
-                <a16:creationId xmlns:a16="http://schemas.microsoft.com/office/drawing/2014/main" id="{BFB09279-40BC-4DA0-AC72-50ADFC18BF5C}"/>
+                <a16:creationId xmlns:a16="http://schemas.microsoft.com/office/drawing/2014/main" id="{DB031731-AAB3-4DB4-926C-EFFFCFC579E8}"/>
               </a:ext>
             </a:extLst>
           </p:cNvPr>
@@ -6254,7 +6254,7 @@
           <p:cNvPr id="16" name="">
             <a:extLst xmlns:a="http://schemas.openxmlformats.org/drawingml/2006/main">
               <a:ext uri="{FF2B5EF4-FFF2-40B4-BE49-F238E27FC236}">
-                <a16:creationId xmlns:a16="http://schemas.microsoft.com/office/drawing/2014/main" id="{F88A56F2-3AEC-4E4F-A3EB-B1B768BE224F}"/>
+                <a16:creationId xmlns:a16="http://schemas.microsoft.com/office/drawing/2014/main" id="{4BD2B9B5-AA57-4839-B99D-47B0D4028BC0}"/>
               </a:ext>
             </a:extLst>
           </p:cNvPr>
@@ -6297,7 +6297,7 @@
     </p:spTree>
     <p:extLst>
       <p:ext uri="{BB962C8B-B14F-4D97-AF65-F5344CB8AC3E}">
-        <p14:creationId xmlns:p14="http://schemas.microsoft.com/office/powerpoint/2010/main" val="696593931"/>
+        <p14:creationId xmlns:p14="http://schemas.microsoft.com/office/powerpoint/2010/main" val="1549970106"/>
       </p:ext>
     </p:extLst>
   </p:cSld>
@@ -6328,7 +6328,7 @@
           <p:cNvPr id="18" name="title-3">
             <a:extLst xmlns:a="http://schemas.openxmlformats.org/drawingml/2006/main">
               <a:ext uri="{FF2B5EF4-FFF2-40B4-BE49-F238E27FC236}">
-                <a16:creationId xmlns:a16="http://schemas.microsoft.com/office/drawing/2014/main" id="{BBFD0A68-F51D-44CB-8230-E1E0CD55C094}"/>
+                <a16:creationId xmlns:a16="http://schemas.microsoft.com/office/drawing/2014/main" id="{E6117EB5-7F0C-41EC-A926-2E17FEE1E4D9}"/>
               </a:ext>
             </a:extLst>
           </p:cNvPr>
@@ -6373,7 +6373,7 @@
           <p:cNvPr id="2" name="source-3">
             <a:extLst xmlns:a="http://schemas.openxmlformats.org/drawingml/2006/main">
               <a:ext uri="{FF2B5EF4-FFF2-40B4-BE49-F238E27FC236}">
-                <a16:creationId xmlns:a16="http://schemas.microsoft.com/office/drawing/2014/main" id="{FC815AB7-DC9F-416E-A397-4EF96F320216}"/>
+                <a16:creationId xmlns:a16="http://schemas.microsoft.com/office/drawing/2014/main" id="{ACCCEDAA-1E21-40C8-A795-6CD2C6CEA99A}"/>
               </a:ext>
             </a:extLst>
           </p:cNvPr>
@@ -6418,7 +6418,7 @@
           <p:cNvPr id="3" name="page-3">
             <a:extLst xmlns:a="http://schemas.openxmlformats.org/drawingml/2006/main">
               <a:ext uri="{FF2B5EF4-FFF2-40B4-BE49-F238E27FC236}">
-                <a16:creationId xmlns:a16="http://schemas.microsoft.com/office/drawing/2014/main" id="{B4DE3084-7FA8-474C-96BD-AD6C068D8DB7}"/>
+                <a16:creationId xmlns:a16="http://schemas.microsoft.com/office/drawing/2014/main" id="{4D471E1A-A83C-4308-A48D-511E23DD1CA8}"/>
               </a:ext>
             </a:extLst>
           </p:cNvPr>
@@ -6463,7 +6463,7 @@
           <p:cNvPr id="4" name="">
             <a:extLst xmlns:a="http://schemas.openxmlformats.org/drawingml/2006/main">
               <a:ext uri="{FF2B5EF4-FFF2-40B4-BE49-F238E27FC236}">
-                <a16:creationId xmlns:a16="http://schemas.microsoft.com/office/drawing/2014/main" id="{A33D4CC7-C504-4296-BCE2-1926B9C01F7A}"/>
+                <a16:creationId xmlns:a16="http://schemas.microsoft.com/office/drawing/2014/main" id="{500A51A5-EC58-4482-B1BB-9BAF0AB8FF0C}"/>
               </a:ext>
             </a:extLst>
           </p:cNvPr>
@@ -6508,7 +6508,7 @@
           <p:cNvPr id="5" name="">
             <a:extLst xmlns:a="http://schemas.openxmlformats.org/drawingml/2006/main">
               <a:ext uri="{FF2B5EF4-FFF2-40B4-BE49-F238E27FC236}">
-                <a16:creationId xmlns:a16="http://schemas.microsoft.com/office/drawing/2014/main" id="{26835AA9-0B83-48E6-8896-775C712F1479}"/>
+                <a16:creationId xmlns:a16="http://schemas.microsoft.com/office/drawing/2014/main" id="{912DA096-BA28-4893-9FA9-5AADF92D9E48}"/>
               </a:ext>
             </a:extLst>
           </p:cNvPr>
@@ -6553,7 +6553,7 @@
           <p:cNvPr id="6" name="">
             <a:extLst xmlns:a="http://schemas.openxmlformats.org/drawingml/2006/main">
               <a:ext uri="{FF2B5EF4-FFF2-40B4-BE49-F238E27FC236}">
-                <a16:creationId xmlns:a16="http://schemas.microsoft.com/office/drawing/2014/main" id="{944FA1D6-18F5-4572-B8EC-BAD21824C0EB}"/>
+                <a16:creationId xmlns:a16="http://schemas.microsoft.com/office/drawing/2014/main" id="{489E0873-0D43-468F-B3A4-17B5B0E89C93}"/>
               </a:ext>
             </a:extLst>
           </p:cNvPr>
@@ -6602,7 +6602,7 @@
           <p:cNvPr id="7" name="">
             <a:extLst xmlns:a="http://schemas.openxmlformats.org/drawingml/2006/main">
               <a:ext uri="{FF2B5EF4-FFF2-40B4-BE49-F238E27FC236}">
-                <a16:creationId xmlns:a16="http://schemas.microsoft.com/office/drawing/2014/main" id="{45954958-3F5B-4A13-A3D1-578C792B9628}"/>
+                <a16:creationId xmlns:a16="http://schemas.microsoft.com/office/drawing/2014/main" id="{B1431141-78F6-4B10-907F-0C6B9301E453}"/>
               </a:ext>
             </a:extLst>
           </p:cNvPr>
@@ -6635,7 +6635,7 @@
           <p:cNvPr id="8" name="">
             <a:extLst xmlns:a="http://schemas.openxmlformats.org/drawingml/2006/main">
               <a:ext uri="{FF2B5EF4-FFF2-40B4-BE49-F238E27FC236}">
-                <a16:creationId xmlns:a16="http://schemas.microsoft.com/office/drawing/2014/main" id="{402A6381-CD89-44C6-83B0-0E8F88FF38D4}"/>
+                <a16:creationId xmlns:a16="http://schemas.microsoft.com/office/drawing/2014/main" id="{89396A7B-C4F9-4E82-8858-0D6F6D001AED}"/>
               </a:ext>
             </a:extLst>
           </p:cNvPr>
@@ -6680,7 +6680,7 @@
           <p:cNvPr id="9" name="">
             <a:extLst xmlns:a="http://schemas.openxmlformats.org/drawingml/2006/main">
               <a:ext uri="{FF2B5EF4-FFF2-40B4-BE49-F238E27FC236}">
-                <a16:creationId xmlns:a16="http://schemas.microsoft.com/office/drawing/2014/main" id="{CB14C308-E12C-482E-94D5-C4294DA7F1AD}"/>
+                <a16:creationId xmlns:a16="http://schemas.microsoft.com/office/drawing/2014/main" id="{E4B70EDE-CF05-43C2-BB0A-BF93D6BBAD3D}"/>
               </a:ext>
             </a:extLst>
           </p:cNvPr>
@@ -6725,7 +6725,7 @@
           <p:cNvPr id="10" name="">
             <a:extLst xmlns:a="http://schemas.openxmlformats.org/drawingml/2006/main">
               <a:ext uri="{FF2B5EF4-FFF2-40B4-BE49-F238E27FC236}">
-                <a16:creationId xmlns:a16="http://schemas.microsoft.com/office/drawing/2014/main" id="{4C4502BB-897F-4202-8181-738DE019914D}"/>
+                <a16:creationId xmlns:a16="http://schemas.microsoft.com/office/drawing/2014/main" id="{7EDA934A-430E-4EBF-B29B-ECC67AB9A77B}"/>
               </a:ext>
             </a:extLst>
           </p:cNvPr>
@@ -6770,7 +6770,7 @@
           <p:cNvPr id="11" name="">
             <a:extLst xmlns:a="http://schemas.openxmlformats.org/drawingml/2006/main">
               <a:ext uri="{FF2B5EF4-FFF2-40B4-BE49-F238E27FC236}">
-                <a16:creationId xmlns:a16="http://schemas.microsoft.com/office/drawing/2014/main" id="{F7F12087-8D69-4F5F-A538-11499A5F9516}"/>
+                <a16:creationId xmlns:a16="http://schemas.microsoft.com/office/drawing/2014/main" id="{B54948E0-0887-48BC-8394-EA7AF488397B}"/>
               </a:ext>
             </a:extLst>
           </p:cNvPr>
@@ -6815,7 +6815,7 @@
           <p:cNvPr id="12" name="">
             <a:extLst xmlns:a="http://schemas.openxmlformats.org/drawingml/2006/main">
               <a:ext uri="{FF2B5EF4-FFF2-40B4-BE49-F238E27FC236}">
-                <a16:creationId xmlns:a16="http://schemas.microsoft.com/office/drawing/2014/main" id="{69489380-50CC-4A61-A2B3-55E8972C2E76}"/>
+                <a16:creationId xmlns:a16="http://schemas.microsoft.com/office/drawing/2014/main" id="{56B3746C-6372-4031-81D5-60376B5F059B}"/>
               </a:ext>
             </a:extLst>
           </p:cNvPr>
@@ -6860,7 +6860,7 @@
           <p:cNvPr id="13" name="">
             <a:extLst xmlns:a="http://schemas.openxmlformats.org/drawingml/2006/main">
               <a:ext uri="{FF2B5EF4-FFF2-40B4-BE49-F238E27FC236}">
-                <a16:creationId xmlns:a16="http://schemas.microsoft.com/office/drawing/2014/main" id="{156B7479-C4B9-4F06-BB63-0BEBD7153743}"/>
+                <a16:creationId xmlns:a16="http://schemas.microsoft.com/office/drawing/2014/main" id="{97D31300-C8C8-4499-887D-2674333555EF}"/>
               </a:ext>
             </a:extLst>
           </p:cNvPr>
@@ -6905,7 +6905,7 @@
           <p:cNvPr id="14" name="">
             <a:extLst xmlns:a="http://schemas.openxmlformats.org/drawingml/2006/main">
               <a:ext uri="{FF2B5EF4-FFF2-40B4-BE49-F238E27FC236}">
-                <a16:creationId xmlns:a16="http://schemas.microsoft.com/office/drawing/2014/main" id="{80D8C48D-7552-4946-B7A9-2C713BDE714D}"/>
+                <a16:creationId xmlns:a16="http://schemas.microsoft.com/office/drawing/2014/main" id="{726897FB-B071-4003-A342-FB7B336E6AD3}"/>
               </a:ext>
             </a:extLst>
           </p:cNvPr>
@@ -6950,7 +6950,7 @@
           <p:cNvPr id="15" name="">
             <a:extLst xmlns:a="http://schemas.openxmlformats.org/drawingml/2006/main">
               <a:ext uri="{FF2B5EF4-FFF2-40B4-BE49-F238E27FC236}">
-                <a16:creationId xmlns:a16="http://schemas.microsoft.com/office/drawing/2014/main" id="{15C5EB81-D6B1-43EE-90DE-EC0295629BCF}"/>
+                <a16:creationId xmlns:a16="http://schemas.microsoft.com/office/drawing/2014/main" id="{8E797295-F12D-4520-BB31-A588249B16D9}"/>
               </a:ext>
             </a:extLst>
           </p:cNvPr>
@@ -6995,7 +6995,7 @@
           <p:cNvPr id="16" name="">
             <a:extLst xmlns:a="http://schemas.openxmlformats.org/drawingml/2006/main">
               <a:ext uri="{FF2B5EF4-FFF2-40B4-BE49-F238E27FC236}">
-                <a16:creationId xmlns:a16="http://schemas.microsoft.com/office/drawing/2014/main" id="{817E4C9D-2843-48EF-A5DB-4AFFF395C6E0}"/>
+                <a16:creationId xmlns:a16="http://schemas.microsoft.com/office/drawing/2014/main" id="{FFD225F7-9B77-4167-9CA7-8287E7ECB8B6}"/>
               </a:ext>
             </a:extLst>
           </p:cNvPr>
@@ -7040,7 +7040,7 @@
           <p:cNvPr id="17" name="">
             <a:extLst xmlns:a="http://schemas.openxmlformats.org/drawingml/2006/main">
               <a:ext uri="{FF2B5EF4-FFF2-40B4-BE49-F238E27FC236}">
-                <a16:creationId xmlns:a16="http://schemas.microsoft.com/office/drawing/2014/main" id="{B06283AB-B8CA-4E33-84F8-91A4D437EC2E}"/>
+                <a16:creationId xmlns:a16="http://schemas.microsoft.com/office/drawing/2014/main" id="{B4113288-3FCE-4509-AF62-9DFD6973AE45}"/>
               </a:ext>
             </a:extLst>
           </p:cNvPr>
@@ -7083,7 +7083,7 @@
     </p:spTree>
     <p:extLst>
       <p:ext uri="{BB962C8B-B14F-4D97-AF65-F5344CB8AC3E}">
-        <p14:creationId xmlns:p14="http://schemas.microsoft.com/office/powerpoint/2010/main" val="511574295"/>
+        <p14:creationId xmlns:p14="http://schemas.microsoft.com/office/powerpoint/2010/main" val="1301077483"/>
       </p:ext>
     </p:extLst>
   </p:cSld>
@@ -7114,7 +7114,7 @@
           <p:cNvPr id="24" name="title-4">
             <a:extLst xmlns:a="http://schemas.openxmlformats.org/drawingml/2006/main">
               <a:ext uri="{FF2B5EF4-FFF2-40B4-BE49-F238E27FC236}">
-                <a16:creationId xmlns:a16="http://schemas.microsoft.com/office/drawing/2014/main" id="{6B2F8784-0CB2-4225-8980-8BD53C4690AD}"/>
+                <a16:creationId xmlns:a16="http://schemas.microsoft.com/office/drawing/2014/main" id="{13E487A2-0276-488F-A21B-2DAF773A9E52}"/>
               </a:ext>
             </a:extLst>
           </p:cNvPr>
@@ -7159,7 +7159,7 @@
           <p:cNvPr id="2" name="source-4">
             <a:extLst xmlns:a="http://schemas.openxmlformats.org/drawingml/2006/main">
               <a:ext uri="{FF2B5EF4-FFF2-40B4-BE49-F238E27FC236}">
-                <a16:creationId xmlns:a16="http://schemas.microsoft.com/office/drawing/2014/main" id="{7207E0EE-6CF2-4173-99CB-4992978E0953}"/>
+                <a16:creationId xmlns:a16="http://schemas.microsoft.com/office/drawing/2014/main" id="{EAC8C81D-BCB1-48AE-8A91-DC512C58D285}"/>
               </a:ext>
             </a:extLst>
           </p:cNvPr>
@@ -7204,7 +7204,7 @@
           <p:cNvPr id="3" name="page-4">
             <a:extLst xmlns:a="http://schemas.openxmlformats.org/drawingml/2006/main">
               <a:ext uri="{FF2B5EF4-FFF2-40B4-BE49-F238E27FC236}">
-                <a16:creationId xmlns:a16="http://schemas.microsoft.com/office/drawing/2014/main" id="{D4A0B689-FAB7-4BFB-8D5F-6CD406E693DA}"/>
+                <a16:creationId xmlns:a16="http://schemas.microsoft.com/office/drawing/2014/main" id="{31E5A7E7-3FA9-40D5-82F3-AF0C53B9AB5B}"/>
               </a:ext>
             </a:extLst>
           </p:cNvPr>
@@ -7249,7 +7249,7 @@
           <p:cNvPr id="4" name="">
             <a:extLst xmlns:a="http://schemas.openxmlformats.org/drawingml/2006/main">
               <a:ext uri="{FF2B5EF4-FFF2-40B4-BE49-F238E27FC236}">
-                <a16:creationId xmlns:a16="http://schemas.microsoft.com/office/drawing/2014/main" id="{4BEA2645-1F43-4CB3-8D13-56861F4359BD}"/>
+                <a16:creationId xmlns:a16="http://schemas.microsoft.com/office/drawing/2014/main" id="{B97E35B9-1781-482C-BC92-531C1D4F3ECF}"/>
               </a:ext>
             </a:extLst>
           </p:cNvPr>
@@ -7294,7 +7294,7 @@
           <p:cNvPr id="5" name="">
             <a:extLst xmlns:a="http://schemas.openxmlformats.org/drawingml/2006/main">
               <a:ext uri="{FF2B5EF4-FFF2-40B4-BE49-F238E27FC236}">
-                <a16:creationId xmlns:a16="http://schemas.microsoft.com/office/drawing/2014/main" id="{53028846-17D1-4730-A002-7E77AFF7BE3A}"/>
+                <a16:creationId xmlns:a16="http://schemas.microsoft.com/office/drawing/2014/main" id="{9308E56F-247C-4720-B414-B150533E3072}"/>
               </a:ext>
             </a:extLst>
           </p:cNvPr>
@@ -7339,7 +7339,7 @@
           <p:cNvPr id="6" name="">
             <a:extLst xmlns:a="http://schemas.openxmlformats.org/drawingml/2006/main">
               <a:ext uri="{FF2B5EF4-FFF2-40B4-BE49-F238E27FC236}">
-                <a16:creationId xmlns:a16="http://schemas.microsoft.com/office/drawing/2014/main" id="{3FEE807E-D31C-4283-B836-F9432F0DBF5D}"/>
+                <a16:creationId xmlns:a16="http://schemas.microsoft.com/office/drawing/2014/main" id="{4DFFB23C-864C-488C-8EF6-75B4B65028F2}"/>
               </a:ext>
             </a:extLst>
           </p:cNvPr>
@@ -7384,7 +7384,7 @@
           <p:cNvPr id="7" name="">
             <a:extLst xmlns:a="http://schemas.openxmlformats.org/drawingml/2006/main">
               <a:ext uri="{FF2B5EF4-FFF2-40B4-BE49-F238E27FC236}">
-                <a16:creationId xmlns:a16="http://schemas.microsoft.com/office/drawing/2014/main" id="{0A584F96-271F-491A-9020-EFF18A1DA98E}"/>
+                <a16:creationId xmlns:a16="http://schemas.microsoft.com/office/drawing/2014/main" id="{4D692458-ECA0-453E-9AF2-E6CD5A0674B0}"/>
               </a:ext>
             </a:extLst>
           </p:cNvPr>
@@ -7417,7 +7417,7 @@
           <p:cNvPr id="8" name="">
             <a:extLst xmlns:a="http://schemas.openxmlformats.org/drawingml/2006/main">
               <a:ext uri="{FF2B5EF4-FFF2-40B4-BE49-F238E27FC236}">
-                <a16:creationId xmlns:a16="http://schemas.microsoft.com/office/drawing/2014/main" id="{B6BAF204-86B6-4C8B-9557-80ACC1E9162D}"/>
+                <a16:creationId xmlns:a16="http://schemas.microsoft.com/office/drawing/2014/main" id="{88399762-5D49-4CBD-9F97-9BC664629182}"/>
               </a:ext>
             </a:extLst>
           </p:cNvPr>
@@ -7462,7 +7462,7 @@
           <p:cNvPr id="9" name="">
             <a:extLst xmlns:a="http://schemas.openxmlformats.org/drawingml/2006/main">
               <a:ext uri="{FF2B5EF4-FFF2-40B4-BE49-F238E27FC236}">
-                <a16:creationId xmlns:a16="http://schemas.microsoft.com/office/drawing/2014/main" id="{D403D5F9-FA6E-4CC6-9D10-6E89A4334F6F}"/>
+                <a16:creationId xmlns:a16="http://schemas.microsoft.com/office/drawing/2014/main" id="{199BA7ED-BEA7-4779-A564-0BD58C653309}"/>
               </a:ext>
             </a:extLst>
           </p:cNvPr>
@@ -7507,7 +7507,7 @@
           <p:cNvPr id="10" name="">
             <a:extLst xmlns:a="http://schemas.openxmlformats.org/drawingml/2006/main">
               <a:ext uri="{FF2B5EF4-FFF2-40B4-BE49-F238E27FC236}">
-                <a16:creationId xmlns:a16="http://schemas.microsoft.com/office/drawing/2014/main" id="{DCDC7A18-1AAD-41AA-BB65-25B996C2A7C7}"/>
+                <a16:creationId xmlns:a16="http://schemas.microsoft.com/office/drawing/2014/main" id="{0E67268A-78D3-4310-B273-A1F676346617}"/>
               </a:ext>
             </a:extLst>
           </p:cNvPr>
@@ -7552,7 +7552,7 @@
           <p:cNvPr id="11" name="">
             <a:extLst xmlns:a="http://schemas.openxmlformats.org/drawingml/2006/main">
               <a:ext uri="{FF2B5EF4-FFF2-40B4-BE49-F238E27FC236}">
-                <a16:creationId xmlns:a16="http://schemas.microsoft.com/office/drawing/2014/main" id="{B24AC032-F3B3-4E5E-9034-0FBBC04516B8}"/>
+                <a16:creationId xmlns:a16="http://schemas.microsoft.com/office/drawing/2014/main" id="{03AAC0D6-AC91-4FFA-8F1A-3C5CDEB8AE95}"/>
               </a:ext>
             </a:extLst>
           </p:cNvPr>
@@ -7585,7 +7585,7 @@
           <p:cNvPr id="12" name="">
             <a:extLst xmlns:a="http://schemas.openxmlformats.org/drawingml/2006/main">
               <a:ext uri="{FF2B5EF4-FFF2-40B4-BE49-F238E27FC236}">
-                <a16:creationId xmlns:a16="http://schemas.microsoft.com/office/drawing/2014/main" id="{6BE96B22-1934-4BF9-8288-89D7D13D9F96}"/>
+                <a16:creationId xmlns:a16="http://schemas.microsoft.com/office/drawing/2014/main" id="{514C3107-3B69-42B3-A412-257F7C763B09}"/>
               </a:ext>
             </a:extLst>
           </p:cNvPr>
@@ -7630,7 +7630,7 @@
           <p:cNvPr id="13" name="">
             <a:extLst xmlns:a="http://schemas.openxmlformats.org/drawingml/2006/main">
               <a:ext uri="{FF2B5EF4-FFF2-40B4-BE49-F238E27FC236}">
-                <a16:creationId xmlns:a16="http://schemas.microsoft.com/office/drawing/2014/main" id="{2A1E3E41-8931-4494-947E-09F3C745C3C6}"/>
+                <a16:creationId xmlns:a16="http://schemas.microsoft.com/office/drawing/2014/main" id="{8AE62CC0-1071-44FE-831A-6C43A91A93DA}"/>
               </a:ext>
             </a:extLst>
           </p:cNvPr>
@@ -7675,7 +7675,7 @@
           <p:cNvPr id="14" name="">
             <a:extLst xmlns:a="http://schemas.openxmlformats.org/drawingml/2006/main">
               <a:ext uri="{FF2B5EF4-FFF2-40B4-BE49-F238E27FC236}">
-                <a16:creationId xmlns:a16="http://schemas.microsoft.com/office/drawing/2014/main" id="{7CB18DFF-E436-428C-841C-5CC774054B6B}"/>
+                <a16:creationId xmlns:a16="http://schemas.microsoft.com/office/drawing/2014/main" id="{332C2380-FCDC-4863-9983-5DA106F044A1}"/>
               </a:ext>
             </a:extLst>
           </p:cNvPr>
@@ -7720,7 +7720,7 @@
           <p:cNvPr id="15" name="">
             <a:extLst xmlns:a="http://schemas.openxmlformats.org/drawingml/2006/main">
               <a:ext uri="{FF2B5EF4-FFF2-40B4-BE49-F238E27FC236}">
-                <a16:creationId xmlns:a16="http://schemas.microsoft.com/office/drawing/2014/main" id="{AB4499E7-C89E-4817-B3F1-6D6D08E71CF8}"/>
+                <a16:creationId xmlns:a16="http://schemas.microsoft.com/office/drawing/2014/main" id="{44EDBB98-A867-443B-BBCC-A17A606DC1DC}"/>
               </a:ext>
             </a:extLst>
           </p:cNvPr>
@@ -7753,7 +7753,7 @@
           <p:cNvPr id="16" name="">
             <a:extLst xmlns:a="http://schemas.openxmlformats.org/drawingml/2006/main">
               <a:ext uri="{FF2B5EF4-FFF2-40B4-BE49-F238E27FC236}">
-                <a16:creationId xmlns:a16="http://schemas.microsoft.com/office/drawing/2014/main" id="{8FFEBBF0-6BE9-4710-81E3-AD890735D507}"/>
+                <a16:creationId xmlns:a16="http://schemas.microsoft.com/office/drawing/2014/main" id="{3E29F93F-C33C-4E2F-81CE-209F6C3E4622}"/>
               </a:ext>
             </a:extLst>
           </p:cNvPr>
@@ -7798,7 +7798,7 @@
           <p:cNvPr id="17" name="">
             <a:extLst xmlns:a="http://schemas.openxmlformats.org/drawingml/2006/main">
               <a:ext uri="{FF2B5EF4-FFF2-40B4-BE49-F238E27FC236}">
-                <a16:creationId xmlns:a16="http://schemas.microsoft.com/office/drawing/2014/main" id="{54CA7D5D-125B-4434-BD92-E8A6DB46FB9F}"/>
+                <a16:creationId xmlns:a16="http://schemas.microsoft.com/office/drawing/2014/main" id="{C09A8410-D538-46C9-848E-5E23020E5733}"/>
               </a:ext>
             </a:extLst>
           </p:cNvPr>
@@ -7843,7 +7843,7 @@
           <p:cNvPr id="18" name="">
             <a:extLst xmlns:a="http://schemas.openxmlformats.org/drawingml/2006/main">
               <a:ext uri="{FF2B5EF4-FFF2-40B4-BE49-F238E27FC236}">
-                <a16:creationId xmlns:a16="http://schemas.microsoft.com/office/drawing/2014/main" id="{057D1EC0-0DF7-4656-B415-1A68B6A85622}"/>
+                <a16:creationId xmlns:a16="http://schemas.microsoft.com/office/drawing/2014/main" id="{3B032E06-2992-4F29-B7CF-880155076C44}"/>
               </a:ext>
             </a:extLst>
           </p:cNvPr>
@@ -7888,7 +7888,7 @@
           <p:cNvPr id="19" name="">
             <a:extLst xmlns:a="http://schemas.openxmlformats.org/drawingml/2006/main">
               <a:ext uri="{FF2B5EF4-FFF2-40B4-BE49-F238E27FC236}">
-                <a16:creationId xmlns:a16="http://schemas.microsoft.com/office/drawing/2014/main" id="{D22B60E6-7D3B-46AC-912C-1A00306A49A0}"/>
+                <a16:creationId xmlns:a16="http://schemas.microsoft.com/office/drawing/2014/main" id="{F865F5B1-132E-4337-BE02-B36544BBE1D6}"/>
               </a:ext>
             </a:extLst>
           </p:cNvPr>
@@ -7921,7 +7921,7 @@
           <p:cNvPr id="20" name="">
             <a:extLst xmlns:a="http://schemas.openxmlformats.org/drawingml/2006/main">
               <a:ext uri="{FF2B5EF4-FFF2-40B4-BE49-F238E27FC236}">
-                <a16:creationId xmlns:a16="http://schemas.microsoft.com/office/drawing/2014/main" id="{44C41BE9-A779-40E1-B229-EBFDDFA9F44A}"/>
+                <a16:creationId xmlns:a16="http://schemas.microsoft.com/office/drawing/2014/main" id="{AD832165-A702-449D-B502-ADC6E20AE7DD}"/>
               </a:ext>
             </a:extLst>
           </p:cNvPr>
@@ -7966,7 +7966,7 @@
           <p:cNvPr id="21" name="">
             <a:extLst xmlns:a="http://schemas.openxmlformats.org/drawingml/2006/main">
               <a:ext uri="{FF2B5EF4-FFF2-40B4-BE49-F238E27FC236}">
-                <a16:creationId xmlns:a16="http://schemas.microsoft.com/office/drawing/2014/main" id="{E45385EE-39CC-490E-BDFA-FCABA62F9C1F}"/>
+                <a16:creationId xmlns:a16="http://schemas.microsoft.com/office/drawing/2014/main" id="{15EA5E4C-6B3B-481C-9D15-9A4228DC08E4}"/>
               </a:ext>
             </a:extLst>
           </p:cNvPr>
@@ -8011,7 +8011,7 @@
           <p:cNvPr id="22" name="">
             <a:extLst xmlns:a="http://schemas.openxmlformats.org/drawingml/2006/main">
               <a:ext uri="{FF2B5EF4-FFF2-40B4-BE49-F238E27FC236}">
-                <a16:creationId xmlns:a16="http://schemas.microsoft.com/office/drawing/2014/main" id="{4B89E26C-5EB8-46CA-9930-BB54FA0391B7}"/>
+                <a16:creationId xmlns:a16="http://schemas.microsoft.com/office/drawing/2014/main" id="{C2001ACD-5F12-4F5D-B8A9-2E853D7EF19F}"/>
               </a:ext>
             </a:extLst>
           </p:cNvPr>
@@ -8056,7 +8056,7 @@
           <p:cNvPr id="23" name="">
             <a:extLst xmlns:a="http://schemas.openxmlformats.org/drawingml/2006/main">
               <a:ext uri="{FF2B5EF4-FFF2-40B4-BE49-F238E27FC236}">
-                <a16:creationId xmlns:a16="http://schemas.microsoft.com/office/drawing/2014/main" id="{13F78B0A-7857-4F74-A75E-0317397A0AB0}"/>
+                <a16:creationId xmlns:a16="http://schemas.microsoft.com/office/drawing/2014/main" id="{E716ADC4-FE65-4D40-B71A-FD54AE8293C4}"/>
               </a:ext>
             </a:extLst>
           </p:cNvPr>
@@ -8099,7 +8099,7 @@
     </p:spTree>
     <p:extLst>
       <p:ext uri="{BB962C8B-B14F-4D97-AF65-F5344CB8AC3E}">
-        <p14:creationId xmlns:p14="http://schemas.microsoft.com/office/powerpoint/2010/main" val="1499272156"/>
+        <p14:creationId xmlns:p14="http://schemas.microsoft.com/office/powerpoint/2010/main" val="578029670"/>
       </p:ext>
     </p:extLst>
   </p:cSld>
@@ -8130,7 +8130,7 @@
           <p:cNvPr id="24" name="title-5">
             <a:extLst xmlns:a="http://schemas.openxmlformats.org/drawingml/2006/main">
               <a:ext uri="{FF2B5EF4-FFF2-40B4-BE49-F238E27FC236}">
-                <a16:creationId xmlns:a16="http://schemas.microsoft.com/office/drawing/2014/main" id="{B75BD45B-AD79-4D53-B674-F8F2BB2981C2}"/>
+                <a16:creationId xmlns:a16="http://schemas.microsoft.com/office/drawing/2014/main" id="{4146AC0E-81EC-4D32-B230-1A7D74083103}"/>
               </a:ext>
             </a:extLst>
           </p:cNvPr>
@@ -8175,7 +8175,7 @@
           <p:cNvPr id="2" name="source-5">
             <a:extLst xmlns:a="http://schemas.openxmlformats.org/drawingml/2006/main">
               <a:ext uri="{FF2B5EF4-FFF2-40B4-BE49-F238E27FC236}">
-                <a16:creationId xmlns:a16="http://schemas.microsoft.com/office/drawing/2014/main" id="{C585375F-900B-410B-99B0-6B827F69C1D2}"/>
+                <a16:creationId xmlns:a16="http://schemas.microsoft.com/office/drawing/2014/main" id="{6C0B5ED6-A6BA-4CA3-8B67-59417CBF67C6}"/>
               </a:ext>
             </a:extLst>
           </p:cNvPr>
@@ -8220,7 +8220,7 @@
           <p:cNvPr id="3" name="page-5">
             <a:extLst xmlns:a="http://schemas.openxmlformats.org/drawingml/2006/main">
               <a:ext uri="{FF2B5EF4-FFF2-40B4-BE49-F238E27FC236}">
-                <a16:creationId xmlns:a16="http://schemas.microsoft.com/office/drawing/2014/main" id="{8B9330F1-7BA3-46E9-8681-7BE44DE150E2}"/>
+                <a16:creationId xmlns:a16="http://schemas.microsoft.com/office/drawing/2014/main" id="{037ADAFA-E12A-4830-BC99-45D446CEA8B4}"/>
               </a:ext>
             </a:extLst>
           </p:cNvPr>
@@ -8265,7 +8265,7 @@
           <p:cNvPr id="4" name="">
             <a:extLst xmlns:a="http://schemas.openxmlformats.org/drawingml/2006/main">
               <a:ext uri="{FF2B5EF4-FFF2-40B4-BE49-F238E27FC236}">
-                <a16:creationId xmlns:a16="http://schemas.microsoft.com/office/drawing/2014/main" id="{63870E58-12E8-4072-A206-8ED66B9C6B53}"/>
+                <a16:creationId xmlns:a16="http://schemas.microsoft.com/office/drawing/2014/main" id="{70F90DC3-6294-45CF-9BEA-0502D695823F}"/>
               </a:ext>
             </a:extLst>
           </p:cNvPr>
@@ -8310,7 +8310,7 @@
           <p:cNvPr id="5" name="">
             <a:extLst xmlns:a="http://schemas.openxmlformats.org/drawingml/2006/main">
               <a:ext uri="{FF2B5EF4-FFF2-40B4-BE49-F238E27FC236}">
-                <a16:creationId xmlns:a16="http://schemas.microsoft.com/office/drawing/2014/main" id="{A99100CE-EE17-4CE5-AE74-301409817A6D}"/>
+                <a16:creationId xmlns:a16="http://schemas.microsoft.com/office/drawing/2014/main" id="{45D20D5A-5ABE-472F-B528-ECB2F9B4BA26}"/>
               </a:ext>
             </a:extLst>
           </p:cNvPr>
@@ -8355,7 +8355,7 @@
           <p:cNvPr id="6" name="">
             <a:extLst xmlns:a="http://schemas.openxmlformats.org/drawingml/2006/main">
               <a:ext uri="{FF2B5EF4-FFF2-40B4-BE49-F238E27FC236}">
-                <a16:creationId xmlns:a16="http://schemas.microsoft.com/office/drawing/2014/main" id="{7F8349F0-A5B4-4B11-9368-E93C23123B84}"/>
+                <a16:creationId xmlns:a16="http://schemas.microsoft.com/office/drawing/2014/main" id="{525A7992-F41F-42E3-A546-EFE2BACEC307}"/>
               </a:ext>
             </a:extLst>
           </p:cNvPr>
@@ -8400,7 +8400,7 @@
           <p:cNvPr id="7" name="role-row-0">
             <a:extLst xmlns:a="http://schemas.openxmlformats.org/drawingml/2006/main">
               <a:ext uri="{FF2B5EF4-FFF2-40B4-BE49-F238E27FC236}">
-                <a16:creationId xmlns:a16="http://schemas.microsoft.com/office/drawing/2014/main" id="{CE86C427-4AC9-40C5-989C-1FC593F7D136}"/>
+                <a16:creationId xmlns:a16="http://schemas.microsoft.com/office/drawing/2014/main" id="{B380B61B-B000-4845-9AD7-5DC5DBE396DE}"/>
               </a:ext>
             </a:extLst>
           </p:cNvPr>
@@ -8433,7 +8433,7 @@
           <p:cNvPr id="8" name="">
             <a:extLst xmlns:a="http://schemas.openxmlformats.org/drawingml/2006/main">
               <a:ext uri="{FF2B5EF4-FFF2-40B4-BE49-F238E27FC236}">
-                <a16:creationId xmlns:a16="http://schemas.microsoft.com/office/drawing/2014/main" id="{DC800C39-53FC-4B7C-86DE-42EF15C343BB}"/>
+                <a16:creationId xmlns:a16="http://schemas.microsoft.com/office/drawing/2014/main" id="{AE8EA5E5-C2C2-4FEE-BAD8-0247BBC409E0}"/>
               </a:ext>
             </a:extLst>
           </p:cNvPr>
@@ -8478,7 +8478,7 @@
           <p:cNvPr id="9" name="">
             <a:extLst xmlns:a="http://schemas.openxmlformats.org/drawingml/2006/main">
               <a:ext uri="{FF2B5EF4-FFF2-40B4-BE49-F238E27FC236}">
-                <a16:creationId xmlns:a16="http://schemas.microsoft.com/office/drawing/2014/main" id="{D79D8669-3AA0-4492-9CFD-41052A4C32D0}"/>
+                <a16:creationId xmlns:a16="http://schemas.microsoft.com/office/drawing/2014/main" id="{C6A1003D-CD5F-4DC1-B6A0-A0E23C87B22F}"/>
               </a:ext>
             </a:extLst>
           </p:cNvPr>
@@ -8524,7 +8524,7 @@
           <p:cNvPr id="10" name="">
             <a:extLst xmlns:a="http://schemas.openxmlformats.org/drawingml/2006/main">
               <a:ext uri="{FF2B5EF4-FFF2-40B4-BE49-F238E27FC236}">
-                <a16:creationId xmlns:a16="http://schemas.microsoft.com/office/drawing/2014/main" id="{1AE252E8-D953-420B-AEE1-A52C6B5F4759}"/>
+                <a16:creationId xmlns:a16="http://schemas.microsoft.com/office/drawing/2014/main" id="{9E216189-988B-46D6-8EBC-0D5ECFC23BAF}"/>
               </a:ext>
             </a:extLst>
           </p:cNvPr>
@@ -8570,7 +8570,7 @@
           <p:cNvPr id="11" name="role-row-1">
             <a:extLst xmlns:a="http://schemas.openxmlformats.org/drawingml/2006/main">
               <a:ext uri="{FF2B5EF4-FFF2-40B4-BE49-F238E27FC236}">
-                <a16:creationId xmlns:a16="http://schemas.microsoft.com/office/drawing/2014/main" id="{55B0FB66-4769-4187-9785-B4ED9930310D}"/>
+                <a16:creationId xmlns:a16="http://schemas.microsoft.com/office/drawing/2014/main" id="{8AEDE4CB-AFE9-4748-B583-D54F819C9178}"/>
               </a:ext>
             </a:extLst>
           </p:cNvPr>
@@ -8603,7 +8603,7 @@
           <p:cNvPr id="12" name="">
             <a:extLst xmlns:a="http://schemas.openxmlformats.org/drawingml/2006/main">
               <a:ext uri="{FF2B5EF4-FFF2-40B4-BE49-F238E27FC236}">
-                <a16:creationId xmlns:a16="http://schemas.microsoft.com/office/drawing/2014/main" id="{D6F90456-88C3-4528-B742-B24C1E37E9E3}"/>
+                <a16:creationId xmlns:a16="http://schemas.microsoft.com/office/drawing/2014/main" id="{E4ABDABE-C021-477D-8580-A709E58F99A3}"/>
               </a:ext>
             </a:extLst>
           </p:cNvPr>
@@ -8648,7 +8648,7 @@
           <p:cNvPr id="13" name="">
             <a:extLst xmlns:a="http://schemas.openxmlformats.org/drawingml/2006/main">
               <a:ext uri="{FF2B5EF4-FFF2-40B4-BE49-F238E27FC236}">
-                <a16:creationId xmlns:a16="http://schemas.microsoft.com/office/drawing/2014/main" id="{F5A1B15C-075A-414D-8756-2B017200B356}"/>
+                <a16:creationId xmlns:a16="http://schemas.microsoft.com/office/drawing/2014/main" id="{75471EB8-0CFD-466E-8557-706A900EC038}"/>
               </a:ext>
             </a:extLst>
           </p:cNvPr>
@@ -8694,7 +8694,7 @@
           <p:cNvPr id="14" name="">
             <a:extLst xmlns:a="http://schemas.openxmlformats.org/drawingml/2006/main">
               <a:ext uri="{FF2B5EF4-FFF2-40B4-BE49-F238E27FC236}">
-                <a16:creationId xmlns:a16="http://schemas.microsoft.com/office/drawing/2014/main" id="{B9B1442C-3AD6-4A68-A381-2BC6C8311E34}"/>
+                <a16:creationId xmlns:a16="http://schemas.microsoft.com/office/drawing/2014/main" id="{388A1A97-1270-4507-A846-6E98074998E9}"/>
               </a:ext>
             </a:extLst>
           </p:cNvPr>
@@ -8740,7 +8740,7 @@
           <p:cNvPr id="15" name="role-row-2">
             <a:extLst xmlns:a="http://schemas.openxmlformats.org/drawingml/2006/main">
               <a:ext uri="{FF2B5EF4-FFF2-40B4-BE49-F238E27FC236}">
-                <a16:creationId xmlns:a16="http://schemas.microsoft.com/office/drawing/2014/main" id="{9DB43178-26EE-49E1-B573-7771D1902063}"/>
+                <a16:creationId xmlns:a16="http://schemas.microsoft.com/office/drawing/2014/main" id="{DB47385F-1C6A-4024-BDA8-0243FBAFE593}"/>
               </a:ext>
             </a:extLst>
           </p:cNvPr>
@@ -8773,7 +8773,7 @@
           <p:cNvPr id="16" name="">
             <a:extLst xmlns:a="http://schemas.openxmlformats.org/drawingml/2006/main">
               <a:ext uri="{FF2B5EF4-FFF2-40B4-BE49-F238E27FC236}">
-                <a16:creationId xmlns:a16="http://schemas.microsoft.com/office/drawing/2014/main" id="{22406BF1-7567-4FED-A6AA-A99DD92CACBC}"/>
+                <a16:creationId xmlns:a16="http://schemas.microsoft.com/office/drawing/2014/main" id="{FB5FF066-ACFE-4D13-A045-9B9B76411144}"/>
               </a:ext>
             </a:extLst>
           </p:cNvPr>
@@ -8818,7 +8818,7 @@
           <p:cNvPr id="17" name="">
             <a:extLst xmlns:a="http://schemas.openxmlformats.org/drawingml/2006/main">
               <a:ext uri="{FF2B5EF4-FFF2-40B4-BE49-F238E27FC236}">
-                <a16:creationId xmlns:a16="http://schemas.microsoft.com/office/drawing/2014/main" id="{83ECB7C7-4E6A-4969-85B1-431CFF19E231}"/>
+                <a16:creationId xmlns:a16="http://schemas.microsoft.com/office/drawing/2014/main" id="{1B8250E7-7C58-4C0A-BF0F-C306A88F864C}"/>
               </a:ext>
             </a:extLst>
           </p:cNvPr>
@@ -8864,7 +8864,7 @@
           <p:cNvPr id="18" name="">
             <a:extLst xmlns:a="http://schemas.openxmlformats.org/drawingml/2006/main">
               <a:ext uri="{FF2B5EF4-FFF2-40B4-BE49-F238E27FC236}">
-                <a16:creationId xmlns:a16="http://schemas.microsoft.com/office/drawing/2014/main" id="{2F246782-4177-4174-923B-5B3EF0FD2010}"/>
+                <a16:creationId xmlns:a16="http://schemas.microsoft.com/office/drawing/2014/main" id="{D0E7F11A-FA40-4FCE-A3E4-3717EABB355C}"/>
               </a:ext>
             </a:extLst>
           </p:cNvPr>
@@ -8910,7 +8910,7 @@
           <p:cNvPr id="19" name="role-row-3">
             <a:extLst xmlns:a="http://schemas.openxmlformats.org/drawingml/2006/main">
               <a:ext uri="{FF2B5EF4-FFF2-40B4-BE49-F238E27FC236}">
-                <a16:creationId xmlns:a16="http://schemas.microsoft.com/office/drawing/2014/main" id="{1F63A618-72D3-4A04-8C5E-05FD75D8A8D8}"/>
+                <a16:creationId xmlns:a16="http://schemas.microsoft.com/office/drawing/2014/main" id="{D3CFEAA1-FC24-40FB-BC0B-1E4DC3626B73}"/>
               </a:ext>
             </a:extLst>
           </p:cNvPr>
@@ -8943,7 +8943,7 @@
           <p:cNvPr id="20" name="">
             <a:extLst xmlns:a="http://schemas.openxmlformats.org/drawingml/2006/main">
               <a:ext uri="{FF2B5EF4-FFF2-40B4-BE49-F238E27FC236}">
-                <a16:creationId xmlns:a16="http://schemas.microsoft.com/office/drawing/2014/main" id="{C4C6ABA9-355D-4EE3-9C44-7D9480C0ACD3}"/>
+                <a16:creationId xmlns:a16="http://schemas.microsoft.com/office/drawing/2014/main" id="{3E8FB856-77ED-47CF-B3DE-8CDC6F225878}"/>
               </a:ext>
             </a:extLst>
           </p:cNvPr>
@@ -8988,7 +8988,7 @@
           <p:cNvPr id="21" name="">
             <a:extLst xmlns:a="http://schemas.openxmlformats.org/drawingml/2006/main">
               <a:ext uri="{FF2B5EF4-FFF2-40B4-BE49-F238E27FC236}">
-                <a16:creationId xmlns:a16="http://schemas.microsoft.com/office/drawing/2014/main" id="{13DB7D5B-6BEA-4402-B073-CED85247346B}"/>
+                <a16:creationId xmlns:a16="http://schemas.microsoft.com/office/drawing/2014/main" id="{3CCE7F79-FC28-44DA-8E82-E9C9CBE7CFD5}"/>
               </a:ext>
             </a:extLst>
           </p:cNvPr>
@@ -9034,7 +9034,7 @@
           <p:cNvPr id="22" name="">
             <a:extLst xmlns:a="http://schemas.openxmlformats.org/drawingml/2006/main">
               <a:ext uri="{FF2B5EF4-FFF2-40B4-BE49-F238E27FC236}">
-                <a16:creationId xmlns:a16="http://schemas.microsoft.com/office/drawing/2014/main" id="{A625EA4C-27A8-4D4B-92D2-98F2F47B5596}"/>
+                <a16:creationId xmlns:a16="http://schemas.microsoft.com/office/drawing/2014/main" id="{8139E3CD-4750-4010-970C-678E58E1CD7A}"/>
               </a:ext>
             </a:extLst>
           </p:cNvPr>
@@ -9080,7 +9080,7 @@
           <p:cNvPr id="23" name="">
             <a:extLst xmlns:a="http://schemas.openxmlformats.org/drawingml/2006/main">
               <a:ext uri="{FF2B5EF4-FFF2-40B4-BE49-F238E27FC236}">
-                <a16:creationId xmlns:a16="http://schemas.microsoft.com/office/drawing/2014/main" id="{A8D08A14-01AC-412B-943C-A746EE92F419}"/>
+                <a16:creationId xmlns:a16="http://schemas.microsoft.com/office/drawing/2014/main" id="{C0940507-F2A8-4938-B9FA-6C96557E9405}"/>
               </a:ext>
             </a:extLst>
           </p:cNvPr>
@@ -9123,7 +9123,7 @@
     </p:spTree>
     <p:extLst>
       <p:ext uri="{BB962C8B-B14F-4D97-AF65-F5344CB8AC3E}">
-        <p14:creationId xmlns:p14="http://schemas.microsoft.com/office/powerpoint/2010/main" val="1792286043"/>
+        <p14:creationId xmlns:p14="http://schemas.microsoft.com/office/powerpoint/2010/main" val="1500332140"/>
       </p:ext>
     </p:extLst>
   </p:cSld>
@@ -9154,7 +9154,7 @@
           <p:cNvPr id="19" name="title-6">
             <a:extLst xmlns:a="http://schemas.openxmlformats.org/drawingml/2006/main">
               <a:ext uri="{FF2B5EF4-FFF2-40B4-BE49-F238E27FC236}">
-                <a16:creationId xmlns:a16="http://schemas.microsoft.com/office/drawing/2014/main" id="{01391FC0-4368-44F5-9A4A-E112A939386E}"/>
+                <a16:creationId xmlns:a16="http://schemas.microsoft.com/office/drawing/2014/main" id="{45100C28-08E4-4C80-9C68-77C9E293CC37}"/>
               </a:ext>
             </a:extLst>
           </p:cNvPr>
@@ -9199,7 +9199,7 @@
           <p:cNvPr id="2" name="source-6">
             <a:extLst xmlns:a="http://schemas.openxmlformats.org/drawingml/2006/main">
               <a:ext uri="{FF2B5EF4-FFF2-40B4-BE49-F238E27FC236}">
-                <a16:creationId xmlns:a16="http://schemas.microsoft.com/office/drawing/2014/main" id="{85CFA1CE-31FB-4C03-8E14-2C3541DA08D5}"/>
+                <a16:creationId xmlns:a16="http://schemas.microsoft.com/office/drawing/2014/main" id="{7A05C4CF-1B7D-4B64-8D02-47D5D86C1A2A}"/>
               </a:ext>
             </a:extLst>
           </p:cNvPr>
@@ -9244,7 +9244,7 @@
           <p:cNvPr id="3" name="page-6">
             <a:extLst xmlns:a="http://schemas.openxmlformats.org/drawingml/2006/main">
               <a:ext uri="{FF2B5EF4-FFF2-40B4-BE49-F238E27FC236}">
-                <a16:creationId xmlns:a16="http://schemas.microsoft.com/office/drawing/2014/main" id="{91C1BF5D-318C-421E-A2A6-78B8593BC315}"/>
+                <a16:creationId xmlns:a16="http://schemas.microsoft.com/office/drawing/2014/main" id="{DCE6C595-02AF-4EDA-A305-BA8D743F4EE5}"/>
               </a:ext>
             </a:extLst>
           </p:cNvPr>
@@ -9289,7 +9289,7 @@
           <p:cNvPr id="4" name="">
             <a:extLst xmlns:a="http://schemas.openxmlformats.org/drawingml/2006/main">
               <a:ext uri="{FF2B5EF4-FFF2-40B4-BE49-F238E27FC236}">
-                <a16:creationId xmlns:a16="http://schemas.microsoft.com/office/drawing/2014/main" id="{0F4D0500-8823-4FD4-90D1-05A584A6E521}"/>
+                <a16:creationId xmlns:a16="http://schemas.microsoft.com/office/drawing/2014/main" id="{998EBF1A-F68A-470A-A646-37B2B86894A6}"/>
               </a:ext>
             </a:extLst>
           </p:cNvPr>
@@ -9334,7 +9334,7 @@
           <p:cNvPr id="5" name="">
             <a:extLst xmlns:a="http://schemas.openxmlformats.org/drawingml/2006/main">
               <a:ext uri="{FF2B5EF4-FFF2-40B4-BE49-F238E27FC236}">
-                <a16:creationId xmlns:a16="http://schemas.microsoft.com/office/drawing/2014/main" id="{E43B53E4-DC08-4610-9DE6-9E059DADA1B1}"/>
+                <a16:creationId xmlns:a16="http://schemas.microsoft.com/office/drawing/2014/main" id="{E47B20F7-B921-4277-B198-83B4E7871422}"/>
               </a:ext>
             </a:extLst>
           </p:cNvPr>
@@ -9367,7 +9367,7 @@
           <p:cNvPr id="6" name="">
             <a:extLst xmlns:a="http://schemas.openxmlformats.org/drawingml/2006/main">
               <a:ext uri="{FF2B5EF4-FFF2-40B4-BE49-F238E27FC236}">
-                <a16:creationId xmlns:a16="http://schemas.microsoft.com/office/drawing/2014/main" id="{784E455D-A5ED-4361-815D-7979CE253A6D}"/>
+                <a16:creationId xmlns:a16="http://schemas.microsoft.com/office/drawing/2014/main" id="{3FDD7390-D2AC-4D88-8A39-9AD0D3810B21}"/>
               </a:ext>
             </a:extLst>
           </p:cNvPr>
@@ -9400,7 +9400,7 @@
           <p:cNvPr id="7" name="">
             <a:extLst xmlns:a="http://schemas.openxmlformats.org/drawingml/2006/main">
               <a:ext uri="{FF2B5EF4-FFF2-40B4-BE49-F238E27FC236}">
-                <a16:creationId xmlns:a16="http://schemas.microsoft.com/office/drawing/2014/main" id="{CCED6B37-77ED-442B-ADD1-A63E15C2AECD}"/>
+                <a16:creationId xmlns:a16="http://schemas.microsoft.com/office/drawing/2014/main" id="{09CAFEEE-1010-4AF9-ABE9-402F4D92760C}"/>
               </a:ext>
             </a:extLst>
           </p:cNvPr>
@@ -9433,7 +9433,7 @@
           <p:cNvPr id="8" name="">
             <a:extLst xmlns:a="http://schemas.openxmlformats.org/drawingml/2006/main">
               <a:ext uri="{FF2B5EF4-FFF2-40B4-BE49-F238E27FC236}">
-                <a16:creationId xmlns:a16="http://schemas.microsoft.com/office/drawing/2014/main" id="{15BB5736-C557-431D-8E17-2C67BAAF3F26}"/>
+                <a16:creationId xmlns:a16="http://schemas.microsoft.com/office/drawing/2014/main" id="{ABD65AE9-C56A-4AA1-8A44-238FAFEF65AB}"/>
               </a:ext>
             </a:extLst>
           </p:cNvPr>
@@ -9466,7 +9466,7 @@
           <p:cNvPr id="9" name="">
             <a:extLst xmlns:a="http://schemas.openxmlformats.org/drawingml/2006/main">
               <a:ext uri="{FF2B5EF4-FFF2-40B4-BE49-F238E27FC236}">
-                <a16:creationId xmlns:a16="http://schemas.microsoft.com/office/drawing/2014/main" id="{6C1E487D-C93B-4438-86D0-2F8A2D0F4AD8}"/>
+                <a16:creationId xmlns:a16="http://schemas.microsoft.com/office/drawing/2014/main" id="{107363FD-63F8-46F4-A505-A0938A59A906}"/>
               </a:ext>
             </a:extLst>
           </p:cNvPr>
@@ -9499,7 +9499,7 @@
           <p:cNvPr id="10" name="">
             <a:extLst xmlns:a="http://schemas.openxmlformats.org/drawingml/2006/main">
               <a:ext uri="{FF2B5EF4-FFF2-40B4-BE49-F238E27FC236}">
-                <a16:creationId xmlns:a16="http://schemas.microsoft.com/office/drawing/2014/main" id="{D664A1E8-D605-4FA8-856B-A28B358679E3}"/>
+                <a16:creationId xmlns:a16="http://schemas.microsoft.com/office/drawing/2014/main" id="{0792D924-7F09-4D13-A659-33F193A8B352}"/>
               </a:ext>
             </a:extLst>
           </p:cNvPr>
@@ -9544,7 +9544,7 @@
           <p:cNvPr id="11" name="">
             <a:extLst xmlns:a="http://schemas.openxmlformats.org/drawingml/2006/main">
               <a:ext uri="{FF2B5EF4-FFF2-40B4-BE49-F238E27FC236}">
-                <a16:creationId xmlns:a16="http://schemas.microsoft.com/office/drawing/2014/main" id="{E504A6D0-DDAB-46E1-B218-6AB762C9C341}"/>
+                <a16:creationId xmlns:a16="http://schemas.microsoft.com/office/drawing/2014/main" id="{F76AC1C1-0667-4A1C-9049-F1C649219E57}"/>
               </a:ext>
             </a:extLst>
           </p:cNvPr>
@@ -9589,7 +9589,7 @@
           <p:cNvPr id="12" name="">
             <a:extLst xmlns:a="http://schemas.openxmlformats.org/drawingml/2006/main">
               <a:ext uri="{FF2B5EF4-FFF2-40B4-BE49-F238E27FC236}">
-                <a16:creationId xmlns:a16="http://schemas.microsoft.com/office/drawing/2014/main" id="{81E9DF2D-5F1A-4B08-A81A-DF5D300DD379}"/>
+                <a16:creationId xmlns:a16="http://schemas.microsoft.com/office/drawing/2014/main" id="{5A9433C1-5AF9-4954-9957-3BBE36B2C18F}"/>
               </a:ext>
             </a:extLst>
           </p:cNvPr>
@@ -9634,7 +9634,7 @@
           <p:cNvPr id="13" name="">
             <a:extLst xmlns:a="http://schemas.openxmlformats.org/drawingml/2006/main">
               <a:ext uri="{FF2B5EF4-FFF2-40B4-BE49-F238E27FC236}">
-                <a16:creationId xmlns:a16="http://schemas.microsoft.com/office/drawing/2014/main" id="{AA41E86C-ECAD-4B29-BB90-ACFDC3D8A1CB}"/>
+                <a16:creationId xmlns:a16="http://schemas.microsoft.com/office/drawing/2014/main" id="{D9665A96-EBA5-4164-9F54-E648A0186B29}"/>
               </a:ext>
             </a:extLst>
           </p:cNvPr>
@@ -9679,7 +9679,7 @@
           <p:cNvPr id="14" name="">
             <a:extLst xmlns:a="http://schemas.openxmlformats.org/drawingml/2006/main">
               <a:ext uri="{FF2B5EF4-FFF2-40B4-BE49-F238E27FC236}">
-                <a16:creationId xmlns:a16="http://schemas.microsoft.com/office/drawing/2014/main" id="{CD6094D9-2B0B-4F8A-9026-CAF0346241B5}"/>
+                <a16:creationId xmlns:a16="http://schemas.microsoft.com/office/drawing/2014/main" id="{5451B821-033C-4BA5-AFB1-3C3F8A72C729}"/>
               </a:ext>
             </a:extLst>
           </p:cNvPr>
@@ -9724,7 +9724,7 @@
           <p:cNvPr id="15" name="">
             <a:extLst xmlns:a="http://schemas.openxmlformats.org/drawingml/2006/main">
               <a:ext uri="{FF2B5EF4-FFF2-40B4-BE49-F238E27FC236}">
-                <a16:creationId xmlns:a16="http://schemas.microsoft.com/office/drawing/2014/main" id="{A131F387-47CF-4A32-B363-0971A6E9FB85}"/>
+                <a16:creationId xmlns:a16="http://schemas.microsoft.com/office/drawing/2014/main" id="{D4D00DEC-8EAA-4A24-8291-370FD4D646B9}"/>
               </a:ext>
             </a:extLst>
           </p:cNvPr>
@@ -9769,7 +9769,7 @@
           <p:cNvPr id="16" name="">
             <a:extLst xmlns:a="http://schemas.openxmlformats.org/drawingml/2006/main">
               <a:ext uri="{FF2B5EF4-FFF2-40B4-BE49-F238E27FC236}">
-                <a16:creationId xmlns:a16="http://schemas.microsoft.com/office/drawing/2014/main" id="{DBD4BAB3-188C-4773-8975-3057502A0B7B}"/>
+                <a16:creationId xmlns:a16="http://schemas.microsoft.com/office/drawing/2014/main" id="{F70E7183-A1A0-449F-853B-E6DE7910C22D}"/>
               </a:ext>
             </a:extLst>
           </p:cNvPr>
@@ -9814,7 +9814,7 @@
           <p:cNvPr id="17" name="">
             <a:extLst xmlns:a="http://schemas.openxmlformats.org/drawingml/2006/main">
               <a:ext uri="{FF2B5EF4-FFF2-40B4-BE49-F238E27FC236}">
-                <a16:creationId xmlns:a16="http://schemas.microsoft.com/office/drawing/2014/main" id="{378A235C-C345-4697-A2B4-4F790133D435}"/>
+                <a16:creationId xmlns:a16="http://schemas.microsoft.com/office/drawing/2014/main" id="{274BCBAF-C0FD-41C2-A8BF-B352F7A7A45E}"/>
               </a:ext>
             </a:extLst>
           </p:cNvPr>
@@ -9859,7 +9859,7 @@
           <p:cNvPr id="18" name="">
             <a:extLst xmlns:a="http://schemas.openxmlformats.org/drawingml/2006/main">
               <a:ext uri="{FF2B5EF4-FFF2-40B4-BE49-F238E27FC236}">
-                <a16:creationId xmlns:a16="http://schemas.microsoft.com/office/drawing/2014/main" id="{8BEB3BB3-68E2-41B5-B23A-0C67112CD679}"/>
+                <a16:creationId xmlns:a16="http://schemas.microsoft.com/office/drawing/2014/main" id="{4CB22BE5-1C20-49AA-8BC4-A3CE249A88D7}"/>
               </a:ext>
             </a:extLst>
           </p:cNvPr>
@@ -9902,7 +9902,7 @@
     </p:spTree>
     <p:extLst>
       <p:ext uri="{BB962C8B-B14F-4D97-AF65-F5344CB8AC3E}">
-        <p14:creationId xmlns:p14="http://schemas.microsoft.com/office/powerpoint/2010/main" val="1328990712"/>
+        <p14:creationId xmlns:p14="http://schemas.microsoft.com/office/powerpoint/2010/main" val="1232464996"/>
       </p:ext>
     </p:extLst>
   </p:cSld>
@@ -9933,7 +9933,7 @@
           <p:cNvPr id="12" name="title-7">
             <a:extLst xmlns:a="http://schemas.openxmlformats.org/drawingml/2006/main">
               <a:ext uri="{FF2B5EF4-FFF2-40B4-BE49-F238E27FC236}">
-                <a16:creationId xmlns:a16="http://schemas.microsoft.com/office/drawing/2014/main" id="{5B228F7F-31C0-419A-B60D-5A97E4BF051F}"/>
+                <a16:creationId xmlns:a16="http://schemas.microsoft.com/office/drawing/2014/main" id="{577BCCB1-102E-4711-A93D-716C0B613FEC}"/>
               </a:ext>
             </a:extLst>
           </p:cNvPr>
@@ -9978,7 +9978,7 @@
           <p:cNvPr id="2" name="source-7">
             <a:extLst xmlns:a="http://schemas.openxmlformats.org/drawingml/2006/main">
               <a:ext uri="{FF2B5EF4-FFF2-40B4-BE49-F238E27FC236}">
-                <a16:creationId xmlns:a16="http://schemas.microsoft.com/office/drawing/2014/main" id="{9534A970-FEF8-4499-9FBF-4A258AD2CC04}"/>
+                <a16:creationId xmlns:a16="http://schemas.microsoft.com/office/drawing/2014/main" id="{8479A70E-1B33-4009-834A-A6A88495D3B0}"/>
               </a:ext>
             </a:extLst>
           </p:cNvPr>
@@ -10023,7 +10023,7 @@
           <p:cNvPr id="3" name="page-7">
             <a:extLst xmlns:a="http://schemas.openxmlformats.org/drawingml/2006/main">
               <a:ext uri="{FF2B5EF4-FFF2-40B4-BE49-F238E27FC236}">
-                <a16:creationId xmlns:a16="http://schemas.microsoft.com/office/drawing/2014/main" id="{26B0BD6D-77F5-4AD2-96C0-D26544EC3379}"/>
+                <a16:creationId xmlns:a16="http://schemas.microsoft.com/office/drawing/2014/main" id="{EE08248F-E626-4B1E-BDF8-1D54BFEC3F04}"/>
               </a:ext>
             </a:extLst>
           </p:cNvPr>
@@ -10068,7 +10068,7 @@
           <p:cNvPr id="4" name="">
             <a:extLst xmlns:a="http://schemas.openxmlformats.org/drawingml/2006/main">
               <a:ext uri="{FF2B5EF4-FFF2-40B4-BE49-F238E27FC236}">
-                <a16:creationId xmlns:a16="http://schemas.microsoft.com/office/drawing/2014/main" id="{56C40C6F-BE93-4722-8912-D18C5725A3A9}"/>
+                <a16:creationId xmlns:a16="http://schemas.microsoft.com/office/drawing/2014/main" id="{4629515C-C9BC-4B76-A7A2-8E204D809D40}"/>
               </a:ext>
             </a:extLst>
           </p:cNvPr>
@@ -10113,7 +10113,7 @@
           <p:cNvPr id="5" name="">
             <a:extLst xmlns:a="http://schemas.openxmlformats.org/drawingml/2006/main">
               <a:ext uri="{FF2B5EF4-FFF2-40B4-BE49-F238E27FC236}">
-                <a16:creationId xmlns:a16="http://schemas.microsoft.com/office/drawing/2014/main" id="{61CC94AF-C024-4FD3-AF4E-5D9FD4D91777}"/>
+                <a16:creationId xmlns:a16="http://schemas.microsoft.com/office/drawing/2014/main" id="{B74705F4-4798-4F72-BD0C-802EDE2C1F14}"/>
               </a:ext>
             </a:extLst>
           </p:cNvPr>
@@ -10158,7 +10158,7 @@
           <p:cNvPr id="6" name="survived">
             <a:extLst xmlns:a="http://schemas.openxmlformats.org/drawingml/2006/main">
               <a:ext uri="{FF2B5EF4-FFF2-40B4-BE49-F238E27FC236}">
-                <a16:creationId xmlns:a16="http://schemas.microsoft.com/office/drawing/2014/main" id="{E42F838D-DB85-474F-A7E1-E15B1FF58AA2}"/>
+                <a16:creationId xmlns:a16="http://schemas.microsoft.com/office/drawing/2014/main" id="{4A811F26-830B-48AE-8A16-65C11E2F9D70}"/>
               </a:ext>
             </a:extLst>
           </p:cNvPr>
@@ -10193,7 +10193,7 @@
           <p:cNvPr id="7" name="changed">
             <a:extLst xmlns:a="http://schemas.openxmlformats.org/drawingml/2006/main">
               <a:ext uri="{FF2B5EF4-FFF2-40B4-BE49-F238E27FC236}">
-                <a16:creationId xmlns:a16="http://schemas.microsoft.com/office/drawing/2014/main" id="{554DCEED-7B72-4E76-B2CE-B26A70E812C1}"/>
+                <a16:creationId xmlns:a16="http://schemas.microsoft.com/office/drawing/2014/main" id="{615F98E7-916B-4AC7-97CD-9FD5162201C0}"/>
               </a:ext>
             </a:extLst>
           </p:cNvPr>
@@ -10228,7 +10228,7 @@
           <p:cNvPr id="8" name="">
             <a:extLst xmlns:a="http://schemas.openxmlformats.org/drawingml/2006/main">
               <a:ext uri="{FF2B5EF4-FFF2-40B4-BE49-F238E27FC236}">
-                <a16:creationId xmlns:a16="http://schemas.microsoft.com/office/drawing/2014/main" id="{DEEF90AE-013F-4E05-A1B2-65BDFB6119D9}"/>
+                <a16:creationId xmlns:a16="http://schemas.microsoft.com/office/drawing/2014/main" id="{2918E76B-0A2F-435F-8C5D-93C84B03F2D7}"/>
               </a:ext>
             </a:extLst>
           </p:cNvPr>
@@ -10276,7 +10276,7 @@
           <p:cNvPr id="9" name="">
             <a:extLst xmlns:a="http://schemas.openxmlformats.org/drawingml/2006/main">
               <a:ext uri="{FF2B5EF4-FFF2-40B4-BE49-F238E27FC236}">
-                <a16:creationId xmlns:a16="http://schemas.microsoft.com/office/drawing/2014/main" id="{5BDF4FE9-63A1-4C8F-858A-8BD93EF44788}"/>
+                <a16:creationId xmlns:a16="http://schemas.microsoft.com/office/drawing/2014/main" id="{F4467747-654D-4EB9-9AFF-FDF51202CA0A}"/>
               </a:ext>
             </a:extLst>
           </p:cNvPr>
@@ -10324,7 +10324,7 @@
           <p:cNvPr id="10" name="">
             <a:extLst xmlns:a="http://schemas.openxmlformats.org/drawingml/2006/main">
               <a:ext uri="{FF2B5EF4-FFF2-40B4-BE49-F238E27FC236}">
-                <a16:creationId xmlns:a16="http://schemas.microsoft.com/office/drawing/2014/main" id="{642077D2-E90D-4D6B-B939-53C5E968F901}"/>
+                <a16:creationId xmlns:a16="http://schemas.microsoft.com/office/drawing/2014/main" id="{A0969DE7-495F-4BCF-8CB1-90C90AD4532D}"/>
               </a:ext>
             </a:extLst>
           </p:cNvPr>
@@ -10369,7 +10369,7 @@
           <p:cNvPr id="11" name="">
             <a:extLst xmlns:a="http://schemas.openxmlformats.org/drawingml/2006/main">
               <a:ext uri="{FF2B5EF4-FFF2-40B4-BE49-F238E27FC236}">
-                <a16:creationId xmlns:a16="http://schemas.microsoft.com/office/drawing/2014/main" id="{2AF8302F-13CC-44CF-B4FB-483B5CDA6072}"/>
+                <a16:creationId xmlns:a16="http://schemas.microsoft.com/office/drawing/2014/main" id="{30F89A7C-7BF6-4F64-96E6-D9481FC2652F}"/>
               </a:ext>
             </a:extLst>
           </p:cNvPr>
@@ -10381,7 +10381,7 @@
         <p:spPr>
           <a:xfrm xmlns:a="http://schemas.openxmlformats.org/drawingml/2006/main">
             <a:off x="6267450" y="5753100"/>
-            <a:ext cx="2857500" cy="266700"/>
+            <a:ext cx="3143250" cy="266700"/>
           </a:xfrm>
           <a:prstGeom xmlns:a="http://schemas.openxmlformats.org/drawingml/2006/main" prst="rect">
             <a:avLst/>
@@ -10404,7 +10404,7 @@
               </a:defRPr>
             </a:pPr>
             <a:r>
-              <a:t>2026 critical edition</a:t>
+              <a:t>2026 standalone dissertation</a:t>
             </a:r>
           </a:p>
         </p:txBody>
@@ -10412,7 +10412,7 @@
     </p:spTree>
     <p:extLst>
       <p:ext uri="{BB962C8B-B14F-4D97-AF65-F5344CB8AC3E}">
-        <p14:creationId xmlns:p14="http://schemas.microsoft.com/office/powerpoint/2010/main" val="1182006726"/>
+        <p14:creationId xmlns:p14="http://schemas.microsoft.com/office/powerpoint/2010/main" val="1367066498"/>
       </p:ext>
     </p:extLst>
   </p:cSld>
@@ -10443,7 +10443,7 @@
           <p:cNvPr id="18" name="title-8">
             <a:extLst xmlns:a="http://schemas.openxmlformats.org/drawingml/2006/main">
               <a:ext uri="{FF2B5EF4-FFF2-40B4-BE49-F238E27FC236}">
-                <a16:creationId xmlns:a16="http://schemas.microsoft.com/office/drawing/2014/main" id="{4F2594C7-E4AA-4FEC-ADFE-C1F86B234F4B}"/>
+                <a16:creationId xmlns:a16="http://schemas.microsoft.com/office/drawing/2014/main" id="{D6FB4A0A-19F3-46EA-B366-C404DE781CB2}"/>
               </a:ext>
             </a:extLst>
           </p:cNvPr>
@@ -10488,7 +10488,7 @@
           <p:cNvPr id="2" name="source-8">
             <a:extLst xmlns:a="http://schemas.openxmlformats.org/drawingml/2006/main">
               <a:ext uri="{FF2B5EF4-FFF2-40B4-BE49-F238E27FC236}">
-                <a16:creationId xmlns:a16="http://schemas.microsoft.com/office/drawing/2014/main" id="{398120A3-2ED9-4DC4-90E3-FD3E8A9B6502}"/>
+                <a16:creationId xmlns:a16="http://schemas.microsoft.com/office/drawing/2014/main" id="{8CD26517-C2E4-4671-AC92-7AACCDD1AE74}"/>
               </a:ext>
             </a:extLst>
           </p:cNvPr>
@@ -10533,7 +10533,7 @@
           <p:cNvPr id="3" name="page-8">
             <a:extLst xmlns:a="http://schemas.openxmlformats.org/drawingml/2006/main">
               <a:ext uri="{FF2B5EF4-FFF2-40B4-BE49-F238E27FC236}">
-                <a16:creationId xmlns:a16="http://schemas.microsoft.com/office/drawing/2014/main" id="{1DE51106-9B56-4E97-9A01-14F67ADF499F}"/>
+                <a16:creationId xmlns:a16="http://schemas.microsoft.com/office/drawing/2014/main" id="{0B843FFF-7EF6-4632-A45D-A78467EF3E32}"/>
               </a:ext>
             </a:extLst>
           </p:cNvPr>
@@ -10578,7 +10578,7 @@
           <p:cNvPr id="4" name="">
             <a:extLst xmlns:a="http://schemas.openxmlformats.org/drawingml/2006/main">
               <a:ext uri="{FF2B5EF4-FFF2-40B4-BE49-F238E27FC236}">
-                <a16:creationId xmlns:a16="http://schemas.microsoft.com/office/drawing/2014/main" id="{2369FBAF-D8BF-4D4F-A50F-0CE78DCA1A33}"/>
+                <a16:creationId xmlns:a16="http://schemas.microsoft.com/office/drawing/2014/main" id="{21781102-54D9-4816-8918-632712C726E3}"/>
               </a:ext>
             </a:extLst>
           </p:cNvPr>
@@ -10623,7 +10623,7 @@
           <p:cNvPr id="5" name="">
             <a:extLst xmlns:a="http://schemas.openxmlformats.org/drawingml/2006/main">
               <a:ext uri="{FF2B5EF4-FFF2-40B4-BE49-F238E27FC236}">
-                <a16:creationId xmlns:a16="http://schemas.microsoft.com/office/drawing/2014/main" id="{8ACC1C66-B5F3-4866-A451-53C0E7612AEA}"/>
+                <a16:creationId xmlns:a16="http://schemas.microsoft.com/office/drawing/2014/main" id="{BBF844F6-9586-4DD6-9154-3D44E6594A42}"/>
               </a:ext>
             </a:extLst>
           </p:cNvPr>
@@ -10656,7 +10656,7 @@
           <p:cNvPr id="6" name="">
             <a:extLst xmlns:a="http://schemas.openxmlformats.org/drawingml/2006/main">
               <a:ext uri="{FF2B5EF4-FFF2-40B4-BE49-F238E27FC236}">
-                <a16:creationId xmlns:a16="http://schemas.microsoft.com/office/drawing/2014/main" id="{021E42AD-3C2F-4C5C-A5EF-16A9051966E6}"/>
+                <a16:creationId xmlns:a16="http://schemas.microsoft.com/office/drawing/2014/main" id="{95A265FB-35AD-4BED-935C-751FC5624AE4}"/>
               </a:ext>
             </a:extLst>
           </p:cNvPr>
@@ -10701,7 +10701,7 @@
           <p:cNvPr id="7" name="">
             <a:extLst xmlns:a="http://schemas.openxmlformats.org/drawingml/2006/main">
               <a:ext uri="{FF2B5EF4-FFF2-40B4-BE49-F238E27FC236}">
-                <a16:creationId xmlns:a16="http://schemas.microsoft.com/office/drawing/2014/main" id="{9CD959B9-FA63-4EDC-B85B-A7CA2E107F58}"/>
+                <a16:creationId xmlns:a16="http://schemas.microsoft.com/office/drawing/2014/main" id="{EC5E0ACA-9A3F-4E4C-930A-8F17CF92EBEE}"/>
               </a:ext>
             </a:extLst>
           </p:cNvPr>
@@ -10746,7 +10746,7 @@
           <p:cNvPr id="8" name="">
             <a:extLst xmlns:a="http://schemas.openxmlformats.org/drawingml/2006/main">
               <a:ext uri="{FF2B5EF4-FFF2-40B4-BE49-F238E27FC236}">
-                <a16:creationId xmlns:a16="http://schemas.microsoft.com/office/drawing/2014/main" id="{DF2291C9-5CB6-49A8-8CA6-6C404F4F25E4}"/>
+                <a16:creationId xmlns:a16="http://schemas.microsoft.com/office/drawing/2014/main" id="{E84E8990-323D-48AF-972C-2C2BE42CAD25}"/>
               </a:ext>
             </a:extLst>
           </p:cNvPr>
@@ -10779,7 +10779,7 @@
           <p:cNvPr id="9" name="">
             <a:extLst xmlns:a="http://schemas.openxmlformats.org/drawingml/2006/main">
               <a:ext uri="{FF2B5EF4-FFF2-40B4-BE49-F238E27FC236}">
-                <a16:creationId xmlns:a16="http://schemas.microsoft.com/office/drawing/2014/main" id="{D3F9ABA8-9CA0-4127-B8DA-939455267D8F}"/>
+                <a16:creationId xmlns:a16="http://schemas.microsoft.com/office/drawing/2014/main" id="{595818E9-77A9-4C07-8C01-995E80AC3756}"/>
               </a:ext>
             </a:extLst>
           </p:cNvPr>
@@ -10824,7 +10824,7 @@
           <p:cNvPr id="10" name="">
             <a:extLst xmlns:a="http://schemas.openxmlformats.org/drawingml/2006/main">
               <a:ext uri="{FF2B5EF4-FFF2-40B4-BE49-F238E27FC236}">
-                <a16:creationId xmlns:a16="http://schemas.microsoft.com/office/drawing/2014/main" id="{6E37F4FF-787B-458C-B4DE-24A354ADCAF5}"/>
+                <a16:creationId xmlns:a16="http://schemas.microsoft.com/office/drawing/2014/main" id="{262B5580-1FC4-4B58-85BD-52CC8B899DC3}"/>
               </a:ext>
             </a:extLst>
           </p:cNvPr>
@@ -10869,7 +10869,7 @@
           <p:cNvPr id="11" name="">
             <a:extLst xmlns:a="http://schemas.openxmlformats.org/drawingml/2006/main">
               <a:ext uri="{FF2B5EF4-FFF2-40B4-BE49-F238E27FC236}">
-                <a16:creationId xmlns:a16="http://schemas.microsoft.com/office/drawing/2014/main" id="{9DF5C91D-A899-498A-90BF-927C25F6C933}"/>
+                <a16:creationId xmlns:a16="http://schemas.microsoft.com/office/drawing/2014/main" id="{8CE53C89-D566-462B-81CD-B171167A6701}"/>
               </a:ext>
             </a:extLst>
           </p:cNvPr>
@@ -10902,7 +10902,7 @@
           <p:cNvPr id="12" name="">
             <a:extLst xmlns:a="http://schemas.openxmlformats.org/drawingml/2006/main">
               <a:ext uri="{FF2B5EF4-FFF2-40B4-BE49-F238E27FC236}">
-                <a16:creationId xmlns:a16="http://schemas.microsoft.com/office/drawing/2014/main" id="{8CA79C38-4337-48E5-8EE9-4870B84B32D0}"/>
+                <a16:creationId xmlns:a16="http://schemas.microsoft.com/office/drawing/2014/main" id="{A115A9E9-C542-4582-9AA0-D669B6B4F980}"/>
               </a:ext>
             </a:extLst>
           </p:cNvPr>
@@ -10947,7 +10947,7 @@
           <p:cNvPr id="13" name="">
             <a:extLst xmlns:a="http://schemas.openxmlformats.org/drawingml/2006/main">
               <a:ext uri="{FF2B5EF4-FFF2-40B4-BE49-F238E27FC236}">
-                <a16:creationId xmlns:a16="http://schemas.microsoft.com/office/drawing/2014/main" id="{369E4AD8-3CB8-4BAC-82B4-128E0B0F7A24}"/>
+                <a16:creationId xmlns:a16="http://schemas.microsoft.com/office/drawing/2014/main" id="{80C4171C-247C-4FBA-ABDB-F5C59C7569AF}"/>
               </a:ext>
             </a:extLst>
           </p:cNvPr>
@@ -10992,7 +10992,7 @@
           <p:cNvPr id="14" name="">
             <a:extLst xmlns:a="http://schemas.openxmlformats.org/drawingml/2006/main">
               <a:ext uri="{FF2B5EF4-FFF2-40B4-BE49-F238E27FC236}">
-                <a16:creationId xmlns:a16="http://schemas.microsoft.com/office/drawing/2014/main" id="{1BBE9C77-9F7D-4BC0-8150-0A5BB38ABF35}"/>
+                <a16:creationId xmlns:a16="http://schemas.microsoft.com/office/drawing/2014/main" id="{A5FDCA1D-85C0-45F2-89E0-FE861A0C73F7}"/>
               </a:ext>
             </a:extLst>
           </p:cNvPr>
@@ -11025,7 +11025,7 @@
           <p:cNvPr id="15" name="">
             <a:extLst xmlns:a="http://schemas.openxmlformats.org/drawingml/2006/main">
               <a:ext uri="{FF2B5EF4-FFF2-40B4-BE49-F238E27FC236}">
-                <a16:creationId xmlns:a16="http://schemas.microsoft.com/office/drawing/2014/main" id="{EAB8581F-1150-440B-9610-40232B3BD350}"/>
+                <a16:creationId xmlns:a16="http://schemas.microsoft.com/office/drawing/2014/main" id="{A8BA7779-5DF1-45AA-88F2-ED288397E915}"/>
               </a:ext>
             </a:extLst>
           </p:cNvPr>
@@ -11070,7 +11070,7 @@
           <p:cNvPr id="16" name="">
             <a:extLst xmlns:a="http://schemas.openxmlformats.org/drawingml/2006/main">
               <a:ext uri="{FF2B5EF4-FFF2-40B4-BE49-F238E27FC236}">
-                <a16:creationId xmlns:a16="http://schemas.microsoft.com/office/drawing/2014/main" id="{362B4057-2C38-4CA4-814F-9862ACC4FFDC}"/>
+                <a16:creationId xmlns:a16="http://schemas.microsoft.com/office/drawing/2014/main" id="{1EDFDD88-7E23-4220-9426-61726C78A7C8}"/>
               </a:ext>
             </a:extLst>
           </p:cNvPr>
@@ -11115,7 +11115,7 @@
           <p:cNvPr id="17" name="">
             <a:extLst xmlns:a="http://schemas.openxmlformats.org/drawingml/2006/main">
               <a:ext uri="{FF2B5EF4-FFF2-40B4-BE49-F238E27FC236}">
-                <a16:creationId xmlns:a16="http://schemas.microsoft.com/office/drawing/2014/main" id="{357E1312-01E4-43FF-84EB-EC6695B0810E}"/>
+                <a16:creationId xmlns:a16="http://schemas.microsoft.com/office/drawing/2014/main" id="{5D7E1CD0-6F1C-4AEF-8D09-0F1A19B80013}"/>
               </a:ext>
             </a:extLst>
           </p:cNvPr>
@@ -11158,7 +11158,7 @@
     </p:spTree>
     <p:extLst>
       <p:ext uri="{BB962C8B-B14F-4D97-AF65-F5344CB8AC3E}">
-        <p14:creationId xmlns:p14="http://schemas.microsoft.com/office/powerpoint/2010/main" val="734710084"/>
+        <p14:creationId xmlns:p14="http://schemas.microsoft.com/office/powerpoint/2010/main" val="5945392"/>
       </p:ext>
     </p:extLst>
   </p:cSld>
@@ -11189,7 +11189,7 @@
           <p:cNvPr id="8" name="title-9">
             <a:extLst xmlns:a="http://schemas.openxmlformats.org/drawingml/2006/main">
               <a:ext uri="{FF2B5EF4-FFF2-40B4-BE49-F238E27FC236}">
-                <a16:creationId xmlns:a16="http://schemas.microsoft.com/office/drawing/2014/main" id="{5C8D9DB0-8DD6-4B21-B4DB-1946FB0AE5B6}"/>
+                <a16:creationId xmlns:a16="http://schemas.microsoft.com/office/drawing/2014/main" id="{95F9162E-208C-4891-9C19-5E4D0EE6425D}"/>
               </a:ext>
             </a:extLst>
           </p:cNvPr>
@@ -11234,7 +11234,7 @@
           <p:cNvPr id="2" name="source-9">
             <a:extLst xmlns:a="http://schemas.openxmlformats.org/drawingml/2006/main">
               <a:ext uri="{FF2B5EF4-FFF2-40B4-BE49-F238E27FC236}">
-                <a16:creationId xmlns:a16="http://schemas.microsoft.com/office/drawing/2014/main" id="{ABDB94D2-29DA-4CA2-8179-FB5428DDA0FE}"/>
+                <a16:creationId xmlns:a16="http://schemas.microsoft.com/office/drawing/2014/main" id="{FB58E03A-347A-4F0E-816B-72B61AB2301D}"/>
               </a:ext>
             </a:extLst>
           </p:cNvPr>
@@ -11279,7 +11279,7 @@
           <p:cNvPr id="3" name="page-9">
             <a:extLst xmlns:a="http://schemas.openxmlformats.org/drawingml/2006/main">
               <a:ext uri="{FF2B5EF4-FFF2-40B4-BE49-F238E27FC236}">
-                <a16:creationId xmlns:a16="http://schemas.microsoft.com/office/drawing/2014/main" id="{76C656A4-11D9-4F95-80A5-369CCE085BC0}"/>
+                <a16:creationId xmlns:a16="http://schemas.microsoft.com/office/drawing/2014/main" id="{4C99680F-0639-4226-8C1C-62A5679752F0}"/>
               </a:ext>
             </a:extLst>
           </p:cNvPr>
@@ -11319,9 +11319,144 @@
           </a:p>
         </p:txBody>
       </p:sp>
+      <p:sp>
+        <p:nvSpPr>
+          <p:cNvPr id="4" name="">
+            <a:extLst xmlns:a="http://schemas.openxmlformats.org/drawingml/2006/main">
+              <a:ext uri="{FF2B5EF4-FFF2-40B4-BE49-F238E27FC236}">
+                <a16:creationId xmlns:a16="http://schemas.microsoft.com/office/drawing/2014/main" id="{645115E9-F814-4B66-9D9C-CC2332FBA306}"/>
+              </a:ext>
+            </a:extLst>
+          </p:cNvPr>
+          <p:cNvSpPr>
+            <a:spLocks xmlns:a="http://schemas.openxmlformats.org/drawingml/2006/main" noGrp="1"/>
+          </p:cNvSpPr>
+          <p:nvPr/>
+        </p:nvSpPr>
+        <p:spPr>
+          <a:xfrm xmlns:a="http://schemas.openxmlformats.org/drawingml/2006/main">
+            <a:off x="7905750" y="1752600"/>
+            <a:ext cx="2952750" cy="1047750"/>
+          </a:xfrm>
+          <a:prstGeom xmlns:a="http://schemas.openxmlformats.org/drawingml/2006/main" prst="rect">
+            <a:avLst/>
+          </a:prstGeom>
+        </p:spPr>
+        <p:txBody>
+          <a:bodyPr xmlns:a="http://schemas.openxmlformats.org/drawingml/2006/main" wrap="square" lIns="0" tIns="0" rIns="0" bIns="0" anchor="t">
+            <a:noAutofit/>
+          </a:bodyPr>
+          <a:lstStyle xmlns:a="http://schemas.openxmlformats.org/drawingml/2006/main"/>
+          <a:p xmlns:a="http://schemas.openxmlformats.org/drawingml/2006/main">
+            <a:pPr algn="l">
+              <a:defRPr sz="5400" b="1">
+                <a:solidFill>
+                  <a:srgbClr val="0F766E"/>
+                </a:solidFill>
+                <a:latin typeface="Helvetica Neue"/>
+                <a:ea typeface="Helvetica Neue"/>
+                <a:cs typeface="Helvetica Neue"/>
+              </a:defRPr>
+            </a:pPr>
+            <a:r>
+              <a:t>2.3×</a:t>
+            </a:r>
+          </a:p>
+        </p:txBody>
+      </p:sp>
+      <p:sp>
+        <p:nvSpPr>
+          <p:cNvPr id="5" name="">
+            <a:extLst xmlns:a="http://schemas.openxmlformats.org/drawingml/2006/main">
+              <a:ext uri="{FF2B5EF4-FFF2-40B4-BE49-F238E27FC236}">
+                <a16:creationId xmlns:a16="http://schemas.microsoft.com/office/drawing/2014/main" id="{721D1E43-5431-4D7B-A558-0BFB0222129E}"/>
+              </a:ext>
+            </a:extLst>
+          </p:cNvPr>
+          <p:cNvSpPr>
+            <a:spLocks xmlns:a="http://schemas.openxmlformats.org/drawingml/2006/main" noGrp="1"/>
+          </p:cNvSpPr>
+          <p:nvPr/>
+        </p:nvSpPr>
+        <p:spPr>
+          <a:xfrm xmlns:a="http://schemas.openxmlformats.org/drawingml/2006/main">
+            <a:off x="7905750" y="2895600"/>
+            <a:ext cx="3143250" cy="1066800"/>
+          </a:xfrm>
+          <a:prstGeom xmlns:a="http://schemas.openxmlformats.org/drawingml/2006/main" prst="rect">
+            <a:avLst/>
+          </a:prstGeom>
+        </p:spPr>
+        <p:txBody>
+          <a:bodyPr xmlns:a="http://schemas.openxmlformats.org/drawingml/2006/main" wrap="square" lIns="0" tIns="0" rIns="0" bIns="0" anchor="t">
+            <a:noAutofit/>
+          </a:bodyPr>
+          <a:lstStyle xmlns:a="http://schemas.openxmlformats.org/drawingml/2006/main"/>
+          <a:p xmlns:a="http://schemas.openxmlformats.org/drawingml/2006/main">
+            <a:pPr algn="l">
+              <a:defRPr sz="1875" b="0">
+                <a:solidFill>
+                  <a:srgbClr val="0F172A"/>
+                </a:solidFill>
+                <a:latin typeface="Helvetica Neue"/>
+                <a:ea typeface="Helvetica Neue"/>
+                <a:cs typeface="Helvetica Neue"/>
+              </a:defRPr>
+            </a:pPr>
+            <a:r>
+              <a:t>more nationally significant incidents handled than the previous year</a:t>
+            </a:r>
+          </a:p>
+        </p:txBody>
+      </p:sp>
+      <p:sp>
+        <p:nvSpPr>
+          <p:cNvPr id="6" name="">
+            <a:extLst xmlns:a="http://schemas.openxmlformats.org/drawingml/2006/main">
+              <a:ext uri="{FF2B5EF4-FFF2-40B4-BE49-F238E27FC236}">
+                <a16:creationId xmlns:a16="http://schemas.microsoft.com/office/drawing/2014/main" id="{96E64030-5D51-4174-9753-60CC230E5088}"/>
+              </a:ext>
+            </a:extLst>
+          </p:cNvPr>
+          <p:cNvSpPr>
+            <a:spLocks xmlns:a="http://schemas.openxmlformats.org/drawingml/2006/main" noGrp="1"/>
+          </p:cNvSpPr>
+          <p:nvPr/>
+        </p:nvSpPr>
+        <p:spPr>
+          <a:xfrm xmlns:a="http://schemas.openxmlformats.org/drawingml/2006/main">
+            <a:off x="7905750" y="4400550"/>
+            <a:ext cx="3333750" cy="1200150"/>
+          </a:xfrm>
+          <a:prstGeom xmlns:a="http://schemas.openxmlformats.org/drawingml/2006/main" prst="rect">
+            <a:avLst/>
+          </a:prstGeom>
+        </p:spPr>
+        <p:txBody>
+          <a:bodyPr xmlns:a="http://schemas.openxmlformats.org/drawingml/2006/main" wrap="square" lIns="0" tIns="0" rIns="0" bIns="0" anchor="t">
+            <a:noAutofit/>
+          </a:bodyPr>
+          <a:lstStyle xmlns:a="http://schemas.openxmlformats.org/drawingml/2006/main"/>
+          <a:p xmlns:a="http://schemas.openxmlformats.org/drawingml/2006/main">
+            <a:pPr algn="l">
+              <a:defRPr sz="1575" b="0">
+                <a:solidFill>
+                  <a:srgbClr val="475569"/>
+                </a:solidFill>
+                <a:latin typeface="Helvetica Neue"/>
+                <a:ea typeface="Helvetica Neue"/>
+                <a:cs typeface="Helvetica Neue"/>
+              </a:defRPr>
+            </a:pPr>
+            <a:r>
+              <a:t>Pressure increased—but the NCSC also states that many more attacks fail than succeed, and prepared organisations recover better.</a:t>
+            </a:r>
+          </a:p>
+        </p:txBody>
+      </p:sp>
       <p:graphicFrame>
         <p:nvGraphicFramePr>
-          <p:cNvPr id="11" name="Chart"/>
+          <p:cNvPr id="14" name="Chart"/>
           <p:cNvGraphicFramePr/>
           <p:nvPr/>
         </p:nvGraphicFramePr>
@@ -11331,149 +11466,14 @@
         </p:xfrm>
         <a:graphic xmlns:a="http://schemas.openxmlformats.org/drawingml/2006/main">
           <a:graphicData uri="http://schemas.openxmlformats.org/drawingml/2006/chart">
-            <c:chart xmlns:r="http://schemas.openxmlformats.org/officeDocument/2006/relationships" xmlns:c="http://schemas.openxmlformats.org/drawingml/2006/chart" r:id="Rc1939d4acd3a4976"/>
+            <c:chart xmlns:r="http://schemas.openxmlformats.org/officeDocument/2006/relationships" xmlns:c="http://schemas.openxmlformats.org/drawingml/2006/chart" r:id="R0d9cf33346414b0b"/>
           </a:graphicData>
         </a:graphic>
       </p:graphicFrame>
-      <p:sp>
-        <p:nvSpPr>
-          <p:cNvPr id="5" name="">
-            <a:extLst xmlns:a="http://schemas.openxmlformats.org/drawingml/2006/main">
-              <a:ext uri="{FF2B5EF4-FFF2-40B4-BE49-F238E27FC236}">
-                <a16:creationId xmlns:a16="http://schemas.microsoft.com/office/drawing/2014/main" id="{ED0AFA37-0388-43D6-ADC5-8B22D5B8BD62}"/>
-              </a:ext>
-            </a:extLst>
-          </p:cNvPr>
-          <p:cNvSpPr>
-            <a:spLocks xmlns:a="http://schemas.openxmlformats.org/drawingml/2006/main" noGrp="1"/>
-          </p:cNvSpPr>
-          <p:nvPr/>
-        </p:nvSpPr>
-        <p:spPr>
-          <a:xfrm xmlns:a="http://schemas.openxmlformats.org/drawingml/2006/main">
-            <a:off x="7905750" y="1752600"/>
-            <a:ext cx="2952750" cy="1047750"/>
-          </a:xfrm>
-          <a:prstGeom xmlns:a="http://schemas.openxmlformats.org/drawingml/2006/main" prst="rect">
-            <a:avLst/>
-          </a:prstGeom>
-        </p:spPr>
-        <p:txBody>
-          <a:bodyPr xmlns:a="http://schemas.openxmlformats.org/drawingml/2006/main" wrap="square" lIns="0" tIns="0" rIns="0" bIns="0" anchor="t">
-            <a:noAutofit/>
-          </a:bodyPr>
-          <a:lstStyle xmlns:a="http://schemas.openxmlformats.org/drawingml/2006/main"/>
-          <a:p xmlns:a="http://schemas.openxmlformats.org/drawingml/2006/main">
-            <a:pPr algn="l">
-              <a:defRPr sz="5400" b="1">
-                <a:solidFill>
-                  <a:srgbClr val="0F766E"/>
-                </a:solidFill>
-                <a:latin typeface="Helvetica Neue"/>
-                <a:ea typeface="Helvetica Neue"/>
-                <a:cs typeface="Helvetica Neue"/>
-              </a:defRPr>
-            </a:pPr>
-            <a:r>
-              <a:t>2.3×</a:t>
-            </a:r>
-          </a:p>
-        </p:txBody>
-      </p:sp>
-      <p:sp>
-        <p:nvSpPr>
-          <p:cNvPr id="6" name="">
-            <a:extLst xmlns:a="http://schemas.openxmlformats.org/drawingml/2006/main">
-              <a:ext uri="{FF2B5EF4-FFF2-40B4-BE49-F238E27FC236}">
-                <a16:creationId xmlns:a16="http://schemas.microsoft.com/office/drawing/2014/main" id="{D641DEA2-B94B-4813-AF1F-9BB10EDB7CBB}"/>
-              </a:ext>
-            </a:extLst>
-          </p:cNvPr>
-          <p:cNvSpPr>
-            <a:spLocks xmlns:a="http://schemas.openxmlformats.org/drawingml/2006/main" noGrp="1"/>
-          </p:cNvSpPr>
-          <p:nvPr/>
-        </p:nvSpPr>
-        <p:spPr>
-          <a:xfrm xmlns:a="http://schemas.openxmlformats.org/drawingml/2006/main">
-            <a:off x="7905750" y="2895600"/>
-            <a:ext cx="3143250" cy="1066800"/>
-          </a:xfrm>
-          <a:prstGeom xmlns:a="http://schemas.openxmlformats.org/drawingml/2006/main" prst="rect">
-            <a:avLst/>
-          </a:prstGeom>
-        </p:spPr>
-        <p:txBody>
-          <a:bodyPr xmlns:a="http://schemas.openxmlformats.org/drawingml/2006/main" wrap="square" lIns="0" tIns="0" rIns="0" bIns="0" anchor="t">
-            <a:noAutofit/>
-          </a:bodyPr>
-          <a:lstStyle xmlns:a="http://schemas.openxmlformats.org/drawingml/2006/main"/>
-          <a:p xmlns:a="http://schemas.openxmlformats.org/drawingml/2006/main">
-            <a:pPr algn="l">
-              <a:defRPr sz="1875" b="0">
-                <a:solidFill>
-                  <a:srgbClr val="0F172A"/>
-                </a:solidFill>
-                <a:latin typeface="Helvetica Neue"/>
-                <a:ea typeface="Helvetica Neue"/>
-                <a:cs typeface="Helvetica Neue"/>
-              </a:defRPr>
-            </a:pPr>
-            <a:r>
-              <a:t>more nationally significant incidents handled than the previous year</a:t>
-            </a:r>
-          </a:p>
-        </p:txBody>
-      </p:sp>
-      <p:sp>
-        <p:nvSpPr>
-          <p:cNvPr id="7" name="">
-            <a:extLst xmlns:a="http://schemas.openxmlformats.org/drawingml/2006/main">
-              <a:ext uri="{FF2B5EF4-FFF2-40B4-BE49-F238E27FC236}">
-                <a16:creationId xmlns:a16="http://schemas.microsoft.com/office/drawing/2014/main" id="{BA3D1F10-45BF-4B49-8B51-0D393AD63C20}"/>
-              </a:ext>
-            </a:extLst>
-          </p:cNvPr>
-          <p:cNvSpPr>
-            <a:spLocks xmlns:a="http://schemas.openxmlformats.org/drawingml/2006/main" noGrp="1"/>
-          </p:cNvSpPr>
-          <p:nvPr/>
-        </p:nvSpPr>
-        <p:spPr>
-          <a:xfrm xmlns:a="http://schemas.openxmlformats.org/drawingml/2006/main">
-            <a:off x="7905750" y="4400550"/>
-            <a:ext cx="3333750" cy="1200150"/>
-          </a:xfrm>
-          <a:prstGeom xmlns:a="http://schemas.openxmlformats.org/drawingml/2006/main" prst="rect">
-            <a:avLst/>
-          </a:prstGeom>
-        </p:spPr>
-        <p:txBody>
-          <a:bodyPr xmlns:a="http://schemas.openxmlformats.org/drawingml/2006/main" wrap="square" lIns="0" tIns="0" rIns="0" bIns="0" anchor="t">
-            <a:noAutofit/>
-          </a:bodyPr>
-          <a:lstStyle xmlns:a="http://schemas.openxmlformats.org/drawingml/2006/main"/>
-          <a:p xmlns:a="http://schemas.openxmlformats.org/drawingml/2006/main">
-            <a:pPr algn="l">
-              <a:defRPr sz="1575" b="0">
-                <a:solidFill>
-                  <a:srgbClr val="475569"/>
-                </a:solidFill>
-                <a:latin typeface="Helvetica Neue"/>
-                <a:ea typeface="Helvetica Neue"/>
-                <a:cs typeface="Helvetica Neue"/>
-              </a:defRPr>
-            </a:pPr>
-            <a:r>
-              <a:t>Pressure increased—but the NCSC also states that many more attacks fail than succeed, and prepared organisations recover better.</a:t>
-            </a:r>
-          </a:p>
-        </p:txBody>
-      </p:sp>
     </p:spTree>
     <p:extLst>
       <p:ext uri="{BB962C8B-B14F-4D97-AF65-F5344CB8AC3E}">
-        <p14:creationId xmlns:p14="http://schemas.microsoft.com/office/powerpoint/2010/main" val="2107747359"/>
+        <p14:creationId xmlns:p14="http://schemas.microsoft.com/office/powerpoint/2010/main" val="830100672"/>
       </p:ext>
     </p:extLst>
   </p:cSld>

</xml_diff>

<commit_message>
Flatten incident chart for mobile previews
</commit_message>
<xml_diff>
--- a/assets/documents/a-level-epq-presentation.pptx
+++ b/assets/documents/a-level-epq-presentation.pptx
@@ -2,26 +2,26 @@
 <file path=ppt/presentation.xml><?xml version="1.0" encoding="utf-8"?>
 <p:presentation xmlns:p="http://schemas.openxmlformats.org/presentationml/2006/main">
   <p:sldMasterIdLst>
-    <p:sldMasterId xmlns:r="http://schemas.openxmlformats.org/officeDocument/2006/relationships" id="2147483648" r:id="R7f4ff8d9a08d4489"/>
+    <p:sldMasterId xmlns:r="http://schemas.openxmlformats.org/officeDocument/2006/relationships" id="2147483648" r:id="R1d68aca13cc047d1"/>
   </p:sldMasterIdLst>
   <p:notesMasterIdLst>
-    <p:notesMasterId xmlns:r="http://schemas.openxmlformats.org/officeDocument/2006/relationships" r:id="R1adaa248842c45d2"/>
+    <p:notesMasterId xmlns:r="http://schemas.openxmlformats.org/officeDocument/2006/relationships" r:id="Rdb9032bd3226408d"/>
   </p:notesMasterIdLst>
   <p:sldIdLst>
-    <p:sldId xmlns:r="http://schemas.openxmlformats.org/officeDocument/2006/relationships" id="256" r:id="Rcb5ca876072e4636"/>
-    <p:sldId xmlns:r="http://schemas.openxmlformats.org/officeDocument/2006/relationships" id="257" r:id="Raf015be1954144b6"/>
-    <p:sldId xmlns:r="http://schemas.openxmlformats.org/officeDocument/2006/relationships" id="258" r:id="R0a11df9ba70e428f"/>
-    <p:sldId xmlns:r="http://schemas.openxmlformats.org/officeDocument/2006/relationships" id="259" r:id="R5a80a0705462457a"/>
-    <p:sldId xmlns:r="http://schemas.openxmlformats.org/officeDocument/2006/relationships" id="260" r:id="R66ba637c40104227"/>
-    <p:sldId xmlns:r="http://schemas.openxmlformats.org/officeDocument/2006/relationships" id="261" r:id="Re9a4335275fe4d5c"/>
-    <p:sldId xmlns:r="http://schemas.openxmlformats.org/officeDocument/2006/relationships" id="262" r:id="R61567e5df4b34bb6"/>
-    <p:sldId xmlns:r="http://schemas.openxmlformats.org/officeDocument/2006/relationships" id="263" r:id="Rea8fdaafa8764ed8"/>
-    <p:sldId xmlns:r="http://schemas.openxmlformats.org/officeDocument/2006/relationships" id="264" r:id="R2917493f459148c1"/>
-    <p:sldId xmlns:r="http://schemas.openxmlformats.org/officeDocument/2006/relationships" id="265" r:id="R45bb18d57d884426"/>
-    <p:sldId xmlns:r="http://schemas.openxmlformats.org/officeDocument/2006/relationships" id="266" r:id="R215a4ef723724de5"/>
-    <p:sldId xmlns:r="http://schemas.openxmlformats.org/officeDocument/2006/relationships" id="267" r:id="R08a873c936c24e23"/>
-    <p:sldId xmlns:r="http://schemas.openxmlformats.org/officeDocument/2006/relationships" id="268" r:id="Rc41f2e74bdb7497a"/>
-    <p:sldId xmlns:r="http://schemas.openxmlformats.org/officeDocument/2006/relationships" id="269" r:id="Rcf423307aefa4be2"/>
+    <p:sldId xmlns:r="http://schemas.openxmlformats.org/officeDocument/2006/relationships" id="256" r:id="Ref3631efa8d541d4"/>
+    <p:sldId xmlns:r="http://schemas.openxmlformats.org/officeDocument/2006/relationships" id="257" r:id="R0c1a6bd36568475b"/>
+    <p:sldId xmlns:r="http://schemas.openxmlformats.org/officeDocument/2006/relationships" id="258" r:id="R495722b55acb4c8b"/>
+    <p:sldId xmlns:r="http://schemas.openxmlformats.org/officeDocument/2006/relationships" id="259" r:id="R239ba6b9ac9e4026"/>
+    <p:sldId xmlns:r="http://schemas.openxmlformats.org/officeDocument/2006/relationships" id="260" r:id="R7afcf994fcbb43c5"/>
+    <p:sldId xmlns:r="http://schemas.openxmlformats.org/officeDocument/2006/relationships" id="261" r:id="Rccee7289c0344cc5"/>
+    <p:sldId xmlns:r="http://schemas.openxmlformats.org/officeDocument/2006/relationships" id="262" r:id="R89a848bc0cd9404a"/>
+    <p:sldId xmlns:r="http://schemas.openxmlformats.org/officeDocument/2006/relationships" id="263" r:id="Rc47067b5f4c74e93"/>
+    <p:sldId xmlns:r="http://schemas.openxmlformats.org/officeDocument/2006/relationships" id="264" r:id="R5f86b5b65ef642b2"/>
+    <p:sldId xmlns:r="http://schemas.openxmlformats.org/officeDocument/2006/relationships" id="265" r:id="R06599c8ae9954f86"/>
+    <p:sldId xmlns:r="http://schemas.openxmlformats.org/officeDocument/2006/relationships" id="266" r:id="R6921dc8af94b4b71"/>
+    <p:sldId xmlns:r="http://schemas.openxmlformats.org/officeDocument/2006/relationships" id="267" r:id="R1f1fd4f6474e44d7"/>
+    <p:sldId xmlns:r="http://schemas.openxmlformats.org/officeDocument/2006/relationships" id="268" r:id="R7c96eac52ec042f9"/>
+    <p:sldId xmlns:r="http://schemas.openxmlformats.org/officeDocument/2006/relationships" id="269" r:id="Ra4b6cd1f40194ac0"/>
   </p:sldIdLst>
   <p:sldSz cx="12192000" cy="6858000"/>
   <p:notesSz cx="6858000" cy="9144000"/>
@@ -1533,7 +1533,7 @@
   </p:cSld>
   <p:clrMap bg1="lt1" tx1="dk1" bg2="lt2" tx2="dk2" accent1="accent1" accent2="accent2" accent3="accent3" accent4="accent4" accent5="accent5" accent6="accent6" hlink="hlink" folHlink="folHlink"/>
   <p:sldLayoutIdLst>
-    <p:sldLayoutId xmlns:r="http://schemas.openxmlformats.org/officeDocument/2006/relationships" id="2147483649" r:id="R921b88b2abda4824"/>
+    <p:sldLayoutId xmlns:r="http://schemas.openxmlformats.org/officeDocument/2006/relationships" id="2147483649" r:id="R2a8de8fecb3e4579"/>
   </p:sldLayoutIdLst>
   <p:txStyles>
     <p:titleStyle>
@@ -2060,186 +2060,6 @@
 </a:theme>
 </file>
 
-<file path=ppt/slides/charts/chart1.xml><?xml version="1.0" encoding="utf-8"?>
-<c:chartSpace xmlns:c="http://schemas.openxmlformats.org/drawingml/2006/chart">
-  <c:lang val="en-US"/>
-  <c:chart>
-    <c:plotArea>
-      <c:barChart>
-        <c:barDir val="col"/>
-        <c:grouping val="clustered"/>
-        <c:varyColors val="0"/>
-        <c:ser>
-          <c:idx val="0"/>
-          <c:order val="0"/>
-          <c:tx>
-            <c:v>Incidents</c:v>
-          </c:tx>
-          <c:spPr>
-            <a:solidFill xmlns:a="http://schemas.openxmlformats.org/drawingml/2006/main">
-              <a:srgbClr val="14B8A6"/>
-            </a:solidFill>
-          </c:spPr>
-          <c:cat>
-            <c:strLit>
-              <c:ptCount val="2"/>
-              <c:pt idx="0">
-                <c:v>2023–24</c:v>
-              </c:pt>
-              <c:pt idx="1">
-                <c:v>2024–25</c:v>
-              </c:pt>
-            </c:strLit>
-          </c:cat>
-          <c:val>
-            <c:numLit>
-              <c:formatCode>General</c:formatCode>
-              <c:ptCount val="2"/>
-              <c:pt idx="0">
-                <c:v>89</c:v>
-              </c:pt>
-              <c:pt idx="1">
-                <c:v>204</c:v>
-              </c:pt>
-            </c:numLit>
-          </c:val>
-        </c:ser>
-        <c:dLbls>
-          <c:txPr>
-            <a:bodyPr xmlns:a="http://schemas.openxmlformats.org/drawingml/2006/main" anchorCtr="1"/>
-            <a:lstStyle xmlns:a="http://schemas.openxmlformats.org/drawingml/2006/main"/>
-            <a:p xmlns:a="http://schemas.openxmlformats.org/drawingml/2006/main">
-              <a:pPr>
-                <a:defRPr sz="1350" b="1">
-                  <a:solidFill>
-                    <a:srgbClr val="0F172A"/>
-                  </a:solidFill>
-                </a:defRPr>
-              </a:pPr>
-            </a:p>
-          </c:txPr>
-          <c:dLblPos val="outEnd"/>
-          <c:showLegendKey val="0"/>
-          <c:showVal val="1"/>
-          <c:showCatName val="0"/>
-          <c:showSerName val="0"/>
-          <c:showPercent val="0"/>
-          <c:showBubbleSize val="0"/>
-          <c:showLeaderLines val="0"/>
-        </c:dLbls>
-        <c:gapWidth val="70"/>
-        <c:axId val="48650112"/>
-        <c:axId val="48672768"/>
-      </c:barChart>
-      <c:catAx>
-        <c:axId val="48650112"/>
-        <c:scaling>
-          <c:orientation val="minMax"/>
-        </c:scaling>
-        <c:delete val="0"/>
-        <c:axPos val="b"/>
-        <c:numFmt formatCode="General"/>
-        <c:majorTickMark val="none"/>
-        <c:minorTickMark val="none"/>
-        <c:spPr>
-          <a:ln xmlns:a="http://schemas.openxmlformats.org/drawingml/2006/main" w="9525">
-            <a:solidFill>
-              <a:srgbClr val="B8BCC4"/>
-            </a:solidFill>
-            <a:prstDash val="solid"/>
-          </a:ln>
-        </c:spPr>
-        <c:txPr>
-          <a:bodyPr xmlns:a="http://schemas.openxmlformats.org/drawingml/2006/main" anchorCtr="1"/>
-          <a:lstStyle xmlns:a="http://schemas.openxmlformats.org/drawingml/2006/main"/>
-          <a:p xmlns:a="http://schemas.openxmlformats.org/drawingml/2006/main">
-            <a:pPr>
-              <a:defRPr sz="1200">
-                <a:solidFill>
-                  <a:srgbClr val="475569"/>
-                </a:solidFill>
-              </a:defRPr>
-            </a:pPr>
-          </a:p>
-        </c:txPr>
-        <c:crossAx val="48672768"/>
-        <c:lblAlgn val="ctr"/>
-        <c:lblOffset val="100"/>
-        <c:noMultiLvlLbl val="0"/>
-      </c:catAx>
-      <c:valAx>
-        <c:axId val="48672768"/>
-        <c:scaling>
-          <c:orientation val="minMax"/>
-          <c:max val="220"/>
-          <c:min val="0"/>
-        </c:scaling>
-        <c:delete val="0"/>
-        <c:axPos val="l"/>
-        <c:majorGridlines>
-          <c:spPr>
-            <a:ln xmlns:a="http://schemas.openxmlformats.org/drawingml/2006/main" w="9525">
-              <a:solidFill>
-                <a:srgbClr val="E2E8F0"/>
-              </a:solidFill>
-              <a:prstDash val="solid"/>
-            </a:ln>
-          </c:spPr>
-        </c:majorGridlines>
-        <c:numFmt formatCode="General"/>
-        <c:majorTickMark val="none"/>
-        <c:minorTickMark val="none"/>
-        <c:spPr>
-          <a:ln xmlns:a="http://schemas.openxmlformats.org/drawingml/2006/main" w="9525">
-            <a:solidFill>
-              <a:srgbClr val="D4D4D4"/>
-            </a:solidFill>
-            <a:prstDash val="solid"/>
-          </a:ln>
-        </c:spPr>
-        <c:txPr>
-          <a:bodyPr xmlns:a="http://schemas.openxmlformats.org/drawingml/2006/main" anchorCtr="1"/>
-          <a:lstStyle xmlns:a="http://schemas.openxmlformats.org/drawingml/2006/main"/>
-          <a:p xmlns:a="http://schemas.openxmlformats.org/drawingml/2006/main">
-            <a:pPr>
-              <a:defRPr sz="1050">
-                <a:solidFill>
-                  <a:srgbClr val="475569"/>
-                </a:solidFill>
-              </a:defRPr>
-            </a:pPr>
-          </a:p>
-        </c:txPr>
-        <c:crossAx val="48650112"/>
-        <c:crossBetween val="between"/>
-        <c:majorUnit val="50"/>
-      </c:valAx>
-      <c:spPr>
-        <a:noFill xmlns:a="http://schemas.openxmlformats.org/drawingml/2006/main"/>
-        <a:ln xmlns:a="http://schemas.openxmlformats.org/drawingml/2006/main" w="0">
-          <a:solidFill>
-            <a:srgbClr val="FFFFFF"/>
-          </a:solidFill>
-          <a:prstDash val="solid"/>
-        </a:ln>
-      </c:spPr>
-    </c:plotArea>
-    <c:plotVisOnly val="1"/>
-  </c:chart>
-  <c:spPr>
-    <a:solidFill xmlns:a="http://schemas.openxmlformats.org/drawingml/2006/main">
-      <a:srgbClr val="FFFFFF"/>
-    </a:solidFill>
-    <a:ln xmlns:a="http://schemas.openxmlformats.org/drawingml/2006/main" w="0">
-      <a:solidFill>
-        <a:srgbClr val="FFFFFF"/>
-      </a:solidFill>
-      <a:prstDash val="solid"/>
-    </a:ln>
-  </c:spPr>
-</c:chartSpace>
-</file>
-
 <file path=ppt/slides/slide1.xml><?xml version="1.0" encoding="utf-8"?>
 <p:sld xmlns:p="http://schemas.openxmlformats.org/presentationml/2006/main">
   <p:cSld>
@@ -2264,7 +2084,7 @@
           <p:cNvPr id="9" name="">
             <a:extLst xmlns:a="http://schemas.openxmlformats.org/drawingml/2006/main">
               <a:ext uri="{FF2B5EF4-FFF2-40B4-BE49-F238E27FC236}">
-                <a16:creationId xmlns:a16="http://schemas.microsoft.com/office/drawing/2014/main" id="{76675351-A01F-479D-A996-DE8558636EB7}"/>
+                <a16:creationId xmlns:a16="http://schemas.microsoft.com/office/drawing/2014/main" id="{4C795803-2684-48AC-9E27-221BE78D03F0}"/>
               </a:ext>
             </a:extLst>
           </p:cNvPr>
@@ -2309,7 +2129,7 @@
           <p:cNvPr id="2" name="">
             <a:extLst xmlns:a="http://schemas.openxmlformats.org/drawingml/2006/main">
               <a:ext uri="{FF2B5EF4-FFF2-40B4-BE49-F238E27FC236}">
-                <a16:creationId xmlns:a16="http://schemas.microsoft.com/office/drawing/2014/main" id="{5657CEFC-9995-48A8-8659-6B5D8343A455}"/>
+                <a16:creationId xmlns:a16="http://schemas.microsoft.com/office/drawing/2014/main" id="{D8E856D9-407C-4ADE-9294-FD620AC8F570}"/>
               </a:ext>
             </a:extLst>
           </p:cNvPr>
@@ -2354,7 +2174,7 @@
           <p:cNvPr id="3" name="">
             <a:extLst xmlns:a="http://schemas.openxmlformats.org/drawingml/2006/main">
               <a:ext uri="{FF2B5EF4-FFF2-40B4-BE49-F238E27FC236}">
-                <a16:creationId xmlns:a16="http://schemas.microsoft.com/office/drawing/2014/main" id="{E061A375-BD56-4B23-AF76-04F1163ACA52}"/>
+                <a16:creationId xmlns:a16="http://schemas.microsoft.com/office/drawing/2014/main" id="{40781F44-04F4-4903-B90A-91C065CA09C8}"/>
               </a:ext>
             </a:extLst>
           </p:cNvPr>
@@ -2399,7 +2219,7 @@
           <p:cNvPr id="4" name="">
             <a:extLst xmlns:a="http://schemas.openxmlformats.org/drawingml/2006/main">
               <a:ext uri="{FF2B5EF4-FFF2-40B4-BE49-F238E27FC236}">
-                <a16:creationId xmlns:a16="http://schemas.microsoft.com/office/drawing/2014/main" id="{813F2033-7095-4399-8170-88D3065794AD}"/>
+                <a16:creationId xmlns:a16="http://schemas.microsoft.com/office/drawing/2014/main" id="{2FC2CBB1-1D4B-4C85-9D62-99B42744A209}"/>
               </a:ext>
             </a:extLst>
           </p:cNvPr>
@@ -2444,7 +2264,7 @@
           <p:cNvPr id="5" name="cover-image-backing">
             <a:extLst xmlns:a="http://schemas.openxmlformats.org/drawingml/2006/main">
               <a:ext uri="{FF2B5EF4-FFF2-40B4-BE49-F238E27FC236}">
-                <a16:creationId xmlns:a16="http://schemas.microsoft.com/office/drawing/2014/main" id="{F0B68708-978F-450A-AD75-7E2DD8220DB0}"/>
+                <a16:creationId xmlns:a16="http://schemas.microsoft.com/office/drawing/2014/main" id="{0915423D-E6E9-469F-BDF2-7CB371986FA1}"/>
               </a:ext>
             </a:extLst>
           </p:cNvPr>
@@ -2479,7 +2299,7 @@
           <p:cNvPr id="6" name="source-1">
             <a:extLst xmlns:a="http://schemas.openxmlformats.org/drawingml/2006/main">
               <a:ext uri="{FF2B5EF4-FFF2-40B4-BE49-F238E27FC236}">
-                <a16:creationId xmlns:a16="http://schemas.microsoft.com/office/drawing/2014/main" id="{C5AB6392-8C45-4BDE-BAA5-4D91B98C85C4}"/>
+                <a16:creationId xmlns:a16="http://schemas.microsoft.com/office/drawing/2014/main" id="{E516A339-147C-43D1-B5A9-61492E9AA30F}"/>
               </a:ext>
             </a:extLst>
           </p:cNvPr>
@@ -2524,7 +2344,7 @@
           <p:cNvPr id="7" name="page-1">
             <a:extLst xmlns:a="http://schemas.openxmlformats.org/drawingml/2006/main">
               <a:ext uri="{FF2B5EF4-FFF2-40B4-BE49-F238E27FC236}">
-                <a16:creationId xmlns:a16="http://schemas.microsoft.com/office/drawing/2014/main" id="{4072699C-25B2-4CAF-B17C-FCC7048527A2}"/>
+                <a16:creationId xmlns:a16="http://schemas.microsoft.com/office/drawing/2014/main" id="{B375A9B5-5405-405B-AC31-1F6171E9A348}"/>
               </a:ext>
             </a:extLst>
           </p:cNvPr>
@@ -2573,7 +2393,7 @@
           <p:nvPr/>
         </p:nvPicPr>
         <p:blipFill>
-          <a:blip xmlns:r="http://schemas.openxmlformats.org/officeDocument/2006/relationships" xmlns:a="http://schemas.openxmlformats.org/drawingml/2006/main" r:embed="R9680163dcf294e38"/>
+          <a:blip xmlns:r="http://schemas.openxmlformats.org/officeDocument/2006/relationships" xmlns:a="http://schemas.openxmlformats.org/drawingml/2006/main" r:embed="R05ccad4490b0405b"/>
           <a:stretch xmlns:a="http://schemas.openxmlformats.org/drawingml/2006/main"/>
         </p:blipFill>
         <p:spPr>
@@ -2589,7 +2409,7 @@
     </p:spTree>
     <p:extLst>
       <p:ext uri="{BB962C8B-B14F-4D97-AF65-F5344CB8AC3E}">
-        <p14:creationId xmlns:p14="http://schemas.microsoft.com/office/powerpoint/2010/main" val="757254883"/>
+        <p14:creationId xmlns:p14="http://schemas.microsoft.com/office/powerpoint/2010/main" val="1926445631"/>
       </p:ext>
     </p:extLst>
   </p:cSld>
@@ -2620,7 +2440,7 @@
           <p:cNvPr id="17" name="title-10">
             <a:extLst xmlns:a="http://schemas.openxmlformats.org/drawingml/2006/main">
               <a:ext uri="{FF2B5EF4-FFF2-40B4-BE49-F238E27FC236}">
-                <a16:creationId xmlns:a16="http://schemas.microsoft.com/office/drawing/2014/main" id="{646CB916-2473-4599-9A29-49A7405EB416}"/>
+                <a16:creationId xmlns:a16="http://schemas.microsoft.com/office/drawing/2014/main" id="{8284879D-886D-488F-AA33-F6E0F30DA8C0}"/>
               </a:ext>
             </a:extLst>
           </p:cNvPr>
@@ -2665,7 +2485,7 @@
           <p:cNvPr id="2" name="source-10">
             <a:extLst xmlns:a="http://schemas.openxmlformats.org/drawingml/2006/main">
               <a:ext uri="{FF2B5EF4-FFF2-40B4-BE49-F238E27FC236}">
-                <a16:creationId xmlns:a16="http://schemas.microsoft.com/office/drawing/2014/main" id="{615DFAF3-9595-49E7-8401-F16196A24326}"/>
+                <a16:creationId xmlns:a16="http://schemas.microsoft.com/office/drawing/2014/main" id="{2CA5E580-2482-4F5B-AE9B-7276FF739F30}"/>
               </a:ext>
             </a:extLst>
           </p:cNvPr>
@@ -2710,7 +2530,7 @@
           <p:cNvPr id="3" name="page-10">
             <a:extLst xmlns:a="http://schemas.openxmlformats.org/drawingml/2006/main">
               <a:ext uri="{FF2B5EF4-FFF2-40B4-BE49-F238E27FC236}">
-                <a16:creationId xmlns:a16="http://schemas.microsoft.com/office/drawing/2014/main" id="{EFBFA35C-B168-4736-816D-923AF9C2571B}"/>
+                <a16:creationId xmlns:a16="http://schemas.microsoft.com/office/drawing/2014/main" id="{F63F91C1-30CF-46C6-A01E-229791331D6A}"/>
               </a:ext>
             </a:extLst>
           </p:cNvPr>
@@ -2755,7 +2575,7 @@
           <p:cNvPr id="4" name="">
             <a:extLst xmlns:a="http://schemas.openxmlformats.org/drawingml/2006/main">
               <a:ext uri="{FF2B5EF4-FFF2-40B4-BE49-F238E27FC236}">
-                <a16:creationId xmlns:a16="http://schemas.microsoft.com/office/drawing/2014/main" id="{7A4427A1-95DA-4AE2-939C-87267912CA0F}"/>
+                <a16:creationId xmlns:a16="http://schemas.microsoft.com/office/drawing/2014/main" id="{03789B23-E548-4C1D-9D32-FABBF7E497BC}"/>
               </a:ext>
             </a:extLst>
           </p:cNvPr>
@@ -2800,7 +2620,7 @@
           <p:cNvPr id="5" name="">
             <a:extLst xmlns:a="http://schemas.openxmlformats.org/drawingml/2006/main">
               <a:ext uri="{FF2B5EF4-FFF2-40B4-BE49-F238E27FC236}">
-                <a16:creationId xmlns:a16="http://schemas.microsoft.com/office/drawing/2014/main" id="{41F3C995-B3FD-4043-98B5-57DA129F1473}"/>
+                <a16:creationId xmlns:a16="http://schemas.microsoft.com/office/drawing/2014/main" id="{DD61D0F1-8C45-49E1-832C-3B6E9A9E2E49}"/>
               </a:ext>
             </a:extLst>
           </p:cNvPr>
@@ -2845,7 +2665,7 @@
           <p:cNvPr id="6" name="">
             <a:extLst xmlns:a="http://schemas.openxmlformats.org/drawingml/2006/main">
               <a:ext uri="{FF2B5EF4-FFF2-40B4-BE49-F238E27FC236}">
-                <a16:creationId xmlns:a16="http://schemas.microsoft.com/office/drawing/2014/main" id="{8FB2D89C-023F-4F2B-83F3-306AB4666364}"/>
+                <a16:creationId xmlns:a16="http://schemas.microsoft.com/office/drawing/2014/main" id="{EFCDBA68-2A87-499F-8172-FCB41E40319B}"/>
               </a:ext>
             </a:extLst>
           </p:cNvPr>
@@ -2890,7 +2710,7 @@
           <p:cNvPr id="7" name="">
             <a:extLst xmlns:a="http://schemas.openxmlformats.org/drawingml/2006/main">
               <a:ext uri="{FF2B5EF4-FFF2-40B4-BE49-F238E27FC236}">
-                <a16:creationId xmlns:a16="http://schemas.microsoft.com/office/drawing/2014/main" id="{4B2DADC3-B312-4836-8D26-5E762F465E04}"/>
+                <a16:creationId xmlns:a16="http://schemas.microsoft.com/office/drawing/2014/main" id="{0D9BBE07-157C-4514-8065-BAF6BF97FBE7}"/>
               </a:ext>
             </a:extLst>
           </p:cNvPr>
@@ -2935,7 +2755,7 @@
           <p:cNvPr id="8" name="">
             <a:extLst xmlns:a="http://schemas.openxmlformats.org/drawingml/2006/main">
               <a:ext uri="{FF2B5EF4-FFF2-40B4-BE49-F238E27FC236}">
-                <a16:creationId xmlns:a16="http://schemas.microsoft.com/office/drawing/2014/main" id="{D59532BC-CE64-4576-A390-61BB08134A18}"/>
+                <a16:creationId xmlns:a16="http://schemas.microsoft.com/office/drawing/2014/main" id="{FD0023DB-056B-4D32-937F-A3F76C7ABD4A}"/>
               </a:ext>
             </a:extLst>
           </p:cNvPr>
@@ -2980,7 +2800,7 @@
           <p:cNvPr id="9" name="">
             <a:extLst xmlns:a="http://schemas.openxmlformats.org/drawingml/2006/main">
               <a:ext uri="{FF2B5EF4-FFF2-40B4-BE49-F238E27FC236}">
-                <a16:creationId xmlns:a16="http://schemas.microsoft.com/office/drawing/2014/main" id="{D32E826A-94A6-490B-8B58-C63CC16A023B}"/>
+                <a16:creationId xmlns:a16="http://schemas.microsoft.com/office/drawing/2014/main" id="{AC35F38E-CA03-47B5-9F22-6EF7234A20CF}"/>
               </a:ext>
             </a:extLst>
           </p:cNvPr>
@@ -3025,7 +2845,7 @@
           <p:cNvPr id="10" name="">
             <a:extLst xmlns:a="http://schemas.openxmlformats.org/drawingml/2006/main">
               <a:ext uri="{FF2B5EF4-FFF2-40B4-BE49-F238E27FC236}">
-                <a16:creationId xmlns:a16="http://schemas.microsoft.com/office/drawing/2014/main" id="{B07AE9DA-B926-4AA4-97D4-1EFE2D5B4442}"/>
+                <a16:creationId xmlns:a16="http://schemas.microsoft.com/office/drawing/2014/main" id="{80CBB40E-9111-4DD3-A0E7-F424C56FDD3E}"/>
               </a:ext>
             </a:extLst>
           </p:cNvPr>
@@ -3070,7 +2890,7 @@
           <p:cNvPr id="11" name="">
             <a:extLst xmlns:a="http://schemas.openxmlformats.org/drawingml/2006/main">
               <a:ext uri="{FF2B5EF4-FFF2-40B4-BE49-F238E27FC236}">
-                <a16:creationId xmlns:a16="http://schemas.microsoft.com/office/drawing/2014/main" id="{F9007D2F-C019-409D-8361-E33DE054BA2D}"/>
+                <a16:creationId xmlns:a16="http://schemas.microsoft.com/office/drawing/2014/main" id="{2BFA5EDE-EBA4-4500-8FC7-C9BBD00AEA7E}"/>
               </a:ext>
             </a:extLst>
           </p:cNvPr>
@@ -3115,7 +2935,7 @@
           <p:cNvPr id="12" name="">
             <a:extLst xmlns:a="http://schemas.openxmlformats.org/drawingml/2006/main">
               <a:ext uri="{FF2B5EF4-FFF2-40B4-BE49-F238E27FC236}">
-                <a16:creationId xmlns:a16="http://schemas.microsoft.com/office/drawing/2014/main" id="{B3D9B67B-BDF0-4479-988C-BD6B1081EA9F}"/>
+                <a16:creationId xmlns:a16="http://schemas.microsoft.com/office/drawing/2014/main" id="{1BBEEB28-2E3D-451E-9A44-EC69EDADD3DD}"/>
               </a:ext>
             </a:extLst>
           </p:cNvPr>
@@ -3160,7 +2980,7 @@
           <p:cNvPr id="13" name="security-guide-frame">
             <a:extLst xmlns:a="http://schemas.openxmlformats.org/drawingml/2006/main">
               <a:ext uri="{FF2B5EF4-FFF2-40B4-BE49-F238E27FC236}">
-                <a16:creationId xmlns:a16="http://schemas.microsoft.com/office/drawing/2014/main" id="{B26B7972-4803-48B2-AB7F-012C1E3CF9B8}"/>
+                <a16:creationId xmlns:a16="http://schemas.microsoft.com/office/drawing/2014/main" id="{71191241-BB44-42D4-990E-7E163CD07640}"/>
               </a:ext>
             </a:extLst>
           </p:cNvPr>
@@ -3195,7 +3015,7 @@
           <p:cNvPr id="14" name="">
             <a:extLst xmlns:a="http://schemas.openxmlformats.org/drawingml/2006/main">
               <a:ext uri="{FF2B5EF4-FFF2-40B4-BE49-F238E27FC236}">
-                <a16:creationId xmlns:a16="http://schemas.microsoft.com/office/drawing/2014/main" id="{9304764B-9ABB-483C-99A3-495361D21E3A}"/>
+                <a16:creationId xmlns:a16="http://schemas.microsoft.com/office/drawing/2014/main" id="{A4663F76-9BAB-4396-A11B-0E59AE2F5567}"/>
               </a:ext>
             </a:extLst>
           </p:cNvPr>
@@ -3240,7 +3060,7 @@
           <p:cNvPr id="15" name="">
             <a:extLst xmlns:a="http://schemas.openxmlformats.org/drawingml/2006/main">
               <a:ext uri="{FF2B5EF4-FFF2-40B4-BE49-F238E27FC236}">
-                <a16:creationId xmlns:a16="http://schemas.microsoft.com/office/drawing/2014/main" id="{3BAD3998-4844-490F-A94B-99E42EBF16AB}"/>
+                <a16:creationId xmlns:a16="http://schemas.microsoft.com/office/drawing/2014/main" id="{D8208140-73DA-4466-A682-98364FD1F869}"/>
               </a:ext>
             </a:extLst>
           </p:cNvPr>
@@ -3289,7 +3109,7 @@
           <p:nvPr/>
         </p:nvPicPr>
         <p:blipFill>
-          <a:blip xmlns:r="http://schemas.openxmlformats.org/officeDocument/2006/relationships" xmlns:a="http://schemas.openxmlformats.org/drawingml/2006/main" r:embed="Rff9ca94dd53d46e1"/>
+          <a:blip xmlns:r="http://schemas.openxmlformats.org/officeDocument/2006/relationships" xmlns:a="http://schemas.openxmlformats.org/drawingml/2006/main" r:embed="R6f5c38fd4df84d41"/>
           <a:stretch xmlns:a="http://schemas.openxmlformats.org/drawingml/2006/main"/>
         </p:blipFill>
         <p:spPr>
@@ -3305,7 +3125,7 @@
     </p:spTree>
     <p:extLst>
       <p:ext uri="{BB962C8B-B14F-4D97-AF65-F5344CB8AC3E}">
-        <p14:creationId xmlns:p14="http://schemas.microsoft.com/office/powerpoint/2010/main" val="704331667"/>
+        <p14:creationId xmlns:p14="http://schemas.microsoft.com/office/powerpoint/2010/main" val="1896880837"/>
       </p:ext>
     </p:extLst>
   </p:cSld>
@@ -3336,7 +3156,7 @@
           <p:cNvPr id="12" name="title-11">
             <a:extLst xmlns:a="http://schemas.openxmlformats.org/drawingml/2006/main">
               <a:ext uri="{FF2B5EF4-FFF2-40B4-BE49-F238E27FC236}">
-                <a16:creationId xmlns:a16="http://schemas.microsoft.com/office/drawing/2014/main" id="{0839FD19-287E-4AAB-8CCC-B719197A7B85}"/>
+                <a16:creationId xmlns:a16="http://schemas.microsoft.com/office/drawing/2014/main" id="{D0BC4922-7284-402E-9B5C-C8FC029FC254}"/>
               </a:ext>
             </a:extLst>
           </p:cNvPr>
@@ -3381,7 +3201,7 @@
           <p:cNvPr id="2" name="source-11">
             <a:extLst xmlns:a="http://schemas.openxmlformats.org/drawingml/2006/main">
               <a:ext uri="{FF2B5EF4-FFF2-40B4-BE49-F238E27FC236}">
-                <a16:creationId xmlns:a16="http://schemas.microsoft.com/office/drawing/2014/main" id="{B2E605AB-BFB1-4A82-B479-B477182B652E}"/>
+                <a16:creationId xmlns:a16="http://schemas.microsoft.com/office/drawing/2014/main" id="{A36E3AF5-0CCB-459A-A8A1-9C34B349C6FE}"/>
               </a:ext>
             </a:extLst>
           </p:cNvPr>
@@ -3426,7 +3246,7 @@
           <p:cNvPr id="3" name="page-11">
             <a:extLst xmlns:a="http://schemas.openxmlformats.org/drawingml/2006/main">
               <a:ext uri="{FF2B5EF4-FFF2-40B4-BE49-F238E27FC236}">
-                <a16:creationId xmlns:a16="http://schemas.microsoft.com/office/drawing/2014/main" id="{93B6BCEF-F5C3-45C8-AAF7-0506EFC383AC}"/>
+                <a16:creationId xmlns:a16="http://schemas.microsoft.com/office/drawing/2014/main" id="{B474963C-5441-4D26-8091-11850E10FC42}"/>
               </a:ext>
             </a:extLst>
           </p:cNvPr>
@@ -3471,7 +3291,7 @@
           <p:cNvPr id="4" name="">
             <a:extLst xmlns:a="http://schemas.openxmlformats.org/drawingml/2006/main">
               <a:ext uri="{FF2B5EF4-FFF2-40B4-BE49-F238E27FC236}">
-                <a16:creationId xmlns:a16="http://schemas.microsoft.com/office/drawing/2014/main" id="{D9B86020-1D5B-4AC0-9A30-70FAD83486AC}"/>
+                <a16:creationId xmlns:a16="http://schemas.microsoft.com/office/drawing/2014/main" id="{C5C2D7DA-9F2B-46E7-BBAD-EB70941B3353}"/>
               </a:ext>
             </a:extLst>
           </p:cNvPr>
@@ -3516,7 +3336,7 @@
           <p:cNvPr id="5" name="">
             <a:extLst xmlns:a="http://schemas.openxmlformats.org/drawingml/2006/main">
               <a:ext uri="{FF2B5EF4-FFF2-40B4-BE49-F238E27FC236}">
-                <a16:creationId xmlns:a16="http://schemas.microsoft.com/office/drawing/2014/main" id="{A39942B5-166B-47E2-A69D-E25DCFA696A6}"/>
+                <a16:creationId xmlns:a16="http://schemas.microsoft.com/office/drawing/2014/main" id="{4DB25757-F868-4D45-82E2-6F2374A338F1}"/>
               </a:ext>
             </a:extLst>
           </p:cNvPr>
@@ -3564,7 +3384,7 @@
           <p:cNvPr id="6" name="">
             <a:extLst xmlns:a="http://schemas.openxmlformats.org/drawingml/2006/main">
               <a:ext uri="{FF2B5EF4-FFF2-40B4-BE49-F238E27FC236}">
-                <a16:creationId xmlns:a16="http://schemas.microsoft.com/office/drawing/2014/main" id="{A3A281D9-FB7C-4F80-A633-618FECC49E32}"/>
+                <a16:creationId xmlns:a16="http://schemas.microsoft.com/office/drawing/2014/main" id="{DD548472-7D6C-4852-9CFB-636EC39CF5C4}"/>
               </a:ext>
             </a:extLst>
           </p:cNvPr>
@@ -3609,7 +3429,7 @@
           <p:cNvPr id="7" name="">
             <a:extLst xmlns:a="http://schemas.openxmlformats.org/drawingml/2006/main">
               <a:ext uri="{FF2B5EF4-FFF2-40B4-BE49-F238E27FC236}">
-                <a16:creationId xmlns:a16="http://schemas.microsoft.com/office/drawing/2014/main" id="{285F4A13-30BE-42E0-9C69-63A84C7FA284}"/>
+                <a16:creationId xmlns:a16="http://schemas.microsoft.com/office/drawing/2014/main" id="{7969A8F7-BC8B-47D8-AD1A-0BCAE7A06098}"/>
               </a:ext>
             </a:extLst>
           </p:cNvPr>
@@ -3657,7 +3477,7 @@
           <p:cNvPr id="8" name="">
             <a:extLst xmlns:a="http://schemas.openxmlformats.org/drawingml/2006/main">
               <a:ext uri="{FF2B5EF4-FFF2-40B4-BE49-F238E27FC236}">
-                <a16:creationId xmlns:a16="http://schemas.microsoft.com/office/drawing/2014/main" id="{138B6BF7-9EE1-4A9D-8EC4-D961059244B8}"/>
+                <a16:creationId xmlns:a16="http://schemas.microsoft.com/office/drawing/2014/main" id="{90BE7E2E-C624-4D77-8DEB-F160BBAE5363}"/>
               </a:ext>
             </a:extLst>
           </p:cNvPr>
@@ -3702,7 +3522,7 @@
           <p:cNvPr id="9" name="">
             <a:extLst xmlns:a="http://schemas.openxmlformats.org/drawingml/2006/main">
               <a:ext uri="{FF2B5EF4-FFF2-40B4-BE49-F238E27FC236}">
-                <a16:creationId xmlns:a16="http://schemas.microsoft.com/office/drawing/2014/main" id="{FE496941-5B56-4AD4-82E2-A7E4AB91E42E}"/>
+                <a16:creationId xmlns:a16="http://schemas.microsoft.com/office/drawing/2014/main" id="{934FE054-73AB-411A-8AA9-C2C705018E51}"/>
               </a:ext>
             </a:extLst>
           </p:cNvPr>
@@ -3750,7 +3570,7 @@
           <p:cNvPr id="10" name="">
             <a:extLst xmlns:a="http://schemas.openxmlformats.org/drawingml/2006/main">
               <a:ext uri="{FF2B5EF4-FFF2-40B4-BE49-F238E27FC236}">
-                <a16:creationId xmlns:a16="http://schemas.microsoft.com/office/drawing/2014/main" id="{36E73067-E3B7-4624-87D0-47E535B6155B}"/>
+                <a16:creationId xmlns:a16="http://schemas.microsoft.com/office/drawing/2014/main" id="{1C4CF4F6-6BAE-4DAF-9BFF-E6D2EDBBE6DC}"/>
               </a:ext>
             </a:extLst>
           </p:cNvPr>
@@ -3783,7 +3603,7 @@
           <p:cNvPr id="11" name="">
             <a:extLst xmlns:a="http://schemas.openxmlformats.org/drawingml/2006/main">
               <a:ext uri="{FF2B5EF4-FFF2-40B4-BE49-F238E27FC236}">
-                <a16:creationId xmlns:a16="http://schemas.microsoft.com/office/drawing/2014/main" id="{C4E9A2DC-0F97-4F79-873D-FE8661A188B5}"/>
+                <a16:creationId xmlns:a16="http://schemas.microsoft.com/office/drawing/2014/main" id="{F9BD0F9B-B92A-43EF-8C90-AB821055395E}"/>
               </a:ext>
             </a:extLst>
           </p:cNvPr>
@@ -3826,7 +3646,7 @@
     </p:spTree>
     <p:extLst>
       <p:ext uri="{BB962C8B-B14F-4D97-AF65-F5344CB8AC3E}">
-        <p14:creationId xmlns:p14="http://schemas.microsoft.com/office/powerpoint/2010/main" val="715131570"/>
+        <p14:creationId xmlns:p14="http://schemas.microsoft.com/office/powerpoint/2010/main" val="1019420382"/>
       </p:ext>
     </p:extLst>
   </p:cSld>
@@ -3857,7 +3677,7 @@
           <p:cNvPr id="23" name="title-12">
             <a:extLst xmlns:a="http://schemas.openxmlformats.org/drawingml/2006/main">
               <a:ext uri="{FF2B5EF4-FFF2-40B4-BE49-F238E27FC236}">
-                <a16:creationId xmlns:a16="http://schemas.microsoft.com/office/drawing/2014/main" id="{458ACCB5-20AF-4221-AF04-D49011D3F414}"/>
+                <a16:creationId xmlns:a16="http://schemas.microsoft.com/office/drawing/2014/main" id="{B20E00B9-E445-4C86-93EA-318721544D96}"/>
               </a:ext>
             </a:extLst>
           </p:cNvPr>
@@ -3902,7 +3722,7 @@
           <p:cNvPr id="2" name="source-12">
             <a:extLst xmlns:a="http://schemas.openxmlformats.org/drawingml/2006/main">
               <a:ext uri="{FF2B5EF4-FFF2-40B4-BE49-F238E27FC236}">
-                <a16:creationId xmlns:a16="http://schemas.microsoft.com/office/drawing/2014/main" id="{FE17AC57-B92E-427B-9F44-B9A22CE8837E}"/>
+                <a16:creationId xmlns:a16="http://schemas.microsoft.com/office/drawing/2014/main" id="{D3153179-20E2-4DF6-8350-F1046B2F09C8}"/>
               </a:ext>
             </a:extLst>
           </p:cNvPr>
@@ -3947,7 +3767,7 @@
           <p:cNvPr id="3" name="page-12">
             <a:extLst xmlns:a="http://schemas.openxmlformats.org/drawingml/2006/main">
               <a:ext uri="{FF2B5EF4-FFF2-40B4-BE49-F238E27FC236}">
-                <a16:creationId xmlns:a16="http://schemas.microsoft.com/office/drawing/2014/main" id="{A17680C3-21C3-4DF7-A48D-3BDD412C6B3D}"/>
+                <a16:creationId xmlns:a16="http://schemas.microsoft.com/office/drawing/2014/main" id="{26D12040-A1F6-47F2-A4D6-3314BE414568}"/>
               </a:ext>
             </a:extLst>
           </p:cNvPr>
@@ -3992,7 +3812,7 @@
           <p:cNvPr id="4" name="">
             <a:extLst xmlns:a="http://schemas.openxmlformats.org/drawingml/2006/main">
               <a:ext uri="{FF2B5EF4-FFF2-40B4-BE49-F238E27FC236}">
-                <a16:creationId xmlns:a16="http://schemas.microsoft.com/office/drawing/2014/main" id="{7FB56C13-93CA-4508-844A-38023F5E087A}"/>
+                <a16:creationId xmlns:a16="http://schemas.microsoft.com/office/drawing/2014/main" id="{6798544C-827D-4783-A0AB-752AFDE10E5E}"/>
               </a:ext>
             </a:extLst>
           </p:cNvPr>
@@ -4025,7 +3845,7 @@
           <p:cNvPr id="5" name="function-label-0">
             <a:extLst xmlns:a="http://schemas.openxmlformats.org/drawingml/2006/main">
               <a:ext uri="{FF2B5EF4-FFF2-40B4-BE49-F238E27FC236}">
-                <a16:creationId xmlns:a16="http://schemas.microsoft.com/office/drawing/2014/main" id="{D7310C6E-FB9B-4708-BEF2-3910E3BB7E86}"/>
+                <a16:creationId xmlns:a16="http://schemas.microsoft.com/office/drawing/2014/main" id="{C9AE7ECC-2DE7-4D4B-B8C9-151FE39B599F}"/>
               </a:ext>
             </a:extLst>
           </p:cNvPr>
@@ -4070,7 +3890,7 @@
           <p:cNvPr id="6" name="function-body-0">
             <a:extLst xmlns:a="http://schemas.openxmlformats.org/drawingml/2006/main">
               <a:ext uri="{FF2B5EF4-FFF2-40B4-BE49-F238E27FC236}">
-                <a16:creationId xmlns:a16="http://schemas.microsoft.com/office/drawing/2014/main" id="{0E278041-AEAF-43A7-B3D3-A9FC56F62B38}"/>
+                <a16:creationId xmlns:a16="http://schemas.microsoft.com/office/drawing/2014/main" id="{CA29FC7C-8A41-4232-B75E-5A44543A94F3}"/>
               </a:ext>
             </a:extLst>
           </p:cNvPr>
@@ -4115,7 +3935,7 @@
           <p:cNvPr id="7" name="">
             <a:extLst xmlns:a="http://schemas.openxmlformats.org/drawingml/2006/main">
               <a:ext uri="{FF2B5EF4-FFF2-40B4-BE49-F238E27FC236}">
-                <a16:creationId xmlns:a16="http://schemas.microsoft.com/office/drawing/2014/main" id="{F2A7B790-B5DD-4F87-8338-4D507AF4D89D}"/>
+                <a16:creationId xmlns:a16="http://schemas.microsoft.com/office/drawing/2014/main" id="{AACF9C7E-531F-469B-9776-2AC227B9649F}"/>
               </a:ext>
             </a:extLst>
           </p:cNvPr>
@@ -4148,7 +3968,7 @@
           <p:cNvPr id="8" name="function-label-1">
             <a:extLst xmlns:a="http://schemas.openxmlformats.org/drawingml/2006/main">
               <a:ext uri="{FF2B5EF4-FFF2-40B4-BE49-F238E27FC236}">
-                <a16:creationId xmlns:a16="http://schemas.microsoft.com/office/drawing/2014/main" id="{7CAAABED-17AC-4E86-98A3-61F45B022F02}"/>
+                <a16:creationId xmlns:a16="http://schemas.microsoft.com/office/drawing/2014/main" id="{ADCC655C-A5F9-4822-B26A-2D33495D8BC1}"/>
               </a:ext>
             </a:extLst>
           </p:cNvPr>
@@ -4193,7 +4013,7 @@
           <p:cNvPr id="9" name="function-body-1">
             <a:extLst xmlns:a="http://schemas.openxmlformats.org/drawingml/2006/main">
               <a:ext uri="{FF2B5EF4-FFF2-40B4-BE49-F238E27FC236}">
-                <a16:creationId xmlns:a16="http://schemas.microsoft.com/office/drawing/2014/main" id="{288659ED-1FE9-416B-B291-A59228339071}"/>
+                <a16:creationId xmlns:a16="http://schemas.microsoft.com/office/drawing/2014/main" id="{CEBC7B93-E89A-45A1-A3A6-4C781E07B175}"/>
               </a:ext>
             </a:extLst>
           </p:cNvPr>
@@ -4238,7 +4058,7 @@
           <p:cNvPr id="10" name="">
             <a:extLst xmlns:a="http://schemas.openxmlformats.org/drawingml/2006/main">
               <a:ext uri="{FF2B5EF4-FFF2-40B4-BE49-F238E27FC236}">
-                <a16:creationId xmlns:a16="http://schemas.microsoft.com/office/drawing/2014/main" id="{847D17A9-0716-49C9-838C-427483AD231C}"/>
+                <a16:creationId xmlns:a16="http://schemas.microsoft.com/office/drawing/2014/main" id="{86A9246D-DDD3-4992-BB8F-999D60F994AA}"/>
               </a:ext>
             </a:extLst>
           </p:cNvPr>
@@ -4271,7 +4091,7 @@
           <p:cNvPr id="11" name="function-label-2">
             <a:extLst xmlns:a="http://schemas.openxmlformats.org/drawingml/2006/main">
               <a:ext uri="{FF2B5EF4-FFF2-40B4-BE49-F238E27FC236}">
-                <a16:creationId xmlns:a16="http://schemas.microsoft.com/office/drawing/2014/main" id="{B2C36705-E63F-4993-B9FA-18C7ED298684}"/>
+                <a16:creationId xmlns:a16="http://schemas.microsoft.com/office/drawing/2014/main" id="{6004E275-059D-4B4F-A58C-57FD2A7EC790}"/>
               </a:ext>
             </a:extLst>
           </p:cNvPr>
@@ -4316,7 +4136,7 @@
           <p:cNvPr id="12" name="function-body-2">
             <a:extLst xmlns:a="http://schemas.openxmlformats.org/drawingml/2006/main">
               <a:ext uri="{FF2B5EF4-FFF2-40B4-BE49-F238E27FC236}">
-                <a16:creationId xmlns:a16="http://schemas.microsoft.com/office/drawing/2014/main" id="{3036E94A-6D49-4A14-AC92-5D593768DE97}"/>
+                <a16:creationId xmlns:a16="http://schemas.microsoft.com/office/drawing/2014/main" id="{DC46AFDF-B13B-42AF-BE71-8CC437573A58}"/>
               </a:ext>
             </a:extLst>
           </p:cNvPr>
@@ -4361,7 +4181,7 @@
           <p:cNvPr id="13" name="">
             <a:extLst xmlns:a="http://schemas.openxmlformats.org/drawingml/2006/main">
               <a:ext uri="{FF2B5EF4-FFF2-40B4-BE49-F238E27FC236}">
-                <a16:creationId xmlns:a16="http://schemas.microsoft.com/office/drawing/2014/main" id="{8FC08A75-7806-42DB-9CCA-D5D199A930A4}"/>
+                <a16:creationId xmlns:a16="http://schemas.microsoft.com/office/drawing/2014/main" id="{E7F56BE5-31FB-4B43-9C57-1711F040140F}"/>
               </a:ext>
             </a:extLst>
           </p:cNvPr>
@@ -4394,7 +4214,7 @@
           <p:cNvPr id="14" name="function-label-3">
             <a:extLst xmlns:a="http://schemas.openxmlformats.org/drawingml/2006/main">
               <a:ext uri="{FF2B5EF4-FFF2-40B4-BE49-F238E27FC236}">
-                <a16:creationId xmlns:a16="http://schemas.microsoft.com/office/drawing/2014/main" id="{88875279-26E6-4EC3-A1FD-4787B2FFE8F3}"/>
+                <a16:creationId xmlns:a16="http://schemas.microsoft.com/office/drawing/2014/main" id="{E1F86DFC-C4F9-4DCC-BDEA-8AA0C32F320A}"/>
               </a:ext>
             </a:extLst>
           </p:cNvPr>
@@ -4439,7 +4259,7 @@
           <p:cNvPr id="15" name="function-body-3">
             <a:extLst xmlns:a="http://schemas.openxmlformats.org/drawingml/2006/main">
               <a:ext uri="{FF2B5EF4-FFF2-40B4-BE49-F238E27FC236}">
-                <a16:creationId xmlns:a16="http://schemas.microsoft.com/office/drawing/2014/main" id="{68852068-C81A-485B-912E-D74F47C67C5F}"/>
+                <a16:creationId xmlns:a16="http://schemas.microsoft.com/office/drawing/2014/main" id="{1720DB64-DCDD-444F-87F2-DD62343EE12E}"/>
               </a:ext>
             </a:extLst>
           </p:cNvPr>
@@ -4484,7 +4304,7 @@
           <p:cNvPr id="16" name="">
             <a:extLst xmlns:a="http://schemas.openxmlformats.org/drawingml/2006/main">
               <a:ext uri="{FF2B5EF4-FFF2-40B4-BE49-F238E27FC236}">
-                <a16:creationId xmlns:a16="http://schemas.microsoft.com/office/drawing/2014/main" id="{8FAC4A43-0279-4A2D-93E4-396B308D201F}"/>
+                <a16:creationId xmlns:a16="http://schemas.microsoft.com/office/drawing/2014/main" id="{F55635BC-E434-4FA6-8930-D66610A70911}"/>
               </a:ext>
             </a:extLst>
           </p:cNvPr>
@@ -4517,7 +4337,7 @@
           <p:cNvPr id="17" name="function-label-4">
             <a:extLst xmlns:a="http://schemas.openxmlformats.org/drawingml/2006/main">
               <a:ext uri="{FF2B5EF4-FFF2-40B4-BE49-F238E27FC236}">
-                <a16:creationId xmlns:a16="http://schemas.microsoft.com/office/drawing/2014/main" id="{89F3734A-98A5-4203-9FD5-C7537A0553FE}"/>
+                <a16:creationId xmlns:a16="http://schemas.microsoft.com/office/drawing/2014/main" id="{C80B90D5-BC68-4CCE-80FE-A55B5DAA77F9}"/>
               </a:ext>
             </a:extLst>
           </p:cNvPr>
@@ -4562,7 +4382,7 @@
           <p:cNvPr id="18" name="function-body-4">
             <a:extLst xmlns:a="http://schemas.openxmlformats.org/drawingml/2006/main">
               <a:ext uri="{FF2B5EF4-FFF2-40B4-BE49-F238E27FC236}">
-                <a16:creationId xmlns:a16="http://schemas.microsoft.com/office/drawing/2014/main" id="{A7242AF3-2DC6-49C5-B605-5347D6E09F06}"/>
+                <a16:creationId xmlns:a16="http://schemas.microsoft.com/office/drawing/2014/main" id="{EB192CA7-075E-4785-833A-A8305F6DC0AA}"/>
               </a:ext>
             </a:extLst>
           </p:cNvPr>
@@ -4607,7 +4427,7 @@
           <p:cNvPr id="19" name="">
             <a:extLst xmlns:a="http://schemas.openxmlformats.org/drawingml/2006/main">
               <a:ext uri="{FF2B5EF4-FFF2-40B4-BE49-F238E27FC236}">
-                <a16:creationId xmlns:a16="http://schemas.microsoft.com/office/drawing/2014/main" id="{56E154A8-DF91-41EE-9F84-925A9996BD6C}"/>
+                <a16:creationId xmlns:a16="http://schemas.microsoft.com/office/drawing/2014/main" id="{F15575BD-AF88-4536-BC57-63269D9648E2}"/>
               </a:ext>
             </a:extLst>
           </p:cNvPr>
@@ -4640,7 +4460,7 @@
           <p:cNvPr id="20" name="function-label-5">
             <a:extLst xmlns:a="http://schemas.openxmlformats.org/drawingml/2006/main">
               <a:ext uri="{FF2B5EF4-FFF2-40B4-BE49-F238E27FC236}">
-                <a16:creationId xmlns:a16="http://schemas.microsoft.com/office/drawing/2014/main" id="{3FB98256-6BF3-475A-9691-70096132DB33}"/>
+                <a16:creationId xmlns:a16="http://schemas.microsoft.com/office/drawing/2014/main" id="{7A9CDE9D-8BBC-4157-B57A-BA62AA45448F}"/>
               </a:ext>
             </a:extLst>
           </p:cNvPr>
@@ -4685,7 +4505,7 @@
           <p:cNvPr id="21" name="function-body-5">
             <a:extLst xmlns:a="http://schemas.openxmlformats.org/drawingml/2006/main">
               <a:ext uri="{FF2B5EF4-FFF2-40B4-BE49-F238E27FC236}">
-                <a16:creationId xmlns:a16="http://schemas.microsoft.com/office/drawing/2014/main" id="{DE16446C-2C25-4F6D-91AE-B4B526560844}"/>
+                <a16:creationId xmlns:a16="http://schemas.microsoft.com/office/drawing/2014/main" id="{E89F1973-D64E-4135-9284-7646BE247B64}"/>
               </a:ext>
             </a:extLst>
           </p:cNvPr>
@@ -4730,7 +4550,7 @@
           <p:cNvPr id="22" name="">
             <a:extLst xmlns:a="http://schemas.openxmlformats.org/drawingml/2006/main">
               <a:ext uri="{FF2B5EF4-FFF2-40B4-BE49-F238E27FC236}">
-                <a16:creationId xmlns:a16="http://schemas.microsoft.com/office/drawing/2014/main" id="{C48FF119-0D72-406E-9F10-6C1E0DA13A0C}"/>
+                <a16:creationId xmlns:a16="http://schemas.microsoft.com/office/drawing/2014/main" id="{FE3A373E-1750-4E3F-9384-FAF1FBD0AFA7}"/>
               </a:ext>
             </a:extLst>
           </p:cNvPr>
@@ -4773,7 +4593,7 @@
     </p:spTree>
     <p:extLst>
       <p:ext uri="{BB962C8B-B14F-4D97-AF65-F5344CB8AC3E}">
-        <p14:creationId xmlns:p14="http://schemas.microsoft.com/office/powerpoint/2010/main" val="1677565376"/>
+        <p14:creationId xmlns:p14="http://schemas.microsoft.com/office/powerpoint/2010/main" val="848012798"/>
       </p:ext>
     </p:extLst>
   </p:cSld>
@@ -4804,7 +4624,7 @@
           <p:cNvPr id="17" name="title-13">
             <a:extLst xmlns:a="http://schemas.openxmlformats.org/drawingml/2006/main">
               <a:ext uri="{FF2B5EF4-FFF2-40B4-BE49-F238E27FC236}">
-                <a16:creationId xmlns:a16="http://schemas.microsoft.com/office/drawing/2014/main" id="{20FA4F09-4964-4FD9-AEC1-230C54C9A95C}"/>
+                <a16:creationId xmlns:a16="http://schemas.microsoft.com/office/drawing/2014/main" id="{F06C8E2B-5E40-438B-8CF2-DFF0C596B22A}"/>
               </a:ext>
             </a:extLst>
           </p:cNvPr>
@@ -4849,7 +4669,7 @@
           <p:cNvPr id="2" name="source-13">
             <a:extLst xmlns:a="http://schemas.openxmlformats.org/drawingml/2006/main">
               <a:ext uri="{FF2B5EF4-FFF2-40B4-BE49-F238E27FC236}">
-                <a16:creationId xmlns:a16="http://schemas.microsoft.com/office/drawing/2014/main" id="{677DBD22-A5E5-4DB2-A162-3FE5CA4D03AE}"/>
+                <a16:creationId xmlns:a16="http://schemas.microsoft.com/office/drawing/2014/main" id="{A1480B6E-472A-48AE-940E-B2BA39A3883B}"/>
               </a:ext>
             </a:extLst>
           </p:cNvPr>
@@ -4894,7 +4714,7 @@
           <p:cNvPr id="3" name="page-13">
             <a:extLst xmlns:a="http://schemas.openxmlformats.org/drawingml/2006/main">
               <a:ext uri="{FF2B5EF4-FFF2-40B4-BE49-F238E27FC236}">
-                <a16:creationId xmlns:a16="http://schemas.microsoft.com/office/drawing/2014/main" id="{00055CC5-D9C5-4A29-B321-D8A10666D441}"/>
+                <a16:creationId xmlns:a16="http://schemas.microsoft.com/office/drawing/2014/main" id="{554F85FC-0785-40FD-B66A-B2725190C5A5}"/>
               </a:ext>
             </a:extLst>
           </p:cNvPr>
@@ -4939,7 +4759,7 @@
           <p:cNvPr id="4" name="">
             <a:extLst xmlns:a="http://schemas.openxmlformats.org/drawingml/2006/main">
               <a:ext uri="{FF2B5EF4-FFF2-40B4-BE49-F238E27FC236}">
-                <a16:creationId xmlns:a16="http://schemas.microsoft.com/office/drawing/2014/main" id="{CD40538F-7E7A-45A1-9A16-2E32189AFCB4}"/>
+                <a16:creationId xmlns:a16="http://schemas.microsoft.com/office/drawing/2014/main" id="{9B2DA5F8-796C-4A18-BF81-E52382CC137C}"/>
               </a:ext>
             </a:extLst>
           </p:cNvPr>
@@ -4984,7 +4804,7 @@
           <p:cNvPr id="5" name="discover-frame">
             <a:extLst xmlns:a="http://schemas.openxmlformats.org/drawingml/2006/main">
               <a:ext uri="{FF2B5EF4-FFF2-40B4-BE49-F238E27FC236}">
-                <a16:creationId xmlns:a16="http://schemas.microsoft.com/office/drawing/2014/main" id="{F1F7BBA3-BBBB-48E1-8FA7-F964AF0B590E}"/>
+                <a16:creationId xmlns:a16="http://schemas.microsoft.com/office/drawing/2014/main" id="{1F02F16E-B246-4E86-B35F-B52482FA4F85}"/>
               </a:ext>
             </a:extLst>
           </p:cNvPr>
@@ -5019,7 +4839,7 @@
           <p:cNvPr id="6" name="compare-frame">
             <a:extLst xmlns:a="http://schemas.openxmlformats.org/drawingml/2006/main">
               <a:ext uri="{FF2B5EF4-FFF2-40B4-BE49-F238E27FC236}">
-                <a16:creationId xmlns:a16="http://schemas.microsoft.com/office/drawing/2014/main" id="{1FF8CE41-1233-4E97-BE46-E5708D9F4963}"/>
+                <a16:creationId xmlns:a16="http://schemas.microsoft.com/office/drawing/2014/main" id="{5E249FA8-D5E6-4EEB-9945-6C931CE04AD2}"/>
               </a:ext>
             </a:extLst>
           </p:cNvPr>
@@ -5054,7 +4874,7 @@
           <p:cNvPr id="7" name="act-frame">
             <a:extLst xmlns:a="http://schemas.openxmlformats.org/drawingml/2006/main">
               <a:ext uri="{FF2B5EF4-FFF2-40B4-BE49-F238E27FC236}">
-                <a16:creationId xmlns:a16="http://schemas.microsoft.com/office/drawing/2014/main" id="{A5C1E794-EB67-4325-997F-B71364B8B05E}"/>
+                <a16:creationId xmlns:a16="http://schemas.microsoft.com/office/drawing/2014/main" id="{18C88550-9F44-436E-ACEE-B4BF01D967F2}"/>
               </a:ext>
             </a:extLst>
           </p:cNvPr>
@@ -5089,7 +4909,7 @@
           <p:cNvPr id="8" name="">
             <a:extLst xmlns:a="http://schemas.openxmlformats.org/drawingml/2006/main">
               <a:ext uri="{FF2B5EF4-FFF2-40B4-BE49-F238E27FC236}">
-                <a16:creationId xmlns:a16="http://schemas.microsoft.com/office/drawing/2014/main" id="{C3367883-109D-4A93-ABE8-16BAE6C79E96}"/>
+                <a16:creationId xmlns:a16="http://schemas.microsoft.com/office/drawing/2014/main" id="{8F7AAC4B-2136-478A-B3B6-0243FA4A4641}"/>
               </a:ext>
             </a:extLst>
           </p:cNvPr>
@@ -5134,7 +4954,7 @@
           <p:cNvPr id="9" name="">
             <a:extLst xmlns:a="http://schemas.openxmlformats.org/drawingml/2006/main">
               <a:ext uri="{FF2B5EF4-FFF2-40B4-BE49-F238E27FC236}">
-                <a16:creationId xmlns:a16="http://schemas.microsoft.com/office/drawing/2014/main" id="{35CA766A-E25A-465D-9D65-D6B6AB2DF258}"/>
+                <a16:creationId xmlns:a16="http://schemas.microsoft.com/office/drawing/2014/main" id="{F5CB3FBD-B6D6-4149-8B0D-CAE85C0FBB0B}"/>
               </a:ext>
             </a:extLst>
           </p:cNvPr>
@@ -5179,7 +4999,7 @@
           <p:cNvPr id="10" name="">
             <a:extLst xmlns:a="http://schemas.openxmlformats.org/drawingml/2006/main">
               <a:ext uri="{FF2B5EF4-FFF2-40B4-BE49-F238E27FC236}">
-                <a16:creationId xmlns:a16="http://schemas.microsoft.com/office/drawing/2014/main" id="{DA57E661-9E19-4270-A390-97C63070CF04}"/>
+                <a16:creationId xmlns:a16="http://schemas.microsoft.com/office/drawing/2014/main" id="{C3D1F3F8-F3CB-47AB-9F92-11880B3F08FF}"/>
               </a:ext>
             </a:extLst>
           </p:cNvPr>
@@ -5224,7 +5044,7 @@
           <p:cNvPr id="11" name="">
             <a:extLst xmlns:a="http://schemas.openxmlformats.org/drawingml/2006/main">
               <a:ext uri="{FF2B5EF4-FFF2-40B4-BE49-F238E27FC236}">
-                <a16:creationId xmlns:a16="http://schemas.microsoft.com/office/drawing/2014/main" id="{16CBCE1B-A57B-4147-AACB-DFC99C96141A}"/>
+                <a16:creationId xmlns:a16="http://schemas.microsoft.com/office/drawing/2014/main" id="{3BF89109-DF12-423D-83B2-979053C92B91}"/>
               </a:ext>
             </a:extLst>
           </p:cNvPr>
@@ -5269,7 +5089,7 @@
           <p:cNvPr id="12" name="">
             <a:extLst xmlns:a="http://schemas.openxmlformats.org/drawingml/2006/main">
               <a:ext uri="{FF2B5EF4-FFF2-40B4-BE49-F238E27FC236}">
-                <a16:creationId xmlns:a16="http://schemas.microsoft.com/office/drawing/2014/main" id="{8E25074D-869B-4BC4-A721-A5493A4BF154}"/>
+                <a16:creationId xmlns:a16="http://schemas.microsoft.com/office/drawing/2014/main" id="{444B725C-9B0D-4FC0-BD36-D4212BF197B4}"/>
               </a:ext>
             </a:extLst>
           </p:cNvPr>
@@ -5314,7 +5134,7 @@
           <p:cNvPr id="13" name="">
             <a:extLst xmlns:a="http://schemas.openxmlformats.org/drawingml/2006/main">
               <a:ext uri="{FF2B5EF4-FFF2-40B4-BE49-F238E27FC236}">
-                <a16:creationId xmlns:a16="http://schemas.microsoft.com/office/drawing/2014/main" id="{132D5236-D252-4FE1-937B-A3ACADC884BC}"/>
+                <a16:creationId xmlns:a16="http://schemas.microsoft.com/office/drawing/2014/main" id="{C4C1BD7A-2F0A-4DB0-AE44-FD98059B1067}"/>
               </a:ext>
             </a:extLst>
           </p:cNvPr>
@@ -5363,7 +5183,7 @@
           <p:nvPr/>
         </p:nvPicPr>
         <p:blipFill>
-          <a:blip xmlns:r="http://schemas.openxmlformats.org/officeDocument/2006/relationships" xmlns:a="http://schemas.openxmlformats.org/drawingml/2006/main" r:embed="R524db22c70ca44d7"/>
+          <a:blip xmlns:r="http://schemas.openxmlformats.org/officeDocument/2006/relationships" xmlns:a="http://schemas.openxmlformats.org/drawingml/2006/main" r:embed="Rfa480e9859b545ca"/>
           <a:stretch xmlns:a="http://schemas.openxmlformats.org/drawingml/2006/main"/>
         </p:blipFill>
         <p:spPr>
@@ -5385,7 +5205,7 @@
           <p:nvPr/>
         </p:nvPicPr>
         <p:blipFill>
-          <a:blip xmlns:r="http://schemas.openxmlformats.org/officeDocument/2006/relationships" xmlns:a="http://schemas.openxmlformats.org/drawingml/2006/main" r:embed="Rdde77bad22ac464b"/>
+          <a:blip xmlns:r="http://schemas.openxmlformats.org/officeDocument/2006/relationships" xmlns:a="http://schemas.openxmlformats.org/drawingml/2006/main" r:embed="R339e9be18d4b4fc2"/>
           <a:stretch xmlns:a="http://schemas.openxmlformats.org/drawingml/2006/main"/>
         </p:blipFill>
         <p:spPr>
@@ -5407,7 +5227,7 @@
           <p:nvPr/>
         </p:nvPicPr>
         <p:blipFill>
-          <a:blip xmlns:r="http://schemas.openxmlformats.org/officeDocument/2006/relationships" xmlns:a="http://schemas.openxmlformats.org/drawingml/2006/main" r:embed="R9ce85b34d8c74324"/>
+          <a:blip xmlns:r="http://schemas.openxmlformats.org/officeDocument/2006/relationships" xmlns:a="http://schemas.openxmlformats.org/drawingml/2006/main" r:embed="R68d91f42567143d1"/>
           <a:stretch xmlns:a="http://schemas.openxmlformats.org/drawingml/2006/main"/>
         </p:blipFill>
         <p:spPr>
@@ -5423,7 +5243,7 @@
     </p:spTree>
     <p:extLst>
       <p:ext uri="{BB962C8B-B14F-4D97-AF65-F5344CB8AC3E}">
-        <p14:creationId xmlns:p14="http://schemas.microsoft.com/office/powerpoint/2010/main" val="1594216235"/>
+        <p14:creationId xmlns:p14="http://schemas.microsoft.com/office/powerpoint/2010/main" val="40828440"/>
       </p:ext>
     </p:extLst>
   </p:cSld>
@@ -5454,7 +5274,7 @@
           <p:cNvPr id="6" name="">
             <a:extLst xmlns:a="http://schemas.openxmlformats.org/drawingml/2006/main">
               <a:ext uri="{FF2B5EF4-FFF2-40B4-BE49-F238E27FC236}">
-                <a16:creationId xmlns:a16="http://schemas.microsoft.com/office/drawing/2014/main" id="{4A36B826-4EA9-4832-9688-7AE85070FDF8}"/>
+                <a16:creationId xmlns:a16="http://schemas.microsoft.com/office/drawing/2014/main" id="{6700F50F-23FE-46F9-A3B2-7EDE075142A4}"/>
               </a:ext>
             </a:extLst>
           </p:cNvPr>
@@ -5499,7 +5319,7 @@
           <p:cNvPr id="2" name="">
             <a:extLst xmlns:a="http://schemas.openxmlformats.org/drawingml/2006/main">
               <a:ext uri="{FF2B5EF4-FFF2-40B4-BE49-F238E27FC236}">
-                <a16:creationId xmlns:a16="http://schemas.microsoft.com/office/drawing/2014/main" id="{66F468D2-4569-4163-978C-C4B3346EB790}"/>
+                <a16:creationId xmlns:a16="http://schemas.microsoft.com/office/drawing/2014/main" id="{BB6DCFC8-E69A-4D48-8987-3C04F172C703}"/>
               </a:ext>
             </a:extLst>
           </p:cNvPr>
@@ -5544,7 +5364,7 @@
           <p:cNvPr id="3" name="">
             <a:extLst xmlns:a="http://schemas.openxmlformats.org/drawingml/2006/main">
               <a:ext uri="{FF2B5EF4-FFF2-40B4-BE49-F238E27FC236}">
-                <a16:creationId xmlns:a16="http://schemas.microsoft.com/office/drawing/2014/main" id="{6B40E2E5-B176-45BC-9C51-3F03988EC340}"/>
+                <a16:creationId xmlns:a16="http://schemas.microsoft.com/office/drawing/2014/main" id="{45806443-9BE8-4D2D-817A-361EA09D2CE0}"/>
               </a:ext>
             </a:extLst>
           </p:cNvPr>
@@ -5589,7 +5409,7 @@
           <p:cNvPr id="4" name="source-14">
             <a:extLst xmlns:a="http://schemas.openxmlformats.org/drawingml/2006/main">
               <a:ext uri="{FF2B5EF4-FFF2-40B4-BE49-F238E27FC236}">
-                <a16:creationId xmlns:a16="http://schemas.microsoft.com/office/drawing/2014/main" id="{C54FAAAB-8876-4F19-9EA3-A225146E537E}"/>
+                <a16:creationId xmlns:a16="http://schemas.microsoft.com/office/drawing/2014/main" id="{F4709044-4352-437E-9C49-8D6F6C627FEA}"/>
               </a:ext>
             </a:extLst>
           </p:cNvPr>
@@ -5634,7 +5454,7 @@
           <p:cNvPr id="5" name="page-14">
             <a:extLst xmlns:a="http://schemas.openxmlformats.org/drawingml/2006/main">
               <a:ext uri="{FF2B5EF4-FFF2-40B4-BE49-F238E27FC236}">
-                <a16:creationId xmlns:a16="http://schemas.microsoft.com/office/drawing/2014/main" id="{FEF6C5BE-CE36-4137-87D4-AB39BF06CCB1}"/>
+                <a16:creationId xmlns:a16="http://schemas.microsoft.com/office/drawing/2014/main" id="{B1DFEE2A-900D-4BAB-935E-819C38F19892}"/>
               </a:ext>
             </a:extLst>
           </p:cNvPr>
@@ -5677,7 +5497,7 @@
     </p:spTree>
     <p:extLst>
       <p:ext uri="{BB962C8B-B14F-4D97-AF65-F5344CB8AC3E}">
-        <p14:creationId xmlns:p14="http://schemas.microsoft.com/office/powerpoint/2010/main" val="420684107"/>
+        <p14:creationId xmlns:p14="http://schemas.microsoft.com/office/powerpoint/2010/main" val="198294646"/>
       </p:ext>
     </p:extLst>
   </p:cSld>
@@ -5708,7 +5528,7 @@
           <p:cNvPr id="23" name="title-2">
             <a:extLst xmlns:a="http://schemas.openxmlformats.org/drawingml/2006/main">
               <a:ext uri="{FF2B5EF4-FFF2-40B4-BE49-F238E27FC236}">
-                <a16:creationId xmlns:a16="http://schemas.microsoft.com/office/drawing/2014/main" id="{ECE4F01C-F733-4CAA-B651-560D5BADED55}"/>
+                <a16:creationId xmlns:a16="http://schemas.microsoft.com/office/drawing/2014/main" id="{32242316-F572-477A-AAE8-1252ACEE1C46}"/>
               </a:ext>
             </a:extLst>
           </p:cNvPr>
@@ -5753,7 +5573,7 @@
           <p:cNvPr id="2" name="source-2">
             <a:extLst xmlns:a="http://schemas.openxmlformats.org/drawingml/2006/main">
               <a:ext uri="{FF2B5EF4-FFF2-40B4-BE49-F238E27FC236}">
-                <a16:creationId xmlns:a16="http://schemas.microsoft.com/office/drawing/2014/main" id="{FD41CD31-1898-416D-AA34-0EA4EAC2D645}"/>
+                <a16:creationId xmlns:a16="http://schemas.microsoft.com/office/drawing/2014/main" id="{7E822BD4-3981-40F8-BE44-23943D0C01DC}"/>
               </a:ext>
             </a:extLst>
           </p:cNvPr>
@@ -5798,7 +5618,7 @@
           <p:cNvPr id="3" name="page-2">
             <a:extLst xmlns:a="http://schemas.openxmlformats.org/drawingml/2006/main">
               <a:ext uri="{FF2B5EF4-FFF2-40B4-BE49-F238E27FC236}">
-                <a16:creationId xmlns:a16="http://schemas.microsoft.com/office/drawing/2014/main" id="{3C0B3A2C-F3E7-441F-B198-A66869DA5DB2}"/>
+                <a16:creationId xmlns:a16="http://schemas.microsoft.com/office/drawing/2014/main" id="{24DF8E22-6617-45CC-A888-283DACE4F551}"/>
               </a:ext>
             </a:extLst>
           </p:cNvPr>
@@ -5843,7 +5663,7 @@
           <p:cNvPr id="4" name="epq-artifact-frame">
             <a:extLst xmlns:a="http://schemas.openxmlformats.org/drawingml/2006/main">
               <a:ext uri="{FF2B5EF4-FFF2-40B4-BE49-F238E27FC236}">
-                <a16:creationId xmlns:a16="http://schemas.microsoft.com/office/drawing/2014/main" id="{C3398C91-213A-4A5D-B49B-01CE215D34BC}"/>
+                <a16:creationId xmlns:a16="http://schemas.microsoft.com/office/drawing/2014/main" id="{38648F29-FF1F-4FD9-B5BB-728E09F3908C}"/>
               </a:ext>
             </a:extLst>
           </p:cNvPr>
@@ -5878,7 +5698,7 @@
           <p:cNvPr id="5" name="undergrad-artifact-frame">
             <a:extLst xmlns:a="http://schemas.openxmlformats.org/drawingml/2006/main">
               <a:ext uri="{FF2B5EF4-FFF2-40B4-BE49-F238E27FC236}">
-                <a16:creationId xmlns:a16="http://schemas.microsoft.com/office/drawing/2014/main" id="{7D458F7B-B445-4929-9382-5EDA35BBA401}"/>
+                <a16:creationId xmlns:a16="http://schemas.microsoft.com/office/drawing/2014/main" id="{31194158-DB9C-4768-B4D9-2EC2476384DB}"/>
               </a:ext>
             </a:extLst>
           </p:cNvPr>
@@ -5913,7 +5733,7 @@
           <p:cNvPr id="6" name="product-artifact-frame">
             <a:extLst xmlns:a="http://schemas.openxmlformats.org/drawingml/2006/main">
               <a:ext uri="{FF2B5EF4-FFF2-40B4-BE49-F238E27FC236}">
-                <a16:creationId xmlns:a16="http://schemas.microsoft.com/office/drawing/2014/main" id="{DD5F596E-B6AC-4B06-A2BE-83B5050FB0D1}"/>
+                <a16:creationId xmlns:a16="http://schemas.microsoft.com/office/drawing/2014/main" id="{25CAFF73-14E2-46B7-80A6-5A8A37F03EAF}"/>
               </a:ext>
             </a:extLst>
           </p:cNvPr>
@@ -5948,7 +5768,7 @@
           <p:cNvPr id="7" name="">
             <a:extLst xmlns:a="http://schemas.openxmlformats.org/drawingml/2006/main">
               <a:ext uri="{FF2B5EF4-FFF2-40B4-BE49-F238E27FC236}">
-                <a16:creationId xmlns:a16="http://schemas.microsoft.com/office/drawing/2014/main" id="{2E11E5A0-841C-42B1-B6A3-4E32D45CBF7D}"/>
+                <a16:creationId xmlns:a16="http://schemas.microsoft.com/office/drawing/2014/main" id="{5F1A800E-AAA8-4B2E-B665-A549AD76C788}"/>
               </a:ext>
             </a:extLst>
           </p:cNvPr>
@@ -5981,7 +5801,7 @@
           <p:cNvPr id="8" name="">
             <a:extLst xmlns:a="http://schemas.openxmlformats.org/drawingml/2006/main">
               <a:ext uri="{FF2B5EF4-FFF2-40B4-BE49-F238E27FC236}">
-                <a16:creationId xmlns:a16="http://schemas.microsoft.com/office/drawing/2014/main" id="{4B292574-AEAE-4BD8-B143-463CC062A735}"/>
+                <a16:creationId xmlns:a16="http://schemas.microsoft.com/office/drawing/2014/main" id="{B710E218-8546-44BB-8DAD-7229C2E3707A}"/>
               </a:ext>
             </a:extLst>
           </p:cNvPr>
@@ -6014,7 +5834,7 @@
           <p:cNvPr id="9" name="">
             <a:extLst xmlns:a="http://schemas.openxmlformats.org/drawingml/2006/main">
               <a:ext uri="{FF2B5EF4-FFF2-40B4-BE49-F238E27FC236}">
-                <a16:creationId xmlns:a16="http://schemas.microsoft.com/office/drawing/2014/main" id="{43C95122-092B-4D97-B939-6749DC7487D5}"/>
+                <a16:creationId xmlns:a16="http://schemas.microsoft.com/office/drawing/2014/main" id="{EE1FA9B5-AAE4-44D5-9B65-0DDF2E044FB0}"/>
               </a:ext>
             </a:extLst>
           </p:cNvPr>
@@ -6047,7 +5867,7 @@
           <p:cNvPr id="10" name="">
             <a:extLst xmlns:a="http://schemas.openxmlformats.org/drawingml/2006/main">
               <a:ext uri="{FF2B5EF4-FFF2-40B4-BE49-F238E27FC236}">
-                <a16:creationId xmlns:a16="http://schemas.microsoft.com/office/drawing/2014/main" id="{6B26721A-EEA2-4E4B-8CC5-59D0637794C4}"/>
+                <a16:creationId xmlns:a16="http://schemas.microsoft.com/office/drawing/2014/main" id="{FE4F48CB-C928-4DC8-B040-CEBDA9E142CF}"/>
               </a:ext>
             </a:extLst>
           </p:cNvPr>
@@ -6080,7 +5900,7 @@
           <p:cNvPr id="11" name="">
             <a:extLst xmlns:a="http://schemas.openxmlformats.org/drawingml/2006/main">
               <a:ext uri="{FF2B5EF4-FFF2-40B4-BE49-F238E27FC236}">
-                <a16:creationId xmlns:a16="http://schemas.microsoft.com/office/drawing/2014/main" id="{20F31743-7A1F-413D-B19D-D2CC87992204}"/>
+                <a16:creationId xmlns:a16="http://schemas.microsoft.com/office/drawing/2014/main" id="{0ABF5FA9-C996-4582-A583-5433F0376988}"/>
               </a:ext>
             </a:extLst>
           </p:cNvPr>
@@ -6125,7 +5945,7 @@
           <p:cNvPr id="12" name="">
             <a:extLst xmlns:a="http://schemas.openxmlformats.org/drawingml/2006/main">
               <a:ext uri="{FF2B5EF4-FFF2-40B4-BE49-F238E27FC236}">
-                <a16:creationId xmlns:a16="http://schemas.microsoft.com/office/drawing/2014/main" id="{9968A141-D8B1-42D0-96A1-06DB29310916}"/>
+                <a16:creationId xmlns:a16="http://schemas.microsoft.com/office/drawing/2014/main" id="{FCA5D7C3-B197-4A91-969E-163CF4CB1D6D}"/>
               </a:ext>
             </a:extLst>
           </p:cNvPr>
@@ -6170,7 +5990,7 @@
           <p:cNvPr id="13" name="">
             <a:extLst xmlns:a="http://schemas.openxmlformats.org/drawingml/2006/main">
               <a:ext uri="{FF2B5EF4-FFF2-40B4-BE49-F238E27FC236}">
-                <a16:creationId xmlns:a16="http://schemas.microsoft.com/office/drawing/2014/main" id="{08BB1C03-A466-4602-A7DA-B7C910043814}"/>
+                <a16:creationId xmlns:a16="http://schemas.microsoft.com/office/drawing/2014/main" id="{52C3C9D8-AF44-48D3-BDB3-058517497F44}"/>
               </a:ext>
             </a:extLst>
           </p:cNvPr>
@@ -6215,7 +6035,7 @@
           <p:cNvPr id="14" name="">
             <a:extLst xmlns:a="http://schemas.openxmlformats.org/drawingml/2006/main">
               <a:ext uri="{FF2B5EF4-FFF2-40B4-BE49-F238E27FC236}">
-                <a16:creationId xmlns:a16="http://schemas.microsoft.com/office/drawing/2014/main" id="{CB07C352-E7E4-4EDF-AFF6-6CFED9E67744}"/>
+                <a16:creationId xmlns:a16="http://schemas.microsoft.com/office/drawing/2014/main" id="{7F7AA511-6591-449F-9C59-79EA89B9EDE6}"/>
               </a:ext>
             </a:extLst>
           </p:cNvPr>
@@ -6260,7 +6080,7 @@
           <p:cNvPr id="15" name="">
             <a:extLst xmlns:a="http://schemas.openxmlformats.org/drawingml/2006/main">
               <a:ext uri="{FF2B5EF4-FFF2-40B4-BE49-F238E27FC236}">
-                <a16:creationId xmlns:a16="http://schemas.microsoft.com/office/drawing/2014/main" id="{89A39CB0-A0D1-4E01-BDF3-841B8A45B6FB}"/>
+                <a16:creationId xmlns:a16="http://schemas.microsoft.com/office/drawing/2014/main" id="{9734D993-0899-46E4-B7FA-990FB21D4D0F}"/>
               </a:ext>
             </a:extLst>
           </p:cNvPr>
@@ -6305,7 +6125,7 @@
           <p:cNvPr id="16" name="">
             <a:extLst xmlns:a="http://schemas.openxmlformats.org/drawingml/2006/main">
               <a:ext uri="{FF2B5EF4-FFF2-40B4-BE49-F238E27FC236}">
-                <a16:creationId xmlns:a16="http://schemas.microsoft.com/office/drawing/2014/main" id="{30735BB3-B6CA-4861-BA06-D93BFAD20AB6}"/>
+                <a16:creationId xmlns:a16="http://schemas.microsoft.com/office/drawing/2014/main" id="{0C84B629-4865-4EC5-AADA-7003F1B54FD8}"/>
               </a:ext>
             </a:extLst>
           </p:cNvPr>
@@ -6350,7 +6170,7 @@
           <p:cNvPr id="17" name="">
             <a:extLst xmlns:a="http://schemas.openxmlformats.org/drawingml/2006/main">
               <a:ext uri="{FF2B5EF4-FFF2-40B4-BE49-F238E27FC236}">
-                <a16:creationId xmlns:a16="http://schemas.microsoft.com/office/drawing/2014/main" id="{2C15A763-DC53-4608-BEEF-E71EBE974BCF}"/>
+                <a16:creationId xmlns:a16="http://schemas.microsoft.com/office/drawing/2014/main" id="{96E60634-1531-423C-8F25-0BEF8D416C27}"/>
               </a:ext>
             </a:extLst>
           </p:cNvPr>
@@ -6395,7 +6215,7 @@
           <p:cNvPr id="18" name="">
             <a:extLst xmlns:a="http://schemas.openxmlformats.org/drawingml/2006/main">
               <a:ext uri="{FF2B5EF4-FFF2-40B4-BE49-F238E27FC236}">
-                <a16:creationId xmlns:a16="http://schemas.microsoft.com/office/drawing/2014/main" id="{C33A4721-4214-40F6-B6D3-444A16ADC111}"/>
+                <a16:creationId xmlns:a16="http://schemas.microsoft.com/office/drawing/2014/main" id="{2403BCF3-798F-46E2-A085-6F97A8016DD2}"/>
               </a:ext>
             </a:extLst>
           </p:cNvPr>
@@ -6440,7 +6260,7 @@
           <p:cNvPr id="19" name="">
             <a:extLst xmlns:a="http://schemas.openxmlformats.org/drawingml/2006/main">
               <a:ext uri="{FF2B5EF4-FFF2-40B4-BE49-F238E27FC236}">
-                <a16:creationId xmlns:a16="http://schemas.microsoft.com/office/drawing/2014/main" id="{3F6E97E0-602B-4C9B-8DB4-78E97DF235E4}"/>
+                <a16:creationId xmlns:a16="http://schemas.microsoft.com/office/drawing/2014/main" id="{F42D555E-02BB-42E0-8444-4D6733D0C89F}"/>
               </a:ext>
             </a:extLst>
           </p:cNvPr>
@@ -6489,7 +6309,7 @@
           <p:nvPr/>
         </p:nvPicPr>
         <p:blipFill>
-          <a:blip xmlns:r="http://schemas.openxmlformats.org/officeDocument/2006/relationships" xmlns:a="http://schemas.openxmlformats.org/drawingml/2006/main" r:embed="R504d065aa1194774"/>
+          <a:blip xmlns:r="http://schemas.openxmlformats.org/officeDocument/2006/relationships" xmlns:a="http://schemas.openxmlformats.org/drawingml/2006/main" r:embed="R53168a6f364c49b1"/>
           <a:stretch xmlns:a="http://schemas.openxmlformats.org/drawingml/2006/main"/>
         </p:blipFill>
         <p:spPr>
@@ -6511,7 +6331,7 @@
           <p:nvPr/>
         </p:nvPicPr>
         <p:blipFill>
-          <a:blip xmlns:r="http://schemas.openxmlformats.org/officeDocument/2006/relationships" xmlns:a="http://schemas.openxmlformats.org/drawingml/2006/main" r:embed="Ra0d7010bb8214d38"/>
+          <a:blip xmlns:r="http://schemas.openxmlformats.org/officeDocument/2006/relationships" xmlns:a="http://schemas.openxmlformats.org/drawingml/2006/main" r:embed="R3b2db10967eb4eb8"/>
           <a:stretch xmlns:a="http://schemas.openxmlformats.org/drawingml/2006/main"/>
         </p:blipFill>
         <p:spPr>
@@ -6533,7 +6353,7 @@
           <p:nvPr/>
         </p:nvPicPr>
         <p:blipFill>
-          <a:blip xmlns:r="http://schemas.openxmlformats.org/officeDocument/2006/relationships" xmlns:a="http://schemas.openxmlformats.org/drawingml/2006/main" r:embed="Re003de17efce46de"/>
+          <a:blip xmlns:r="http://schemas.openxmlformats.org/officeDocument/2006/relationships" xmlns:a="http://schemas.openxmlformats.org/drawingml/2006/main" r:embed="Rf1d3f528c62646ec"/>
           <a:srcRect xmlns:a="http://schemas.openxmlformats.org/drawingml/2006/main" l="0" t="19720" r="0" b="19720"/>
           <a:stretch xmlns:a="http://schemas.openxmlformats.org/drawingml/2006/main">
             <a:fillRect l="0" t="0" r="0" b="0"/>
@@ -6552,7 +6372,7 @@
     </p:spTree>
     <p:extLst>
       <p:ext uri="{BB962C8B-B14F-4D97-AF65-F5344CB8AC3E}">
-        <p14:creationId xmlns:p14="http://schemas.microsoft.com/office/powerpoint/2010/main" val="1329469549"/>
+        <p14:creationId xmlns:p14="http://schemas.microsoft.com/office/powerpoint/2010/main" val="1252717686"/>
       </p:ext>
     </p:extLst>
   </p:cSld>
@@ -6583,7 +6403,7 @@
           <p:cNvPr id="18" name="title-3">
             <a:extLst xmlns:a="http://schemas.openxmlformats.org/drawingml/2006/main">
               <a:ext uri="{FF2B5EF4-FFF2-40B4-BE49-F238E27FC236}">
-                <a16:creationId xmlns:a16="http://schemas.microsoft.com/office/drawing/2014/main" id="{F53A5FD6-9FBB-41A9-B7E9-B8E105FECE34}"/>
+                <a16:creationId xmlns:a16="http://schemas.microsoft.com/office/drawing/2014/main" id="{9F708D5E-558B-4EC3-B210-0AE4BD04D40C}"/>
               </a:ext>
             </a:extLst>
           </p:cNvPr>
@@ -6628,7 +6448,7 @@
           <p:cNvPr id="2" name="source-3">
             <a:extLst xmlns:a="http://schemas.openxmlformats.org/drawingml/2006/main">
               <a:ext uri="{FF2B5EF4-FFF2-40B4-BE49-F238E27FC236}">
-                <a16:creationId xmlns:a16="http://schemas.microsoft.com/office/drawing/2014/main" id="{F04F8E35-48FC-4E04-AB76-3484C71159EC}"/>
+                <a16:creationId xmlns:a16="http://schemas.microsoft.com/office/drawing/2014/main" id="{A4233B2E-5F5F-4290-B341-356B677116A4}"/>
               </a:ext>
             </a:extLst>
           </p:cNvPr>
@@ -6673,7 +6493,7 @@
           <p:cNvPr id="3" name="page-3">
             <a:extLst xmlns:a="http://schemas.openxmlformats.org/drawingml/2006/main">
               <a:ext uri="{FF2B5EF4-FFF2-40B4-BE49-F238E27FC236}">
-                <a16:creationId xmlns:a16="http://schemas.microsoft.com/office/drawing/2014/main" id="{40BA94E2-C53C-46C2-9DA0-6BFC29D4FB44}"/>
+                <a16:creationId xmlns:a16="http://schemas.microsoft.com/office/drawing/2014/main" id="{79708B49-E7CB-4CCC-8145-966965F9AB66}"/>
               </a:ext>
             </a:extLst>
           </p:cNvPr>
@@ -6718,7 +6538,7 @@
           <p:cNvPr id="4" name="">
             <a:extLst xmlns:a="http://schemas.openxmlformats.org/drawingml/2006/main">
               <a:ext uri="{FF2B5EF4-FFF2-40B4-BE49-F238E27FC236}">
-                <a16:creationId xmlns:a16="http://schemas.microsoft.com/office/drawing/2014/main" id="{B6C857DA-4C72-4038-A274-19AAA1317498}"/>
+                <a16:creationId xmlns:a16="http://schemas.microsoft.com/office/drawing/2014/main" id="{7596EE46-394A-49AB-A005-75643F2B3DCB}"/>
               </a:ext>
             </a:extLst>
           </p:cNvPr>
@@ -6763,7 +6583,7 @@
           <p:cNvPr id="5" name="">
             <a:extLst xmlns:a="http://schemas.openxmlformats.org/drawingml/2006/main">
               <a:ext uri="{FF2B5EF4-FFF2-40B4-BE49-F238E27FC236}">
-                <a16:creationId xmlns:a16="http://schemas.microsoft.com/office/drawing/2014/main" id="{5AC0022A-79FD-4DEF-8034-A50DB3BA4950}"/>
+                <a16:creationId xmlns:a16="http://schemas.microsoft.com/office/drawing/2014/main" id="{B758CA7F-B1BC-48AA-8624-F1419C5D6909}"/>
               </a:ext>
             </a:extLst>
           </p:cNvPr>
@@ -6808,7 +6628,7 @@
           <p:cNvPr id="6" name="">
             <a:extLst xmlns:a="http://schemas.openxmlformats.org/drawingml/2006/main">
               <a:ext uri="{FF2B5EF4-FFF2-40B4-BE49-F238E27FC236}">
-                <a16:creationId xmlns:a16="http://schemas.microsoft.com/office/drawing/2014/main" id="{496A2D60-0CF4-4D24-BA80-280BC53E0862}"/>
+                <a16:creationId xmlns:a16="http://schemas.microsoft.com/office/drawing/2014/main" id="{3EB3DD4D-834F-4EF8-A89D-C2410F22188D}"/>
               </a:ext>
             </a:extLst>
           </p:cNvPr>
@@ -6857,7 +6677,7 @@
           <p:cNvPr id="7" name="">
             <a:extLst xmlns:a="http://schemas.openxmlformats.org/drawingml/2006/main">
               <a:ext uri="{FF2B5EF4-FFF2-40B4-BE49-F238E27FC236}">
-                <a16:creationId xmlns:a16="http://schemas.microsoft.com/office/drawing/2014/main" id="{064C7F31-AB07-47A5-97E8-405D8920BD5C}"/>
+                <a16:creationId xmlns:a16="http://schemas.microsoft.com/office/drawing/2014/main" id="{B673D159-4088-4C85-BA6A-16CC947F81B5}"/>
               </a:ext>
             </a:extLst>
           </p:cNvPr>
@@ -6890,7 +6710,7 @@
           <p:cNvPr id="8" name="">
             <a:extLst xmlns:a="http://schemas.openxmlformats.org/drawingml/2006/main">
               <a:ext uri="{FF2B5EF4-FFF2-40B4-BE49-F238E27FC236}">
-                <a16:creationId xmlns:a16="http://schemas.microsoft.com/office/drawing/2014/main" id="{69BAC046-82F3-47E2-900C-0ADE7C4C8D6D}"/>
+                <a16:creationId xmlns:a16="http://schemas.microsoft.com/office/drawing/2014/main" id="{31B0D4AE-8487-4904-A776-75B2A03AAB45}"/>
               </a:ext>
             </a:extLst>
           </p:cNvPr>
@@ -6935,7 +6755,7 @@
           <p:cNvPr id="9" name="">
             <a:extLst xmlns:a="http://schemas.openxmlformats.org/drawingml/2006/main">
               <a:ext uri="{FF2B5EF4-FFF2-40B4-BE49-F238E27FC236}">
-                <a16:creationId xmlns:a16="http://schemas.microsoft.com/office/drawing/2014/main" id="{1E6A8F1A-D90A-4C6B-86BD-45903DAF5535}"/>
+                <a16:creationId xmlns:a16="http://schemas.microsoft.com/office/drawing/2014/main" id="{54883A03-7E64-4902-B1F4-F1109C285294}"/>
               </a:ext>
             </a:extLst>
           </p:cNvPr>
@@ -6980,7 +6800,7 @@
           <p:cNvPr id="10" name="">
             <a:extLst xmlns:a="http://schemas.openxmlformats.org/drawingml/2006/main">
               <a:ext uri="{FF2B5EF4-FFF2-40B4-BE49-F238E27FC236}">
-                <a16:creationId xmlns:a16="http://schemas.microsoft.com/office/drawing/2014/main" id="{857B15FF-083F-44F9-A1FC-DD0356ACFBD9}"/>
+                <a16:creationId xmlns:a16="http://schemas.microsoft.com/office/drawing/2014/main" id="{3613870E-54D2-42CD-8FA2-AD90F4F0F3C5}"/>
               </a:ext>
             </a:extLst>
           </p:cNvPr>
@@ -7025,7 +6845,7 @@
           <p:cNvPr id="11" name="">
             <a:extLst xmlns:a="http://schemas.openxmlformats.org/drawingml/2006/main">
               <a:ext uri="{FF2B5EF4-FFF2-40B4-BE49-F238E27FC236}">
-                <a16:creationId xmlns:a16="http://schemas.microsoft.com/office/drawing/2014/main" id="{A7220EBB-7110-41E0-8F90-2006CA88726B}"/>
+                <a16:creationId xmlns:a16="http://schemas.microsoft.com/office/drawing/2014/main" id="{BCEF70C4-A472-49DA-ADF3-B2B880053CA9}"/>
               </a:ext>
             </a:extLst>
           </p:cNvPr>
@@ -7070,7 +6890,7 @@
           <p:cNvPr id="12" name="">
             <a:extLst xmlns:a="http://schemas.openxmlformats.org/drawingml/2006/main">
               <a:ext uri="{FF2B5EF4-FFF2-40B4-BE49-F238E27FC236}">
-                <a16:creationId xmlns:a16="http://schemas.microsoft.com/office/drawing/2014/main" id="{CF8DD425-8502-41BE-8917-300AF0D8A9D4}"/>
+                <a16:creationId xmlns:a16="http://schemas.microsoft.com/office/drawing/2014/main" id="{900F4A4A-EECF-47C2-B5D8-EC191D3C4801}"/>
               </a:ext>
             </a:extLst>
           </p:cNvPr>
@@ -7115,7 +6935,7 @@
           <p:cNvPr id="13" name="">
             <a:extLst xmlns:a="http://schemas.openxmlformats.org/drawingml/2006/main">
               <a:ext uri="{FF2B5EF4-FFF2-40B4-BE49-F238E27FC236}">
-                <a16:creationId xmlns:a16="http://schemas.microsoft.com/office/drawing/2014/main" id="{B5A85FB0-B645-4660-B285-A732A93C75A9}"/>
+                <a16:creationId xmlns:a16="http://schemas.microsoft.com/office/drawing/2014/main" id="{7BA26909-C861-4341-AE58-CE2C792A563B}"/>
               </a:ext>
             </a:extLst>
           </p:cNvPr>
@@ -7160,7 +6980,7 @@
           <p:cNvPr id="14" name="">
             <a:extLst xmlns:a="http://schemas.openxmlformats.org/drawingml/2006/main">
               <a:ext uri="{FF2B5EF4-FFF2-40B4-BE49-F238E27FC236}">
-                <a16:creationId xmlns:a16="http://schemas.microsoft.com/office/drawing/2014/main" id="{C1E841EC-5146-4AB2-A910-F008BEC8BA83}"/>
+                <a16:creationId xmlns:a16="http://schemas.microsoft.com/office/drawing/2014/main" id="{A55844D0-C6A9-4C01-B2C4-55A28F172F3D}"/>
               </a:ext>
             </a:extLst>
           </p:cNvPr>
@@ -7205,7 +7025,7 @@
           <p:cNvPr id="15" name="">
             <a:extLst xmlns:a="http://schemas.openxmlformats.org/drawingml/2006/main">
               <a:ext uri="{FF2B5EF4-FFF2-40B4-BE49-F238E27FC236}">
-                <a16:creationId xmlns:a16="http://schemas.microsoft.com/office/drawing/2014/main" id="{358F21D1-7086-460E-B652-89374F208FCD}"/>
+                <a16:creationId xmlns:a16="http://schemas.microsoft.com/office/drawing/2014/main" id="{28029581-96D8-4C78-9AB5-80003CEFEE30}"/>
               </a:ext>
             </a:extLst>
           </p:cNvPr>
@@ -7250,7 +7070,7 @@
           <p:cNvPr id="16" name="">
             <a:extLst xmlns:a="http://schemas.openxmlformats.org/drawingml/2006/main">
               <a:ext uri="{FF2B5EF4-FFF2-40B4-BE49-F238E27FC236}">
-                <a16:creationId xmlns:a16="http://schemas.microsoft.com/office/drawing/2014/main" id="{A01DDED5-AD9D-4B89-8CE5-1F0A1B72393F}"/>
+                <a16:creationId xmlns:a16="http://schemas.microsoft.com/office/drawing/2014/main" id="{D7A309D8-240F-42B5-8D8A-FAF699D288B2}"/>
               </a:ext>
             </a:extLst>
           </p:cNvPr>
@@ -7295,7 +7115,7 @@
           <p:cNvPr id="17" name="">
             <a:extLst xmlns:a="http://schemas.openxmlformats.org/drawingml/2006/main">
               <a:ext uri="{FF2B5EF4-FFF2-40B4-BE49-F238E27FC236}">
-                <a16:creationId xmlns:a16="http://schemas.microsoft.com/office/drawing/2014/main" id="{0B8D883A-CF87-4AE5-8622-966D98757C56}"/>
+                <a16:creationId xmlns:a16="http://schemas.microsoft.com/office/drawing/2014/main" id="{513BCE08-4367-4E6D-B356-060F2C17C0C3}"/>
               </a:ext>
             </a:extLst>
           </p:cNvPr>
@@ -7338,7 +7158,7 @@
     </p:spTree>
     <p:extLst>
       <p:ext uri="{BB962C8B-B14F-4D97-AF65-F5344CB8AC3E}">
-        <p14:creationId xmlns:p14="http://schemas.microsoft.com/office/powerpoint/2010/main" val="1385820512"/>
+        <p14:creationId xmlns:p14="http://schemas.microsoft.com/office/powerpoint/2010/main" val="1994853788"/>
       </p:ext>
     </p:extLst>
   </p:cSld>
@@ -7369,7 +7189,7 @@
           <p:cNvPr id="27" name="title-4">
             <a:extLst xmlns:a="http://schemas.openxmlformats.org/drawingml/2006/main">
               <a:ext uri="{FF2B5EF4-FFF2-40B4-BE49-F238E27FC236}">
-                <a16:creationId xmlns:a16="http://schemas.microsoft.com/office/drawing/2014/main" id="{6B8A1845-244D-4403-99AE-D16C42883BD8}"/>
+                <a16:creationId xmlns:a16="http://schemas.microsoft.com/office/drawing/2014/main" id="{8E2E7936-51A8-428D-B49A-A73B8C93C0F7}"/>
               </a:ext>
             </a:extLst>
           </p:cNvPr>
@@ -7414,7 +7234,7 @@
           <p:cNvPr id="2" name="source-4">
             <a:extLst xmlns:a="http://schemas.openxmlformats.org/drawingml/2006/main">
               <a:ext uri="{FF2B5EF4-FFF2-40B4-BE49-F238E27FC236}">
-                <a16:creationId xmlns:a16="http://schemas.microsoft.com/office/drawing/2014/main" id="{4A80C88B-18F7-4C23-8B76-A8CCD22AA46B}"/>
+                <a16:creationId xmlns:a16="http://schemas.microsoft.com/office/drawing/2014/main" id="{32A0B01C-EC26-4C24-B8AE-4870019BCCB4}"/>
               </a:ext>
             </a:extLst>
           </p:cNvPr>
@@ -7459,7 +7279,7 @@
           <p:cNvPr id="3" name="page-4">
             <a:extLst xmlns:a="http://schemas.openxmlformats.org/drawingml/2006/main">
               <a:ext uri="{FF2B5EF4-FFF2-40B4-BE49-F238E27FC236}">
-                <a16:creationId xmlns:a16="http://schemas.microsoft.com/office/drawing/2014/main" id="{4E0DD1CB-F530-4C75-A84F-2CE088056B74}"/>
+                <a16:creationId xmlns:a16="http://schemas.microsoft.com/office/drawing/2014/main" id="{E6A773F2-C5E0-40F1-98B0-D35BB3658F64}"/>
               </a:ext>
             </a:extLst>
           </p:cNvPr>
@@ -7504,7 +7324,7 @@
           <p:cNvPr id="4" name="">
             <a:extLst xmlns:a="http://schemas.openxmlformats.org/drawingml/2006/main">
               <a:ext uri="{FF2B5EF4-FFF2-40B4-BE49-F238E27FC236}">
-                <a16:creationId xmlns:a16="http://schemas.microsoft.com/office/drawing/2014/main" id="{441D2B7A-C5DB-4A1B-9970-885143C82B8D}"/>
+                <a16:creationId xmlns:a16="http://schemas.microsoft.com/office/drawing/2014/main" id="{D04FE3E1-96FF-4165-8C38-F6E8C7BC1F39}"/>
               </a:ext>
             </a:extLst>
           </p:cNvPr>
@@ -7549,7 +7369,7 @@
           <p:cNvPr id="5" name="">
             <a:extLst xmlns:a="http://schemas.openxmlformats.org/drawingml/2006/main">
               <a:ext uri="{FF2B5EF4-FFF2-40B4-BE49-F238E27FC236}">
-                <a16:creationId xmlns:a16="http://schemas.microsoft.com/office/drawing/2014/main" id="{D6DB13BB-A276-4FAC-B728-37397D3BA893}"/>
+                <a16:creationId xmlns:a16="http://schemas.microsoft.com/office/drawing/2014/main" id="{2CE987E7-3B10-4BD6-AFD9-5C0D53B57C1E}"/>
               </a:ext>
             </a:extLst>
           </p:cNvPr>
@@ -7594,7 +7414,7 @@
           <p:cNvPr id="6" name="">
             <a:extLst xmlns:a="http://schemas.openxmlformats.org/drawingml/2006/main">
               <a:ext uri="{FF2B5EF4-FFF2-40B4-BE49-F238E27FC236}">
-                <a16:creationId xmlns:a16="http://schemas.microsoft.com/office/drawing/2014/main" id="{8B39CF81-B8AE-4DA5-85A5-D98C0B90F097}"/>
+                <a16:creationId xmlns:a16="http://schemas.microsoft.com/office/drawing/2014/main" id="{337DCAA3-8B1D-4094-B956-5814B13F8346}"/>
               </a:ext>
             </a:extLst>
           </p:cNvPr>
@@ -7639,7 +7459,7 @@
           <p:cNvPr id="7" name="">
             <a:extLst xmlns:a="http://schemas.openxmlformats.org/drawingml/2006/main">
               <a:ext uri="{FF2B5EF4-FFF2-40B4-BE49-F238E27FC236}">
-                <a16:creationId xmlns:a16="http://schemas.microsoft.com/office/drawing/2014/main" id="{37A01543-E812-4023-BF49-5E05DAB515C4}"/>
+                <a16:creationId xmlns:a16="http://schemas.microsoft.com/office/drawing/2014/main" id="{A323FA1C-5E3C-424D-9488-25310F11A412}"/>
               </a:ext>
             </a:extLst>
           </p:cNvPr>
@@ -7672,7 +7492,7 @@
           <p:cNvPr id="8" name="">
             <a:extLst xmlns:a="http://schemas.openxmlformats.org/drawingml/2006/main">
               <a:ext uri="{FF2B5EF4-FFF2-40B4-BE49-F238E27FC236}">
-                <a16:creationId xmlns:a16="http://schemas.microsoft.com/office/drawing/2014/main" id="{01A7F6EA-5D47-4D2B-BD3D-6E45CE7FB41F}"/>
+                <a16:creationId xmlns:a16="http://schemas.microsoft.com/office/drawing/2014/main" id="{5FFAE368-0984-49DD-9378-1AA0AE4F883E}"/>
               </a:ext>
             </a:extLst>
           </p:cNvPr>
@@ -7717,7 +7537,7 @@
           <p:cNvPr id="9" name="">
             <a:extLst xmlns:a="http://schemas.openxmlformats.org/drawingml/2006/main">
               <a:ext uri="{FF2B5EF4-FFF2-40B4-BE49-F238E27FC236}">
-                <a16:creationId xmlns:a16="http://schemas.microsoft.com/office/drawing/2014/main" id="{27CA3CDB-B6F1-49BA-8DBA-C36FD5CD6E6A}"/>
+                <a16:creationId xmlns:a16="http://schemas.microsoft.com/office/drawing/2014/main" id="{518F7644-8DF2-458B-B297-71F3AE52C525}"/>
               </a:ext>
             </a:extLst>
           </p:cNvPr>
@@ -7762,7 +7582,7 @@
           <p:cNvPr id="10" name="">
             <a:extLst xmlns:a="http://schemas.openxmlformats.org/drawingml/2006/main">
               <a:ext uri="{FF2B5EF4-FFF2-40B4-BE49-F238E27FC236}">
-                <a16:creationId xmlns:a16="http://schemas.microsoft.com/office/drawing/2014/main" id="{6E303D57-7759-4802-A61C-60D71D3F3680}"/>
+                <a16:creationId xmlns:a16="http://schemas.microsoft.com/office/drawing/2014/main" id="{CA309957-93F6-407F-9A4E-134A0C688252}"/>
               </a:ext>
             </a:extLst>
           </p:cNvPr>
@@ -7807,7 +7627,7 @@
           <p:cNvPr id="11" name="">
             <a:extLst xmlns:a="http://schemas.openxmlformats.org/drawingml/2006/main">
               <a:ext uri="{FF2B5EF4-FFF2-40B4-BE49-F238E27FC236}">
-                <a16:creationId xmlns:a16="http://schemas.microsoft.com/office/drawing/2014/main" id="{04AC1DC3-A4E7-4AD8-89DB-A763839413E6}"/>
+                <a16:creationId xmlns:a16="http://schemas.microsoft.com/office/drawing/2014/main" id="{0902DF10-0812-4BD2-953D-1AAD40270AFB}"/>
               </a:ext>
             </a:extLst>
           </p:cNvPr>
@@ -7840,7 +7660,7 @@
           <p:cNvPr id="12" name="">
             <a:extLst xmlns:a="http://schemas.openxmlformats.org/drawingml/2006/main">
               <a:ext uri="{FF2B5EF4-FFF2-40B4-BE49-F238E27FC236}">
-                <a16:creationId xmlns:a16="http://schemas.microsoft.com/office/drawing/2014/main" id="{E93A7A59-D4FA-4658-A739-43BF73F38AA6}"/>
+                <a16:creationId xmlns:a16="http://schemas.microsoft.com/office/drawing/2014/main" id="{1FD36D77-A346-4457-9EDD-DDA9DD55B9F2}"/>
               </a:ext>
             </a:extLst>
           </p:cNvPr>
@@ -7885,7 +7705,7 @@
           <p:cNvPr id="13" name="">
             <a:extLst xmlns:a="http://schemas.openxmlformats.org/drawingml/2006/main">
               <a:ext uri="{FF2B5EF4-FFF2-40B4-BE49-F238E27FC236}">
-                <a16:creationId xmlns:a16="http://schemas.microsoft.com/office/drawing/2014/main" id="{8BE9D93B-CA67-4AFE-ADA6-E75E466B8A4F}"/>
+                <a16:creationId xmlns:a16="http://schemas.microsoft.com/office/drawing/2014/main" id="{E619D705-3156-44A0-812B-0D22C4088EA2}"/>
               </a:ext>
             </a:extLst>
           </p:cNvPr>
@@ -7930,7 +7750,7 @@
           <p:cNvPr id="14" name="">
             <a:extLst xmlns:a="http://schemas.openxmlformats.org/drawingml/2006/main">
               <a:ext uri="{FF2B5EF4-FFF2-40B4-BE49-F238E27FC236}">
-                <a16:creationId xmlns:a16="http://schemas.microsoft.com/office/drawing/2014/main" id="{82CDBD12-6450-4E70-9816-8C387B14CE3B}"/>
+                <a16:creationId xmlns:a16="http://schemas.microsoft.com/office/drawing/2014/main" id="{C8D38E9D-BCD0-4CB2-A842-69CD7E707680}"/>
               </a:ext>
             </a:extLst>
           </p:cNvPr>
@@ -7975,7 +7795,7 @@
           <p:cNvPr id="15" name="">
             <a:extLst xmlns:a="http://schemas.openxmlformats.org/drawingml/2006/main">
               <a:ext uri="{FF2B5EF4-FFF2-40B4-BE49-F238E27FC236}">
-                <a16:creationId xmlns:a16="http://schemas.microsoft.com/office/drawing/2014/main" id="{1C5ACE2C-066A-4209-AB96-0D689CB31B58}"/>
+                <a16:creationId xmlns:a16="http://schemas.microsoft.com/office/drawing/2014/main" id="{ACBDFF48-D8FD-4233-B68C-E002C80FC287}"/>
               </a:ext>
             </a:extLst>
           </p:cNvPr>
@@ -8008,7 +7828,7 @@
           <p:cNvPr id="16" name="">
             <a:extLst xmlns:a="http://schemas.openxmlformats.org/drawingml/2006/main">
               <a:ext uri="{FF2B5EF4-FFF2-40B4-BE49-F238E27FC236}">
-                <a16:creationId xmlns:a16="http://schemas.microsoft.com/office/drawing/2014/main" id="{58071853-5FD3-489A-B2F1-496D9060C204}"/>
+                <a16:creationId xmlns:a16="http://schemas.microsoft.com/office/drawing/2014/main" id="{989CDC96-46BA-4C6C-BFAC-3BEA601047A5}"/>
               </a:ext>
             </a:extLst>
           </p:cNvPr>
@@ -8053,7 +7873,7 @@
           <p:cNvPr id="17" name="">
             <a:extLst xmlns:a="http://schemas.openxmlformats.org/drawingml/2006/main">
               <a:ext uri="{FF2B5EF4-FFF2-40B4-BE49-F238E27FC236}">
-                <a16:creationId xmlns:a16="http://schemas.microsoft.com/office/drawing/2014/main" id="{64EE9E1E-3BBE-4008-BC53-759F4C6266B5}"/>
+                <a16:creationId xmlns:a16="http://schemas.microsoft.com/office/drawing/2014/main" id="{56518652-6265-4612-8A34-583185518E24}"/>
               </a:ext>
             </a:extLst>
           </p:cNvPr>
@@ -8098,7 +7918,7 @@
           <p:cNvPr id="18" name="">
             <a:extLst xmlns:a="http://schemas.openxmlformats.org/drawingml/2006/main">
               <a:ext uri="{FF2B5EF4-FFF2-40B4-BE49-F238E27FC236}">
-                <a16:creationId xmlns:a16="http://schemas.microsoft.com/office/drawing/2014/main" id="{C60DBEE3-E48C-46B2-B3F4-5A52FF2A0EF5}"/>
+                <a16:creationId xmlns:a16="http://schemas.microsoft.com/office/drawing/2014/main" id="{FDF11E9B-6CD0-41DC-A85F-6BC3F8B5DB71}"/>
               </a:ext>
             </a:extLst>
           </p:cNvPr>
@@ -8143,7 +7963,7 @@
           <p:cNvPr id="19" name="">
             <a:extLst xmlns:a="http://schemas.openxmlformats.org/drawingml/2006/main">
               <a:ext uri="{FF2B5EF4-FFF2-40B4-BE49-F238E27FC236}">
-                <a16:creationId xmlns:a16="http://schemas.microsoft.com/office/drawing/2014/main" id="{28EF05F7-CFB4-4264-A11C-C4C5ED8D2349}"/>
+                <a16:creationId xmlns:a16="http://schemas.microsoft.com/office/drawing/2014/main" id="{DDD9349D-0D79-44E9-8091-1B2278FF5267}"/>
               </a:ext>
             </a:extLst>
           </p:cNvPr>
@@ -8176,7 +7996,7 @@
           <p:cNvPr id="20" name="">
             <a:extLst xmlns:a="http://schemas.openxmlformats.org/drawingml/2006/main">
               <a:ext uri="{FF2B5EF4-FFF2-40B4-BE49-F238E27FC236}">
-                <a16:creationId xmlns:a16="http://schemas.microsoft.com/office/drawing/2014/main" id="{DD84FCBD-1548-46DD-9A5D-1D46D8C7BADD}"/>
+                <a16:creationId xmlns:a16="http://schemas.microsoft.com/office/drawing/2014/main" id="{2E13B9B9-039A-433E-B09A-64B33A51C4AD}"/>
               </a:ext>
             </a:extLst>
           </p:cNvPr>
@@ -8221,7 +8041,7 @@
           <p:cNvPr id="21" name="">
             <a:extLst xmlns:a="http://schemas.openxmlformats.org/drawingml/2006/main">
               <a:ext uri="{FF2B5EF4-FFF2-40B4-BE49-F238E27FC236}">
-                <a16:creationId xmlns:a16="http://schemas.microsoft.com/office/drawing/2014/main" id="{A4A28ABF-64D7-4874-9FD6-C9A33BC0798C}"/>
+                <a16:creationId xmlns:a16="http://schemas.microsoft.com/office/drawing/2014/main" id="{9F0716E5-F0A0-4DA2-94B7-CDE383904A3B}"/>
               </a:ext>
             </a:extLst>
           </p:cNvPr>
@@ -8266,7 +8086,7 @@
           <p:cNvPr id="22" name="">
             <a:extLst xmlns:a="http://schemas.openxmlformats.org/drawingml/2006/main">
               <a:ext uri="{FF2B5EF4-FFF2-40B4-BE49-F238E27FC236}">
-                <a16:creationId xmlns:a16="http://schemas.microsoft.com/office/drawing/2014/main" id="{031C4BB2-5F03-4473-945F-5460028BE611}"/>
+                <a16:creationId xmlns:a16="http://schemas.microsoft.com/office/drawing/2014/main" id="{BACCA7BF-8321-4183-9603-B42CC372AD9D}"/>
               </a:ext>
             </a:extLst>
           </p:cNvPr>
@@ -8311,7 +8131,7 @@
           <p:cNvPr id="23" name="field-appendix-frame">
             <a:extLst xmlns:a="http://schemas.openxmlformats.org/drawingml/2006/main">
               <a:ext uri="{FF2B5EF4-FFF2-40B4-BE49-F238E27FC236}">
-                <a16:creationId xmlns:a16="http://schemas.microsoft.com/office/drawing/2014/main" id="{E261B6F0-274B-48F3-9B25-32B52903E383}"/>
+                <a16:creationId xmlns:a16="http://schemas.microsoft.com/office/drawing/2014/main" id="{E8F9D9A0-C66C-4638-9B1A-59C735D4CBAB}"/>
               </a:ext>
             </a:extLst>
           </p:cNvPr>
@@ -8346,7 +8166,7 @@
           <p:cNvPr id="24" name="">
             <a:extLst xmlns:a="http://schemas.openxmlformats.org/drawingml/2006/main">
               <a:ext uri="{FF2B5EF4-FFF2-40B4-BE49-F238E27FC236}">
-                <a16:creationId xmlns:a16="http://schemas.microsoft.com/office/drawing/2014/main" id="{F14E29F6-8DB8-4729-B7FF-1E87826FFED3}"/>
+                <a16:creationId xmlns:a16="http://schemas.microsoft.com/office/drawing/2014/main" id="{AE1C820F-573D-4C58-B0ED-F944F8680B5E}"/>
               </a:ext>
             </a:extLst>
           </p:cNvPr>
@@ -8391,7 +8211,7 @@
           <p:cNvPr id="25" name="">
             <a:extLst xmlns:a="http://schemas.openxmlformats.org/drawingml/2006/main">
               <a:ext uri="{FF2B5EF4-FFF2-40B4-BE49-F238E27FC236}">
-                <a16:creationId xmlns:a16="http://schemas.microsoft.com/office/drawing/2014/main" id="{42C4BB5D-B081-4BFB-A467-47A820A5791E}"/>
+                <a16:creationId xmlns:a16="http://schemas.microsoft.com/office/drawing/2014/main" id="{26DCEC31-A182-4B3F-BF6E-0CDEFC75C117}"/>
               </a:ext>
             </a:extLst>
           </p:cNvPr>
@@ -8440,7 +8260,7 @@
           <p:nvPr/>
         </p:nvPicPr>
         <p:blipFill>
-          <a:blip xmlns:r="http://schemas.openxmlformats.org/officeDocument/2006/relationships" xmlns:a="http://schemas.openxmlformats.org/drawingml/2006/main" r:embed="Rdc1c71c478a1418e"/>
+          <a:blip xmlns:r="http://schemas.openxmlformats.org/officeDocument/2006/relationships" xmlns:a="http://schemas.openxmlformats.org/drawingml/2006/main" r:embed="Rc0fb1e78eab347bf"/>
           <a:stretch xmlns:a="http://schemas.openxmlformats.org/drawingml/2006/main"/>
         </p:blipFill>
         <p:spPr>
@@ -8456,7 +8276,7 @@
     </p:spTree>
     <p:extLst>
       <p:ext uri="{BB962C8B-B14F-4D97-AF65-F5344CB8AC3E}">
-        <p14:creationId xmlns:p14="http://schemas.microsoft.com/office/powerpoint/2010/main" val="114105142"/>
+        <p14:creationId xmlns:p14="http://schemas.microsoft.com/office/powerpoint/2010/main" val="24191610"/>
       </p:ext>
     </p:extLst>
   </p:cSld>
@@ -8487,7 +8307,7 @@
           <p:cNvPr id="24" name="title-5">
             <a:extLst xmlns:a="http://schemas.openxmlformats.org/drawingml/2006/main">
               <a:ext uri="{FF2B5EF4-FFF2-40B4-BE49-F238E27FC236}">
-                <a16:creationId xmlns:a16="http://schemas.microsoft.com/office/drawing/2014/main" id="{00BC0590-F168-44E8-8B9C-0F5035C197E6}"/>
+                <a16:creationId xmlns:a16="http://schemas.microsoft.com/office/drawing/2014/main" id="{BD33356F-593B-4A5B-AA90-E600D80A6166}"/>
               </a:ext>
             </a:extLst>
           </p:cNvPr>
@@ -8532,7 +8352,7 @@
           <p:cNvPr id="2" name="source-5">
             <a:extLst xmlns:a="http://schemas.openxmlformats.org/drawingml/2006/main">
               <a:ext uri="{FF2B5EF4-FFF2-40B4-BE49-F238E27FC236}">
-                <a16:creationId xmlns:a16="http://schemas.microsoft.com/office/drawing/2014/main" id="{5D176044-3006-4A9E-A24D-724786EB51A4}"/>
+                <a16:creationId xmlns:a16="http://schemas.microsoft.com/office/drawing/2014/main" id="{5852B235-39FA-49CF-9F3E-96FEB5C0194B}"/>
               </a:ext>
             </a:extLst>
           </p:cNvPr>
@@ -8577,7 +8397,7 @@
           <p:cNvPr id="3" name="page-5">
             <a:extLst xmlns:a="http://schemas.openxmlformats.org/drawingml/2006/main">
               <a:ext uri="{FF2B5EF4-FFF2-40B4-BE49-F238E27FC236}">
-                <a16:creationId xmlns:a16="http://schemas.microsoft.com/office/drawing/2014/main" id="{4063DC28-7B9C-4E65-8BCE-7C48050EAB57}"/>
+                <a16:creationId xmlns:a16="http://schemas.microsoft.com/office/drawing/2014/main" id="{7C21A39E-DB54-4926-8F4F-34882BD46419}"/>
               </a:ext>
             </a:extLst>
           </p:cNvPr>
@@ -8622,7 +8442,7 @@
           <p:cNvPr id="4" name="">
             <a:extLst xmlns:a="http://schemas.openxmlformats.org/drawingml/2006/main">
               <a:ext uri="{FF2B5EF4-FFF2-40B4-BE49-F238E27FC236}">
-                <a16:creationId xmlns:a16="http://schemas.microsoft.com/office/drawing/2014/main" id="{8958C845-1DDD-44CF-9554-28E264BD507A}"/>
+                <a16:creationId xmlns:a16="http://schemas.microsoft.com/office/drawing/2014/main" id="{D8234AB5-6F8D-4F90-B338-109AB026C129}"/>
               </a:ext>
             </a:extLst>
           </p:cNvPr>
@@ -8667,7 +8487,7 @@
           <p:cNvPr id="5" name="">
             <a:extLst xmlns:a="http://schemas.openxmlformats.org/drawingml/2006/main">
               <a:ext uri="{FF2B5EF4-FFF2-40B4-BE49-F238E27FC236}">
-                <a16:creationId xmlns:a16="http://schemas.microsoft.com/office/drawing/2014/main" id="{57355650-28D8-4319-9E59-B42BAFBB03C3}"/>
+                <a16:creationId xmlns:a16="http://schemas.microsoft.com/office/drawing/2014/main" id="{A3F896E5-39FB-4934-B0A3-FB3B06ADC683}"/>
               </a:ext>
             </a:extLst>
           </p:cNvPr>
@@ -8712,7 +8532,7 @@
           <p:cNvPr id="6" name="">
             <a:extLst xmlns:a="http://schemas.openxmlformats.org/drawingml/2006/main">
               <a:ext uri="{FF2B5EF4-FFF2-40B4-BE49-F238E27FC236}">
-                <a16:creationId xmlns:a16="http://schemas.microsoft.com/office/drawing/2014/main" id="{4C12EAE7-A1F0-457E-A007-1BA1F95B6F26}"/>
+                <a16:creationId xmlns:a16="http://schemas.microsoft.com/office/drawing/2014/main" id="{A02C437D-1165-4D16-9798-288ACA00416E}"/>
               </a:ext>
             </a:extLst>
           </p:cNvPr>
@@ -8757,7 +8577,7 @@
           <p:cNvPr id="7" name="role-row-0">
             <a:extLst xmlns:a="http://schemas.openxmlformats.org/drawingml/2006/main">
               <a:ext uri="{FF2B5EF4-FFF2-40B4-BE49-F238E27FC236}">
-                <a16:creationId xmlns:a16="http://schemas.microsoft.com/office/drawing/2014/main" id="{50499E5D-E659-4863-9C0E-77C910C88A38}"/>
+                <a16:creationId xmlns:a16="http://schemas.microsoft.com/office/drawing/2014/main" id="{0590A736-A466-490E-B464-1A2769F897B6}"/>
               </a:ext>
             </a:extLst>
           </p:cNvPr>
@@ -8790,7 +8610,7 @@
           <p:cNvPr id="8" name="">
             <a:extLst xmlns:a="http://schemas.openxmlformats.org/drawingml/2006/main">
               <a:ext uri="{FF2B5EF4-FFF2-40B4-BE49-F238E27FC236}">
-                <a16:creationId xmlns:a16="http://schemas.microsoft.com/office/drawing/2014/main" id="{CBECC117-482F-4EDF-80B4-D292345892EC}"/>
+                <a16:creationId xmlns:a16="http://schemas.microsoft.com/office/drawing/2014/main" id="{28CE28C8-39D7-4AB6-907F-984CB9D25C54}"/>
               </a:ext>
             </a:extLst>
           </p:cNvPr>
@@ -8835,7 +8655,7 @@
           <p:cNvPr id="9" name="">
             <a:extLst xmlns:a="http://schemas.openxmlformats.org/drawingml/2006/main">
               <a:ext uri="{FF2B5EF4-FFF2-40B4-BE49-F238E27FC236}">
-                <a16:creationId xmlns:a16="http://schemas.microsoft.com/office/drawing/2014/main" id="{29448F57-1D59-4169-B358-47A4D5FE625E}"/>
+                <a16:creationId xmlns:a16="http://schemas.microsoft.com/office/drawing/2014/main" id="{1359BFD6-080D-4E10-8F6C-1C5F510110E0}"/>
               </a:ext>
             </a:extLst>
           </p:cNvPr>
@@ -8881,7 +8701,7 @@
           <p:cNvPr id="10" name="">
             <a:extLst xmlns:a="http://schemas.openxmlformats.org/drawingml/2006/main">
               <a:ext uri="{FF2B5EF4-FFF2-40B4-BE49-F238E27FC236}">
-                <a16:creationId xmlns:a16="http://schemas.microsoft.com/office/drawing/2014/main" id="{396F10BE-B4A8-4FA2-A070-093F590033C3}"/>
+                <a16:creationId xmlns:a16="http://schemas.microsoft.com/office/drawing/2014/main" id="{6DC5540F-21F2-412B-9573-167C1C440610}"/>
               </a:ext>
             </a:extLst>
           </p:cNvPr>
@@ -8927,7 +8747,7 @@
           <p:cNvPr id="11" name="role-row-1">
             <a:extLst xmlns:a="http://schemas.openxmlformats.org/drawingml/2006/main">
               <a:ext uri="{FF2B5EF4-FFF2-40B4-BE49-F238E27FC236}">
-                <a16:creationId xmlns:a16="http://schemas.microsoft.com/office/drawing/2014/main" id="{85F10097-C15F-46C8-9770-88684F238EF1}"/>
+                <a16:creationId xmlns:a16="http://schemas.microsoft.com/office/drawing/2014/main" id="{5BA4F726-5CC5-477B-A2AF-B8404CA50248}"/>
               </a:ext>
             </a:extLst>
           </p:cNvPr>
@@ -8960,7 +8780,7 @@
           <p:cNvPr id="12" name="">
             <a:extLst xmlns:a="http://schemas.openxmlformats.org/drawingml/2006/main">
               <a:ext uri="{FF2B5EF4-FFF2-40B4-BE49-F238E27FC236}">
-                <a16:creationId xmlns:a16="http://schemas.microsoft.com/office/drawing/2014/main" id="{A93B54C7-08A8-46DE-9D97-4DD482B423F6}"/>
+                <a16:creationId xmlns:a16="http://schemas.microsoft.com/office/drawing/2014/main" id="{A868A18B-167A-4F1A-8DC4-20FBE9581515}"/>
               </a:ext>
             </a:extLst>
           </p:cNvPr>
@@ -9005,7 +8825,7 @@
           <p:cNvPr id="13" name="">
             <a:extLst xmlns:a="http://schemas.openxmlformats.org/drawingml/2006/main">
               <a:ext uri="{FF2B5EF4-FFF2-40B4-BE49-F238E27FC236}">
-                <a16:creationId xmlns:a16="http://schemas.microsoft.com/office/drawing/2014/main" id="{1CCDD0D5-73E6-4435-B366-5AB4B5ADE920}"/>
+                <a16:creationId xmlns:a16="http://schemas.microsoft.com/office/drawing/2014/main" id="{E0598F85-2E77-472A-AF8A-501FB3E253BF}"/>
               </a:ext>
             </a:extLst>
           </p:cNvPr>
@@ -9051,7 +8871,7 @@
           <p:cNvPr id="14" name="">
             <a:extLst xmlns:a="http://schemas.openxmlformats.org/drawingml/2006/main">
               <a:ext uri="{FF2B5EF4-FFF2-40B4-BE49-F238E27FC236}">
-                <a16:creationId xmlns:a16="http://schemas.microsoft.com/office/drawing/2014/main" id="{897F7B50-E75E-48A9-BC7F-83363EF67E4D}"/>
+                <a16:creationId xmlns:a16="http://schemas.microsoft.com/office/drawing/2014/main" id="{926509EB-AF95-4C79-8A8B-34E9F926F60F}"/>
               </a:ext>
             </a:extLst>
           </p:cNvPr>
@@ -9097,7 +8917,7 @@
           <p:cNvPr id="15" name="role-row-2">
             <a:extLst xmlns:a="http://schemas.openxmlformats.org/drawingml/2006/main">
               <a:ext uri="{FF2B5EF4-FFF2-40B4-BE49-F238E27FC236}">
-                <a16:creationId xmlns:a16="http://schemas.microsoft.com/office/drawing/2014/main" id="{3CE220EA-4BFB-4A68-B6D4-60B38DCFA679}"/>
+                <a16:creationId xmlns:a16="http://schemas.microsoft.com/office/drawing/2014/main" id="{EACE9652-E930-431D-B1D1-2E6917516A4F}"/>
               </a:ext>
             </a:extLst>
           </p:cNvPr>
@@ -9130,7 +8950,7 @@
           <p:cNvPr id="16" name="">
             <a:extLst xmlns:a="http://schemas.openxmlformats.org/drawingml/2006/main">
               <a:ext uri="{FF2B5EF4-FFF2-40B4-BE49-F238E27FC236}">
-                <a16:creationId xmlns:a16="http://schemas.microsoft.com/office/drawing/2014/main" id="{B5BBC43B-0A60-496E-BF95-78E4DD41B5DC}"/>
+                <a16:creationId xmlns:a16="http://schemas.microsoft.com/office/drawing/2014/main" id="{A6535564-DD75-45B2-8E06-C38634777525}"/>
               </a:ext>
             </a:extLst>
           </p:cNvPr>
@@ -9175,7 +8995,7 @@
           <p:cNvPr id="17" name="">
             <a:extLst xmlns:a="http://schemas.openxmlformats.org/drawingml/2006/main">
               <a:ext uri="{FF2B5EF4-FFF2-40B4-BE49-F238E27FC236}">
-                <a16:creationId xmlns:a16="http://schemas.microsoft.com/office/drawing/2014/main" id="{F11944B7-2664-4AE3-97EF-B38963693A02}"/>
+                <a16:creationId xmlns:a16="http://schemas.microsoft.com/office/drawing/2014/main" id="{3BD8909B-23A7-47C9-BDEB-CF85214354A6}"/>
               </a:ext>
             </a:extLst>
           </p:cNvPr>
@@ -9221,7 +9041,7 @@
           <p:cNvPr id="18" name="">
             <a:extLst xmlns:a="http://schemas.openxmlformats.org/drawingml/2006/main">
               <a:ext uri="{FF2B5EF4-FFF2-40B4-BE49-F238E27FC236}">
-                <a16:creationId xmlns:a16="http://schemas.microsoft.com/office/drawing/2014/main" id="{06D59678-4C5D-4D04-A6AB-E51724016E1E}"/>
+                <a16:creationId xmlns:a16="http://schemas.microsoft.com/office/drawing/2014/main" id="{8886C456-8247-414B-B79D-03DDEB303044}"/>
               </a:ext>
             </a:extLst>
           </p:cNvPr>
@@ -9267,7 +9087,7 @@
           <p:cNvPr id="19" name="role-row-3">
             <a:extLst xmlns:a="http://schemas.openxmlformats.org/drawingml/2006/main">
               <a:ext uri="{FF2B5EF4-FFF2-40B4-BE49-F238E27FC236}">
-                <a16:creationId xmlns:a16="http://schemas.microsoft.com/office/drawing/2014/main" id="{6E5FBF5A-2DDD-4681-97B4-06851413616F}"/>
+                <a16:creationId xmlns:a16="http://schemas.microsoft.com/office/drawing/2014/main" id="{01B196CB-C126-4F64-82D5-CDD33473CFD1}"/>
               </a:ext>
             </a:extLst>
           </p:cNvPr>
@@ -9300,7 +9120,7 @@
           <p:cNvPr id="20" name="">
             <a:extLst xmlns:a="http://schemas.openxmlformats.org/drawingml/2006/main">
               <a:ext uri="{FF2B5EF4-FFF2-40B4-BE49-F238E27FC236}">
-                <a16:creationId xmlns:a16="http://schemas.microsoft.com/office/drawing/2014/main" id="{E4C54933-84A7-49E6-AF02-1948867076A6}"/>
+                <a16:creationId xmlns:a16="http://schemas.microsoft.com/office/drawing/2014/main" id="{9D2809F5-1F30-4C3A-8B6C-C1502101D88C}"/>
               </a:ext>
             </a:extLst>
           </p:cNvPr>
@@ -9345,7 +9165,7 @@
           <p:cNvPr id="21" name="">
             <a:extLst xmlns:a="http://schemas.openxmlformats.org/drawingml/2006/main">
               <a:ext uri="{FF2B5EF4-FFF2-40B4-BE49-F238E27FC236}">
-                <a16:creationId xmlns:a16="http://schemas.microsoft.com/office/drawing/2014/main" id="{42C80634-066B-4F53-B595-09DD32091E22}"/>
+                <a16:creationId xmlns:a16="http://schemas.microsoft.com/office/drawing/2014/main" id="{E4E237BE-F086-49F5-A38B-DFE849425B30}"/>
               </a:ext>
             </a:extLst>
           </p:cNvPr>
@@ -9391,7 +9211,7 @@
           <p:cNvPr id="22" name="">
             <a:extLst xmlns:a="http://schemas.openxmlformats.org/drawingml/2006/main">
               <a:ext uri="{FF2B5EF4-FFF2-40B4-BE49-F238E27FC236}">
-                <a16:creationId xmlns:a16="http://schemas.microsoft.com/office/drawing/2014/main" id="{D76FA3B8-A114-41F9-AD11-076FA44A08FF}"/>
+                <a16:creationId xmlns:a16="http://schemas.microsoft.com/office/drawing/2014/main" id="{55EC346F-AA0B-4040-9558-9B7C55D12425}"/>
               </a:ext>
             </a:extLst>
           </p:cNvPr>
@@ -9437,7 +9257,7 @@
           <p:cNvPr id="23" name="">
             <a:extLst xmlns:a="http://schemas.openxmlformats.org/drawingml/2006/main">
               <a:ext uri="{FF2B5EF4-FFF2-40B4-BE49-F238E27FC236}">
-                <a16:creationId xmlns:a16="http://schemas.microsoft.com/office/drawing/2014/main" id="{48BFA86B-414C-458B-824B-4E3F2C0C00B4}"/>
+                <a16:creationId xmlns:a16="http://schemas.microsoft.com/office/drawing/2014/main" id="{063A4DB0-D5D6-4C8F-A0B9-BAC5AF285793}"/>
               </a:ext>
             </a:extLst>
           </p:cNvPr>
@@ -9480,7 +9300,7 @@
     </p:spTree>
     <p:extLst>
       <p:ext uri="{BB962C8B-B14F-4D97-AF65-F5344CB8AC3E}">
-        <p14:creationId xmlns:p14="http://schemas.microsoft.com/office/powerpoint/2010/main" val="1600205333"/>
+        <p14:creationId xmlns:p14="http://schemas.microsoft.com/office/powerpoint/2010/main" val="1406058824"/>
       </p:ext>
     </p:extLst>
   </p:cSld>
@@ -9511,7 +9331,7 @@
           <p:cNvPr id="19" name="title-6">
             <a:extLst xmlns:a="http://schemas.openxmlformats.org/drawingml/2006/main">
               <a:ext uri="{FF2B5EF4-FFF2-40B4-BE49-F238E27FC236}">
-                <a16:creationId xmlns:a16="http://schemas.microsoft.com/office/drawing/2014/main" id="{F3320E03-67E9-497D-B515-0378D4E1C1C0}"/>
+                <a16:creationId xmlns:a16="http://schemas.microsoft.com/office/drawing/2014/main" id="{0BD59CDF-4595-4F52-8A37-8450309DD64F}"/>
               </a:ext>
             </a:extLst>
           </p:cNvPr>
@@ -9556,7 +9376,7 @@
           <p:cNvPr id="2" name="source-6">
             <a:extLst xmlns:a="http://schemas.openxmlformats.org/drawingml/2006/main">
               <a:ext uri="{FF2B5EF4-FFF2-40B4-BE49-F238E27FC236}">
-                <a16:creationId xmlns:a16="http://schemas.microsoft.com/office/drawing/2014/main" id="{58648BEA-4AE8-4E2F-A5BA-933EC0CF1B4F}"/>
+                <a16:creationId xmlns:a16="http://schemas.microsoft.com/office/drawing/2014/main" id="{493F9F7C-DF5B-44E9-BC50-A1D5AED6AB93}"/>
               </a:ext>
             </a:extLst>
           </p:cNvPr>
@@ -9601,7 +9421,7 @@
           <p:cNvPr id="3" name="page-6">
             <a:extLst xmlns:a="http://schemas.openxmlformats.org/drawingml/2006/main">
               <a:ext uri="{FF2B5EF4-FFF2-40B4-BE49-F238E27FC236}">
-                <a16:creationId xmlns:a16="http://schemas.microsoft.com/office/drawing/2014/main" id="{8F9AA08E-E212-4DF4-AC88-4FB51C45E58D}"/>
+                <a16:creationId xmlns:a16="http://schemas.microsoft.com/office/drawing/2014/main" id="{466D0185-51F7-4824-9F5C-447FC562FDBA}"/>
               </a:ext>
             </a:extLst>
           </p:cNvPr>
@@ -9646,7 +9466,7 @@
           <p:cNvPr id="4" name="">
             <a:extLst xmlns:a="http://schemas.openxmlformats.org/drawingml/2006/main">
               <a:ext uri="{FF2B5EF4-FFF2-40B4-BE49-F238E27FC236}">
-                <a16:creationId xmlns:a16="http://schemas.microsoft.com/office/drawing/2014/main" id="{57A30853-BCAA-4D11-8C82-44141A0D3FEF}"/>
+                <a16:creationId xmlns:a16="http://schemas.microsoft.com/office/drawing/2014/main" id="{2BC5D3B0-40ED-44E2-A506-E37F934032FC}"/>
               </a:ext>
             </a:extLst>
           </p:cNvPr>
@@ -9691,7 +9511,7 @@
           <p:cNvPr id="5" name="">
             <a:extLst xmlns:a="http://schemas.openxmlformats.org/drawingml/2006/main">
               <a:ext uri="{FF2B5EF4-FFF2-40B4-BE49-F238E27FC236}">
-                <a16:creationId xmlns:a16="http://schemas.microsoft.com/office/drawing/2014/main" id="{CCBF41D2-6B09-4031-B0C9-5DC7DE24AEBA}"/>
+                <a16:creationId xmlns:a16="http://schemas.microsoft.com/office/drawing/2014/main" id="{CB2ADB51-B3A8-4C0B-ACB4-66D460E2AC9D}"/>
               </a:ext>
             </a:extLst>
           </p:cNvPr>
@@ -9724,7 +9544,7 @@
           <p:cNvPr id="6" name="">
             <a:extLst xmlns:a="http://schemas.openxmlformats.org/drawingml/2006/main">
               <a:ext uri="{FF2B5EF4-FFF2-40B4-BE49-F238E27FC236}">
-                <a16:creationId xmlns:a16="http://schemas.microsoft.com/office/drawing/2014/main" id="{26290C01-8713-4E9D-864C-5E7A65E28F90}"/>
+                <a16:creationId xmlns:a16="http://schemas.microsoft.com/office/drawing/2014/main" id="{FB423D2F-6112-4339-AC77-AC7534D9412C}"/>
               </a:ext>
             </a:extLst>
           </p:cNvPr>
@@ -9757,7 +9577,7 @@
           <p:cNvPr id="7" name="">
             <a:extLst xmlns:a="http://schemas.openxmlformats.org/drawingml/2006/main">
               <a:ext uri="{FF2B5EF4-FFF2-40B4-BE49-F238E27FC236}">
-                <a16:creationId xmlns:a16="http://schemas.microsoft.com/office/drawing/2014/main" id="{689CBB0B-EB8E-4D3E-8A10-C3ED307F73B5}"/>
+                <a16:creationId xmlns:a16="http://schemas.microsoft.com/office/drawing/2014/main" id="{EE2AAE55-31B7-4A07-930D-C688136FDD2C}"/>
               </a:ext>
             </a:extLst>
           </p:cNvPr>
@@ -9790,7 +9610,7 @@
           <p:cNvPr id="8" name="">
             <a:extLst xmlns:a="http://schemas.openxmlformats.org/drawingml/2006/main">
               <a:ext uri="{FF2B5EF4-FFF2-40B4-BE49-F238E27FC236}">
-                <a16:creationId xmlns:a16="http://schemas.microsoft.com/office/drawing/2014/main" id="{06C7B8E8-7485-4041-9CCA-87E9E64C3628}"/>
+                <a16:creationId xmlns:a16="http://schemas.microsoft.com/office/drawing/2014/main" id="{CD54868A-FE65-4BF9-BDA1-0DDC0BC88DEC}"/>
               </a:ext>
             </a:extLst>
           </p:cNvPr>
@@ -9823,7 +9643,7 @@
           <p:cNvPr id="9" name="">
             <a:extLst xmlns:a="http://schemas.openxmlformats.org/drawingml/2006/main">
               <a:ext uri="{FF2B5EF4-FFF2-40B4-BE49-F238E27FC236}">
-                <a16:creationId xmlns:a16="http://schemas.microsoft.com/office/drawing/2014/main" id="{29E45E4B-BACA-44EF-8B13-B1AAB2F50C81}"/>
+                <a16:creationId xmlns:a16="http://schemas.microsoft.com/office/drawing/2014/main" id="{CFA330D9-15D9-4511-B94C-7ECEE48D7416}"/>
               </a:ext>
             </a:extLst>
           </p:cNvPr>
@@ -9856,7 +9676,7 @@
           <p:cNvPr id="10" name="">
             <a:extLst xmlns:a="http://schemas.openxmlformats.org/drawingml/2006/main">
               <a:ext uri="{FF2B5EF4-FFF2-40B4-BE49-F238E27FC236}">
-                <a16:creationId xmlns:a16="http://schemas.microsoft.com/office/drawing/2014/main" id="{2EC23B5A-440B-4983-A8EA-4D7AA9316DE6}"/>
+                <a16:creationId xmlns:a16="http://schemas.microsoft.com/office/drawing/2014/main" id="{1C148275-A339-487C-9ED1-7DAED0DD4784}"/>
               </a:ext>
             </a:extLst>
           </p:cNvPr>
@@ -9901,7 +9721,7 @@
           <p:cNvPr id="11" name="">
             <a:extLst xmlns:a="http://schemas.openxmlformats.org/drawingml/2006/main">
               <a:ext uri="{FF2B5EF4-FFF2-40B4-BE49-F238E27FC236}">
-                <a16:creationId xmlns:a16="http://schemas.microsoft.com/office/drawing/2014/main" id="{422BD028-7622-467F-A682-9876D19F8CBF}"/>
+                <a16:creationId xmlns:a16="http://schemas.microsoft.com/office/drawing/2014/main" id="{DF3B97F3-D440-4FCD-A204-005A43FCDD4B}"/>
               </a:ext>
             </a:extLst>
           </p:cNvPr>
@@ -9946,7 +9766,7 @@
           <p:cNvPr id="12" name="">
             <a:extLst xmlns:a="http://schemas.openxmlformats.org/drawingml/2006/main">
               <a:ext uri="{FF2B5EF4-FFF2-40B4-BE49-F238E27FC236}">
-                <a16:creationId xmlns:a16="http://schemas.microsoft.com/office/drawing/2014/main" id="{F1033563-B8A8-47A5-B43C-9203CBF6C94D}"/>
+                <a16:creationId xmlns:a16="http://schemas.microsoft.com/office/drawing/2014/main" id="{BFC1AD53-12BE-47AC-BED3-A99356E6DF3B}"/>
               </a:ext>
             </a:extLst>
           </p:cNvPr>
@@ -9991,7 +9811,7 @@
           <p:cNvPr id="13" name="">
             <a:extLst xmlns:a="http://schemas.openxmlformats.org/drawingml/2006/main">
               <a:ext uri="{FF2B5EF4-FFF2-40B4-BE49-F238E27FC236}">
-                <a16:creationId xmlns:a16="http://schemas.microsoft.com/office/drawing/2014/main" id="{6E678A7E-C944-47B0-95C3-BF9CD5E0F055}"/>
+                <a16:creationId xmlns:a16="http://schemas.microsoft.com/office/drawing/2014/main" id="{366AA19C-37FD-4545-8440-373411F9A0BC}"/>
               </a:ext>
             </a:extLst>
           </p:cNvPr>
@@ -10036,7 +9856,7 @@
           <p:cNvPr id="14" name="">
             <a:extLst xmlns:a="http://schemas.openxmlformats.org/drawingml/2006/main">
               <a:ext uri="{FF2B5EF4-FFF2-40B4-BE49-F238E27FC236}">
-                <a16:creationId xmlns:a16="http://schemas.microsoft.com/office/drawing/2014/main" id="{04CB8C41-4D03-44A6-9CE9-238C3D732757}"/>
+                <a16:creationId xmlns:a16="http://schemas.microsoft.com/office/drawing/2014/main" id="{FD26200A-1ADC-4DFA-B130-98D9AE4B0B0F}"/>
               </a:ext>
             </a:extLst>
           </p:cNvPr>
@@ -10081,7 +9901,7 @@
           <p:cNvPr id="15" name="">
             <a:extLst xmlns:a="http://schemas.openxmlformats.org/drawingml/2006/main">
               <a:ext uri="{FF2B5EF4-FFF2-40B4-BE49-F238E27FC236}">
-                <a16:creationId xmlns:a16="http://schemas.microsoft.com/office/drawing/2014/main" id="{30C68108-CB53-4AC4-850E-28A7A7DBD340}"/>
+                <a16:creationId xmlns:a16="http://schemas.microsoft.com/office/drawing/2014/main" id="{208DFF45-9DF8-4BE2-8DB0-95DD7EA186C7}"/>
               </a:ext>
             </a:extLst>
           </p:cNvPr>
@@ -10126,7 +9946,7 @@
           <p:cNvPr id="16" name="">
             <a:extLst xmlns:a="http://schemas.openxmlformats.org/drawingml/2006/main">
               <a:ext uri="{FF2B5EF4-FFF2-40B4-BE49-F238E27FC236}">
-                <a16:creationId xmlns:a16="http://schemas.microsoft.com/office/drawing/2014/main" id="{5CE32518-91F6-4BE7-92C9-97C435A9215F}"/>
+                <a16:creationId xmlns:a16="http://schemas.microsoft.com/office/drawing/2014/main" id="{598C733C-ADCA-42DD-9E67-0D0AE98BAE02}"/>
               </a:ext>
             </a:extLst>
           </p:cNvPr>
@@ -10171,7 +9991,7 @@
           <p:cNvPr id="17" name="">
             <a:extLst xmlns:a="http://schemas.openxmlformats.org/drawingml/2006/main">
               <a:ext uri="{FF2B5EF4-FFF2-40B4-BE49-F238E27FC236}">
-                <a16:creationId xmlns:a16="http://schemas.microsoft.com/office/drawing/2014/main" id="{BB7F0E10-21F3-4725-9707-2FAA57C9D5DD}"/>
+                <a16:creationId xmlns:a16="http://schemas.microsoft.com/office/drawing/2014/main" id="{E7246C55-B580-440F-B751-CC174D5F423B}"/>
               </a:ext>
             </a:extLst>
           </p:cNvPr>
@@ -10216,7 +10036,7 @@
           <p:cNvPr id="18" name="">
             <a:extLst xmlns:a="http://schemas.openxmlformats.org/drawingml/2006/main">
               <a:ext uri="{FF2B5EF4-FFF2-40B4-BE49-F238E27FC236}">
-                <a16:creationId xmlns:a16="http://schemas.microsoft.com/office/drawing/2014/main" id="{82BEF630-A718-487A-AC7F-CCD55B6CEB79}"/>
+                <a16:creationId xmlns:a16="http://schemas.microsoft.com/office/drawing/2014/main" id="{DE679F71-71EF-43FD-8C55-5DC03E72547F}"/>
               </a:ext>
             </a:extLst>
           </p:cNvPr>
@@ -10259,7 +10079,7 @@
     </p:spTree>
     <p:extLst>
       <p:ext uri="{BB962C8B-B14F-4D97-AF65-F5344CB8AC3E}">
-        <p14:creationId xmlns:p14="http://schemas.microsoft.com/office/powerpoint/2010/main" val="1855485293"/>
+        <p14:creationId xmlns:p14="http://schemas.microsoft.com/office/powerpoint/2010/main" val="640417000"/>
       </p:ext>
     </p:extLst>
   </p:cSld>
@@ -10290,7 +10110,7 @@
           <p:cNvPr id="14" name="title-7">
             <a:extLst xmlns:a="http://schemas.openxmlformats.org/drawingml/2006/main">
               <a:ext uri="{FF2B5EF4-FFF2-40B4-BE49-F238E27FC236}">
-                <a16:creationId xmlns:a16="http://schemas.microsoft.com/office/drawing/2014/main" id="{01E8B602-7B63-4AF9-AD6F-33BD65BA16FF}"/>
+                <a16:creationId xmlns:a16="http://schemas.microsoft.com/office/drawing/2014/main" id="{55C03E72-F590-4AB7-A183-36D8853CAAD0}"/>
               </a:ext>
             </a:extLst>
           </p:cNvPr>
@@ -10335,7 +10155,7 @@
           <p:cNvPr id="2" name="source-7">
             <a:extLst xmlns:a="http://schemas.openxmlformats.org/drawingml/2006/main">
               <a:ext uri="{FF2B5EF4-FFF2-40B4-BE49-F238E27FC236}">
-                <a16:creationId xmlns:a16="http://schemas.microsoft.com/office/drawing/2014/main" id="{E54854D7-3D14-4941-A9E1-D5E00F1305D1}"/>
+                <a16:creationId xmlns:a16="http://schemas.microsoft.com/office/drawing/2014/main" id="{BC045B03-73E7-4B8B-B708-0812A1630C0A}"/>
               </a:ext>
             </a:extLst>
           </p:cNvPr>
@@ -10380,7 +10200,7 @@
           <p:cNvPr id="3" name="page-7">
             <a:extLst xmlns:a="http://schemas.openxmlformats.org/drawingml/2006/main">
               <a:ext uri="{FF2B5EF4-FFF2-40B4-BE49-F238E27FC236}">
-                <a16:creationId xmlns:a16="http://schemas.microsoft.com/office/drawing/2014/main" id="{B18F96E6-CF92-4730-9D9D-15123AC65F6E}"/>
+                <a16:creationId xmlns:a16="http://schemas.microsoft.com/office/drawing/2014/main" id="{D92C78E3-8EF4-4E27-86DB-290B1EF1B827}"/>
               </a:ext>
             </a:extLst>
           </p:cNvPr>
@@ -10425,7 +10245,7 @@
           <p:cNvPr id="4" name="">
             <a:extLst xmlns:a="http://schemas.openxmlformats.org/drawingml/2006/main">
               <a:ext uri="{FF2B5EF4-FFF2-40B4-BE49-F238E27FC236}">
-                <a16:creationId xmlns:a16="http://schemas.microsoft.com/office/drawing/2014/main" id="{9DB9B473-8332-4D89-82DC-0D1AAB28D485}"/>
+                <a16:creationId xmlns:a16="http://schemas.microsoft.com/office/drawing/2014/main" id="{2EADAEF2-1888-4EF4-9F26-A039BA7E6657}"/>
               </a:ext>
             </a:extLst>
           </p:cNvPr>
@@ -10470,7 +10290,7 @@
           <p:cNvPr id="5" name="">
             <a:extLst xmlns:a="http://schemas.openxmlformats.org/drawingml/2006/main">
               <a:ext uri="{FF2B5EF4-FFF2-40B4-BE49-F238E27FC236}">
-                <a16:creationId xmlns:a16="http://schemas.microsoft.com/office/drawing/2014/main" id="{D6612BEF-548D-4331-988B-67DE8E98F601}"/>
+                <a16:creationId xmlns:a16="http://schemas.microsoft.com/office/drawing/2014/main" id="{26E76BD6-EFFF-446A-B30C-A913699495A9}"/>
               </a:ext>
             </a:extLst>
           </p:cNvPr>
@@ -10515,7 +10335,7 @@
           <p:cNvPr id="6" name="original-page-frame">
             <a:extLst xmlns:a="http://schemas.openxmlformats.org/drawingml/2006/main">
               <a:ext uri="{FF2B5EF4-FFF2-40B4-BE49-F238E27FC236}">
-                <a16:creationId xmlns:a16="http://schemas.microsoft.com/office/drawing/2014/main" id="{1775943E-6A85-4D9A-9CAF-1950A177F4CD}"/>
+                <a16:creationId xmlns:a16="http://schemas.microsoft.com/office/drawing/2014/main" id="{0F6E5456-F135-4A47-BE0C-F4A7D3D93551}"/>
               </a:ext>
             </a:extLst>
           </p:cNvPr>
@@ -10550,7 +10370,7 @@
           <p:cNvPr id="7" name="new-page-frame">
             <a:extLst xmlns:a="http://schemas.openxmlformats.org/drawingml/2006/main">
               <a:ext uri="{FF2B5EF4-FFF2-40B4-BE49-F238E27FC236}">
-                <a16:creationId xmlns:a16="http://schemas.microsoft.com/office/drawing/2014/main" id="{F8599D80-8570-4082-A0F8-77836F0CDA35}"/>
+                <a16:creationId xmlns:a16="http://schemas.microsoft.com/office/drawing/2014/main" id="{5A4286E3-8917-4869-A8AA-D6ADC0CD1F72}"/>
               </a:ext>
             </a:extLst>
           </p:cNvPr>
@@ -10585,7 +10405,7 @@
           <p:cNvPr id="8" name="">
             <a:extLst xmlns:a="http://schemas.openxmlformats.org/drawingml/2006/main">
               <a:ext uri="{FF2B5EF4-FFF2-40B4-BE49-F238E27FC236}">
-                <a16:creationId xmlns:a16="http://schemas.microsoft.com/office/drawing/2014/main" id="{1CB4BD9C-6BD0-436C-B4BB-9C950FD30EEF}"/>
+                <a16:creationId xmlns:a16="http://schemas.microsoft.com/office/drawing/2014/main" id="{8CAA6565-BD3E-4C52-AE7C-A883AB4FB9AE}"/>
               </a:ext>
             </a:extLst>
           </p:cNvPr>
@@ -10633,7 +10453,7 @@
           <p:cNvPr id="9" name="">
             <a:extLst xmlns:a="http://schemas.openxmlformats.org/drawingml/2006/main">
               <a:ext uri="{FF2B5EF4-FFF2-40B4-BE49-F238E27FC236}">
-                <a16:creationId xmlns:a16="http://schemas.microsoft.com/office/drawing/2014/main" id="{4AF9EA0D-BBCB-4469-B8BE-7C00E660CC89}"/>
+                <a16:creationId xmlns:a16="http://schemas.microsoft.com/office/drawing/2014/main" id="{072AA848-D0C7-4CBE-A368-13ABE4DCF1B5}"/>
               </a:ext>
             </a:extLst>
           </p:cNvPr>
@@ -10681,7 +10501,7 @@
           <p:cNvPr id="10" name="">
             <a:extLst xmlns:a="http://schemas.openxmlformats.org/drawingml/2006/main">
               <a:ext uri="{FF2B5EF4-FFF2-40B4-BE49-F238E27FC236}">
-                <a16:creationId xmlns:a16="http://schemas.microsoft.com/office/drawing/2014/main" id="{D180C477-25B7-40C6-9AB6-A073AE6AF180}"/>
+                <a16:creationId xmlns:a16="http://schemas.microsoft.com/office/drawing/2014/main" id="{9FBA1EAB-817C-4B70-B75F-AEAB0515328D}"/>
               </a:ext>
             </a:extLst>
           </p:cNvPr>
@@ -10726,7 +10546,7 @@
           <p:cNvPr id="11" name="">
             <a:extLst xmlns:a="http://schemas.openxmlformats.org/drawingml/2006/main">
               <a:ext uri="{FF2B5EF4-FFF2-40B4-BE49-F238E27FC236}">
-                <a16:creationId xmlns:a16="http://schemas.microsoft.com/office/drawing/2014/main" id="{5C0A0706-CEA1-4551-BB49-DFB0292C5AEC}"/>
+                <a16:creationId xmlns:a16="http://schemas.microsoft.com/office/drawing/2014/main" id="{76D6E03F-212E-4D40-99C7-2E891FA28E49}"/>
               </a:ext>
             </a:extLst>
           </p:cNvPr>
@@ -10775,7 +10595,7 @@
           <p:nvPr/>
         </p:nvPicPr>
         <p:blipFill>
-          <a:blip xmlns:r="http://schemas.openxmlformats.org/officeDocument/2006/relationships" xmlns:a="http://schemas.openxmlformats.org/drawingml/2006/main" r:embed="R76e423c41e5c44f2"/>
+          <a:blip xmlns:r="http://schemas.openxmlformats.org/officeDocument/2006/relationships" xmlns:a="http://schemas.openxmlformats.org/drawingml/2006/main" r:embed="Rbb29f4622d7e4add"/>
           <a:stretch xmlns:a="http://schemas.openxmlformats.org/drawingml/2006/main"/>
         </p:blipFill>
         <p:spPr>
@@ -10797,7 +10617,7 @@
           <p:nvPr/>
         </p:nvPicPr>
         <p:blipFill>
-          <a:blip xmlns:r="http://schemas.openxmlformats.org/officeDocument/2006/relationships" xmlns:a="http://schemas.openxmlformats.org/drawingml/2006/main" r:embed="Rc1cbd37262ae49f9"/>
+          <a:blip xmlns:r="http://schemas.openxmlformats.org/officeDocument/2006/relationships" xmlns:a="http://schemas.openxmlformats.org/drawingml/2006/main" r:embed="R609d6cbdac5541a1"/>
           <a:stretch xmlns:a="http://schemas.openxmlformats.org/drawingml/2006/main"/>
         </p:blipFill>
         <p:spPr>
@@ -10813,7 +10633,7 @@
     </p:spTree>
     <p:extLst>
       <p:ext uri="{BB962C8B-B14F-4D97-AF65-F5344CB8AC3E}">
-        <p14:creationId xmlns:p14="http://schemas.microsoft.com/office/powerpoint/2010/main" val="997577748"/>
+        <p14:creationId xmlns:p14="http://schemas.microsoft.com/office/powerpoint/2010/main" val="1040706967"/>
       </p:ext>
     </p:extLst>
   </p:cSld>
@@ -10844,7 +10664,7 @@
           <p:cNvPr id="18" name="title-8">
             <a:extLst xmlns:a="http://schemas.openxmlformats.org/drawingml/2006/main">
               <a:ext uri="{FF2B5EF4-FFF2-40B4-BE49-F238E27FC236}">
-                <a16:creationId xmlns:a16="http://schemas.microsoft.com/office/drawing/2014/main" id="{D4C09FD0-1989-47AD-B3EE-665F86F82638}"/>
+                <a16:creationId xmlns:a16="http://schemas.microsoft.com/office/drawing/2014/main" id="{864DD77F-9ED4-403A-967A-B735E8B10DE3}"/>
               </a:ext>
             </a:extLst>
           </p:cNvPr>
@@ -10889,7 +10709,7 @@
           <p:cNvPr id="2" name="source-8">
             <a:extLst xmlns:a="http://schemas.openxmlformats.org/drawingml/2006/main">
               <a:ext uri="{FF2B5EF4-FFF2-40B4-BE49-F238E27FC236}">
-                <a16:creationId xmlns:a16="http://schemas.microsoft.com/office/drawing/2014/main" id="{F3B7DC09-21A9-4753-90A9-AB69EF7C608E}"/>
+                <a16:creationId xmlns:a16="http://schemas.microsoft.com/office/drawing/2014/main" id="{FBE7BEB8-3162-42B6-85A0-9E60F25F0E97}"/>
               </a:ext>
             </a:extLst>
           </p:cNvPr>
@@ -10934,7 +10754,7 @@
           <p:cNvPr id="3" name="page-8">
             <a:extLst xmlns:a="http://schemas.openxmlformats.org/drawingml/2006/main">
               <a:ext uri="{FF2B5EF4-FFF2-40B4-BE49-F238E27FC236}">
-                <a16:creationId xmlns:a16="http://schemas.microsoft.com/office/drawing/2014/main" id="{57236B5A-49C5-4B26-B468-97E5874F08E7}"/>
+                <a16:creationId xmlns:a16="http://schemas.microsoft.com/office/drawing/2014/main" id="{20FFD4AF-202A-40A0-AF20-0327176539D4}"/>
               </a:ext>
             </a:extLst>
           </p:cNvPr>
@@ -10979,7 +10799,7 @@
           <p:cNvPr id="4" name="">
             <a:extLst xmlns:a="http://schemas.openxmlformats.org/drawingml/2006/main">
               <a:ext uri="{FF2B5EF4-FFF2-40B4-BE49-F238E27FC236}">
-                <a16:creationId xmlns:a16="http://schemas.microsoft.com/office/drawing/2014/main" id="{104D82D4-CD3A-4DDC-A0B6-52E38B0D6407}"/>
+                <a16:creationId xmlns:a16="http://schemas.microsoft.com/office/drawing/2014/main" id="{4B63F795-6E25-4888-B258-EB1537C3C9A8}"/>
               </a:ext>
             </a:extLst>
           </p:cNvPr>
@@ -11024,7 +10844,7 @@
           <p:cNvPr id="5" name="">
             <a:extLst xmlns:a="http://schemas.openxmlformats.org/drawingml/2006/main">
               <a:ext uri="{FF2B5EF4-FFF2-40B4-BE49-F238E27FC236}">
-                <a16:creationId xmlns:a16="http://schemas.microsoft.com/office/drawing/2014/main" id="{001BFBF3-A6A1-44C0-A2C0-946231ED90C3}"/>
+                <a16:creationId xmlns:a16="http://schemas.microsoft.com/office/drawing/2014/main" id="{935B6AE7-C8DA-4341-A250-85413DB7976A}"/>
               </a:ext>
             </a:extLst>
           </p:cNvPr>
@@ -11057,7 +10877,7 @@
           <p:cNvPr id="6" name="">
             <a:extLst xmlns:a="http://schemas.openxmlformats.org/drawingml/2006/main">
               <a:ext uri="{FF2B5EF4-FFF2-40B4-BE49-F238E27FC236}">
-                <a16:creationId xmlns:a16="http://schemas.microsoft.com/office/drawing/2014/main" id="{E2977BA0-09C6-4A76-8A1F-A2AD72776C04}"/>
+                <a16:creationId xmlns:a16="http://schemas.microsoft.com/office/drawing/2014/main" id="{CE9640E0-1DB5-4B9F-AB06-BE773C50D490}"/>
               </a:ext>
             </a:extLst>
           </p:cNvPr>
@@ -11102,7 +10922,7 @@
           <p:cNvPr id="7" name="">
             <a:extLst xmlns:a="http://schemas.openxmlformats.org/drawingml/2006/main">
               <a:ext uri="{FF2B5EF4-FFF2-40B4-BE49-F238E27FC236}">
-                <a16:creationId xmlns:a16="http://schemas.microsoft.com/office/drawing/2014/main" id="{060FF174-A04D-4935-9CB7-6394C9E1C310}"/>
+                <a16:creationId xmlns:a16="http://schemas.microsoft.com/office/drawing/2014/main" id="{F66ECA85-9043-43CA-825F-5D76986C64A8}"/>
               </a:ext>
             </a:extLst>
           </p:cNvPr>
@@ -11147,7 +10967,7 @@
           <p:cNvPr id="8" name="">
             <a:extLst xmlns:a="http://schemas.openxmlformats.org/drawingml/2006/main">
               <a:ext uri="{FF2B5EF4-FFF2-40B4-BE49-F238E27FC236}">
-                <a16:creationId xmlns:a16="http://schemas.microsoft.com/office/drawing/2014/main" id="{E98BCAC4-02F3-48B7-A940-6DFDB617EE3B}"/>
+                <a16:creationId xmlns:a16="http://schemas.microsoft.com/office/drawing/2014/main" id="{95C5D8B7-B2DF-49BC-B5F7-064CE009C18B}"/>
               </a:ext>
             </a:extLst>
           </p:cNvPr>
@@ -11180,7 +11000,7 @@
           <p:cNvPr id="9" name="">
             <a:extLst xmlns:a="http://schemas.openxmlformats.org/drawingml/2006/main">
               <a:ext uri="{FF2B5EF4-FFF2-40B4-BE49-F238E27FC236}">
-                <a16:creationId xmlns:a16="http://schemas.microsoft.com/office/drawing/2014/main" id="{41876A23-9114-45BE-A1EF-A919C634B484}"/>
+                <a16:creationId xmlns:a16="http://schemas.microsoft.com/office/drawing/2014/main" id="{59E02A68-C99A-4954-B31D-2202A478EB0B}"/>
               </a:ext>
             </a:extLst>
           </p:cNvPr>
@@ -11225,7 +11045,7 @@
           <p:cNvPr id="10" name="">
             <a:extLst xmlns:a="http://schemas.openxmlformats.org/drawingml/2006/main">
               <a:ext uri="{FF2B5EF4-FFF2-40B4-BE49-F238E27FC236}">
-                <a16:creationId xmlns:a16="http://schemas.microsoft.com/office/drawing/2014/main" id="{111F5E2F-124E-4A8A-81A3-2F9EFFADD7DF}"/>
+                <a16:creationId xmlns:a16="http://schemas.microsoft.com/office/drawing/2014/main" id="{EE7D8FDD-7473-452A-8743-E54CE17447B5}"/>
               </a:ext>
             </a:extLst>
           </p:cNvPr>
@@ -11270,7 +11090,7 @@
           <p:cNvPr id="11" name="">
             <a:extLst xmlns:a="http://schemas.openxmlformats.org/drawingml/2006/main">
               <a:ext uri="{FF2B5EF4-FFF2-40B4-BE49-F238E27FC236}">
-                <a16:creationId xmlns:a16="http://schemas.microsoft.com/office/drawing/2014/main" id="{69182B0C-9A46-40D1-A642-E5927DD8534A}"/>
+                <a16:creationId xmlns:a16="http://schemas.microsoft.com/office/drawing/2014/main" id="{AE54600B-0DDA-47B2-8AB6-BE631C0AACD2}"/>
               </a:ext>
             </a:extLst>
           </p:cNvPr>
@@ -11303,7 +11123,7 @@
           <p:cNvPr id="12" name="">
             <a:extLst xmlns:a="http://schemas.openxmlformats.org/drawingml/2006/main">
               <a:ext uri="{FF2B5EF4-FFF2-40B4-BE49-F238E27FC236}">
-                <a16:creationId xmlns:a16="http://schemas.microsoft.com/office/drawing/2014/main" id="{3658B5F8-5894-4C19-A0DF-9B650115DB1D}"/>
+                <a16:creationId xmlns:a16="http://schemas.microsoft.com/office/drawing/2014/main" id="{11D1072E-AB14-4268-90B0-4BC4A873AB86}"/>
               </a:ext>
             </a:extLst>
           </p:cNvPr>
@@ -11348,7 +11168,7 @@
           <p:cNvPr id="13" name="">
             <a:extLst xmlns:a="http://schemas.openxmlformats.org/drawingml/2006/main">
               <a:ext uri="{FF2B5EF4-FFF2-40B4-BE49-F238E27FC236}">
-                <a16:creationId xmlns:a16="http://schemas.microsoft.com/office/drawing/2014/main" id="{3D7C4630-3966-4AF5-821E-0AB3994DF487}"/>
+                <a16:creationId xmlns:a16="http://schemas.microsoft.com/office/drawing/2014/main" id="{CCE00218-83C7-4C82-AF17-1A9DA383629E}"/>
               </a:ext>
             </a:extLst>
           </p:cNvPr>
@@ -11393,7 +11213,7 @@
           <p:cNvPr id="14" name="">
             <a:extLst xmlns:a="http://schemas.openxmlformats.org/drawingml/2006/main">
               <a:ext uri="{FF2B5EF4-FFF2-40B4-BE49-F238E27FC236}">
-                <a16:creationId xmlns:a16="http://schemas.microsoft.com/office/drawing/2014/main" id="{375BAFD7-90FA-40C6-89ED-35BAA924E506}"/>
+                <a16:creationId xmlns:a16="http://schemas.microsoft.com/office/drawing/2014/main" id="{76E570BD-7CED-40CD-B819-D07751DCD6BC}"/>
               </a:ext>
             </a:extLst>
           </p:cNvPr>
@@ -11426,7 +11246,7 @@
           <p:cNvPr id="15" name="">
             <a:extLst xmlns:a="http://schemas.openxmlformats.org/drawingml/2006/main">
               <a:ext uri="{FF2B5EF4-FFF2-40B4-BE49-F238E27FC236}">
-                <a16:creationId xmlns:a16="http://schemas.microsoft.com/office/drawing/2014/main" id="{93BD0C5A-2049-4213-A6C5-6F80FEFFA7A3}"/>
+                <a16:creationId xmlns:a16="http://schemas.microsoft.com/office/drawing/2014/main" id="{BD95E634-CBAE-4A85-9AF5-F95AD7C0F1E7}"/>
               </a:ext>
             </a:extLst>
           </p:cNvPr>
@@ -11471,7 +11291,7 @@
           <p:cNvPr id="16" name="">
             <a:extLst xmlns:a="http://schemas.openxmlformats.org/drawingml/2006/main">
               <a:ext uri="{FF2B5EF4-FFF2-40B4-BE49-F238E27FC236}">
-                <a16:creationId xmlns:a16="http://schemas.microsoft.com/office/drawing/2014/main" id="{ED5F9977-A9CD-4AF5-911B-C118AFC43A95}"/>
+                <a16:creationId xmlns:a16="http://schemas.microsoft.com/office/drawing/2014/main" id="{871D69AD-ADE5-455B-99F7-DA5B50B21BC7}"/>
               </a:ext>
             </a:extLst>
           </p:cNvPr>
@@ -11516,7 +11336,7 @@
           <p:cNvPr id="17" name="">
             <a:extLst xmlns:a="http://schemas.openxmlformats.org/drawingml/2006/main">
               <a:ext uri="{FF2B5EF4-FFF2-40B4-BE49-F238E27FC236}">
-                <a16:creationId xmlns:a16="http://schemas.microsoft.com/office/drawing/2014/main" id="{6BACDFFC-17D3-4FF4-B127-67B9E63CA1C8}"/>
+                <a16:creationId xmlns:a16="http://schemas.microsoft.com/office/drawing/2014/main" id="{77DE2461-92E0-4BAF-A069-969C9147CB52}"/>
               </a:ext>
             </a:extLst>
           </p:cNvPr>
@@ -11559,7 +11379,7 @@
     </p:spTree>
     <p:extLst>
       <p:ext uri="{BB962C8B-B14F-4D97-AF65-F5344CB8AC3E}">
-        <p14:creationId xmlns:p14="http://schemas.microsoft.com/office/powerpoint/2010/main" val="984558302"/>
+        <p14:creationId xmlns:p14="http://schemas.microsoft.com/office/powerpoint/2010/main" val="812574032"/>
       </p:ext>
     </p:extLst>
   </p:cSld>
@@ -11590,7 +11410,7 @@
           <p:cNvPr id="8" name="title-9">
             <a:extLst xmlns:a="http://schemas.openxmlformats.org/drawingml/2006/main">
               <a:ext uri="{FF2B5EF4-FFF2-40B4-BE49-F238E27FC236}">
-                <a16:creationId xmlns:a16="http://schemas.microsoft.com/office/drawing/2014/main" id="{4FDA4974-96D6-4C2E-AE9F-BF0B54DCE0F6}"/>
+                <a16:creationId xmlns:a16="http://schemas.microsoft.com/office/drawing/2014/main" id="{A088D4B7-D481-4839-9870-84E98A1ECC0A}"/>
               </a:ext>
             </a:extLst>
           </p:cNvPr>
@@ -11635,7 +11455,7 @@
           <p:cNvPr id="2" name="source-9">
             <a:extLst xmlns:a="http://schemas.openxmlformats.org/drawingml/2006/main">
               <a:ext uri="{FF2B5EF4-FFF2-40B4-BE49-F238E27FC236}">
-                <a16:creationId xmlns:a16="http://schemas.microsoft.com/office/drawing/2014/main" id="{50B71070-5B35-42BC-B64C-547302679546}"/>
+                <a16:creationId xmlns:a16="http://schemas.microsoft.com/office/drawing/2014/main" id="{1F0622E1-A902-4C50-B55E-B186C9EA47C7}"/>
               </a:ext>
             </a:extLst>
           </p:cNvPr>
@@ -11680,7 +11500,7 @@
           <p:cNvPr id="3" name="page-9">
             <a:extLst xmlns:a="http://schemas.openxmlformats.org/drawingml/2006/main">
               <a:ext uri="{FF2B5EF4-FFF2-40B4-BE49-F238E27FC236}">
-                <a16:creationId xmlns:a16="http://schemas.microsoft.com/office/drawing/2014/main" id="{C0F0B9EC-5819-426B-8D2E-D0949E70EACB}"/>
+                <a16:creationId xmlns:a16="http://schemas.microsoft.com/office/drawing/2014/main" id="{70799E5C-6811-4353-8F0B-C298E5FED8A5}"/>
               </a:ext>
             </a:extLst>
           </p:cNvPr>
@@ -11725,7 +11545,7 @@
           <p:cNvPr id="4" name="">
             <a:extLst xmlns:a="http://schemas.openxmlformats.org/drawingml/2006/main">
               <a:ext uri="{FF2B5EF4-FFF2-40B4-BE49-F238E27FC236}">
-                <a16:creationId xmlns:a16="http://schemas.microsoft.com/office/drawing/2014/main" id="{53CE1D01-EA73-4F28-AA45-B6744252133E}"/>
+                <a16:creationId xmlns:a16="http://schemas.microsoft.com/office/drawing/2014/main" id="{D54B4758-5AE0-404B-AF9E-1586E7FE2591}"/>
               </a:ext>
             </a:extLst>
           </p:cNvPr>
@@ -11770,7 +11590,7 @@
           <p:cNvPr id="5" name="">
             <a:extLst xmlns:a="http://schemas.openxmlformats.org/drawingml/2006/main">
               <a:ext uri="{FF2B5EF4-FFF2-40B4-BE49-F238E27FC236}">
-                <a16:creationId xmlns:a16="http://schemas.microsoft.com/office/drawing/2014/main" id="{DB60675D-D228-47B5-9A82-45B377F4A8C5}"/>
+                <a16:creationId xmlns:a16="http://schemas.microsoft.com/office/drawing/2014/main" id="{1111FF68-5055-4773-80DE-78E96DA54D36}"/>
               </a:ext>
             </a:extLst>
           </p:cNvPr>
@@ -11815,7 +11635,7 @@
           <p:cNvPr id="6" name="">
             <a:extLst xmlns:a="http://schemas.openxmlformats.org/drawingml/2006/main">
               <a:ext uri="{FF2B5EF4-FFF2-40B4-BE49-F238E27FC236}">
-                <a16:creationId xmlns:a16="http://schemas.microsoft.com/office/drawing/2014/main" id="{2921AB83-3C2A-472C-B7B6-3B102F5A10B5}"/>
+                <a16:creationId xmlns:a16="http://schemas.microsoft.com/office/drawing/2014/main" id="{CAABE8A8-C36E-4E4F-BEA6-21E4D0D3E057}"/>
               </a:ext>
             </a:extLst>
           </p:cNvPr>
@@ -11855,26 +11675,32 @@
           </a:p>
         </p:txBody>
       </p:sp>
-      <p:graphicFrame>
-        <p:nvGraphicFramePr>
-          <p:cNvPr id="14" name="Chart"/>
-          <p:cNvGraphicFramePr/>
-          <p:nvPr/>
-        </p:nvGraphicFramePr>
-        <p:xfrm>
-          <a:off xmlns:a="http://schemas.openxmlformats.org/drawingml/2006/main" x="590550" y="1466850"/>
-          <a:ext xmlns:a="http://schemas.openxmlformats.org/drawingml/2006/main" cx="6667500" cy="4095750"/>
-        </p:xfrm>
-        <a:graphic xmlns:a="http://schemas.openxmlformats.org/drawingml/2006/main">
-          <a:graphicData uri="http://schemas.openxmlformats.org/drawingml/2006/chart">
-            <c:chart xmlns:r="http://schemas.openxmlformats.org/officeDocument/2006/relationships" xmlns:c="http://schemas.openxmlformats.org/drawingml/2006/chart" r:id="R255e6affb1a045ac"/>
-          </a:graphicData>
-        </a:graphic>
-      </p:graphicFrame>
+      <p:pic>
+        <p:nvPicPr>
+          <p:cNvPr id="14" name=""/>
+          <p:cNvPicPr>
+            <a:picLocks xmlns:a="http://schemas.openxmlformats.org/drawingml/2006/main" noChangeAspect="1"/>
+          </p:cNvPicPr>
+          <p:nvPr/>
+        </p:nvPicPr>
+        <p:blipFill>
+          <a:blip xmlns:r="http://schemas.openxmlformats.org/officeDocument/2006/relationships" xmlns:a="http://schemas.openxmlformats.org/drawingml/2006/main" r:embed="Raf3964f593814129"/>
+          <a:stretch xmlns:a="http://schemas.openxmlformats.org/drawingml/2006/main"/>
+        </p:blipFill>
+        <p:spPr>
+          <a:xfrm xmlns:a="http://schemas.openxmlformats.org/drawingml/2006/main">
+            <a:off x="590550" y="1466850"/>
+            <a:ext cx="6667500" cy="4095750"/>
+          </a:xfrm>
+          <a:prstGeom xmlns:a="http://schemas.openxmlformats.org/drawingml/2006/main" prst="rect">
+            <a:avLst/>
+          </a:prstGeom>
+        </p:spPr>
+      </p:pic>
     </p:spTree>
     <p:extLst>
       <p:ext uri="{BB962C8B-B14F-4D97-AF65-F5344CB8AC3E}">
-        <p14:creationId xmlns:p14="http://schemas.microsoft.com/office/powerpoint/2010/main" val="1526234037"/>
+        <p14:creationId xmlns:p14="http://schemas.microsoft.com/office/powerpoint/2010/main" val="576339544"/>
       </p:ext>
     </p:extLst>
   </p:cSld>

</xml_diff>